<commit_message>
Feat: apply strict Humanizer rules to eliminate AI clichés, robotic punctuation and template formatting
</commit_message>
<xml_diff>
--- a/demo/output/presentation.pptx
+++ b/demo/output/presentation.pptx
@@ -7,11 +7,6 @@
   <p:sldIdLst>
     <p:sldId id="256" r:id="rId7"/>
     <p:sldId id="257" r:id="rId8"/>
-    <p:sldId id="258" r:id="rId9"/>
-    <p:sldId id="259" r:id="rId10"/>
-    <p:sldId id="260" r:id="rId11"/>
-    <p:sldId id="261" r:id="rId12"/>
-    <p:sldId id="262" r:id="rId13"/>
   </p:sldIdLst>
   <p:sldSz cx="12191695" cy="6858000" type="screen4x3"/>
   <p:notesSz cx="6858000" cy="9144000"/>
@@ -3132,7 +3127,7 @@
               </a:defRPr>
             </a:pPr>
             <a:r>
-              <a:t>Libérer Votre Potentiel Créatif</a:t>
+              <a:t>Débloquer le Potentiel Créatif</a:t>
             </a:r>
           </a:p>
           <a:p>
@@ -3147,7 +3142,7 @@
               </a:defRPr>
             </a:pPr>
             <a:r>
-              <a:t>Stratégies pour Innover dans un Monde Hyper-Connecté / Date / Client</a:t>
+              <a:t>Stratégies de créativité, 2023, Zoe Hames</a:t>
             </a:r>
           </a:p>
         </p:txBody>
@@ -3208,7 +3203,7 @@
               </a:defRPr>
             </a:pPr>
             <a:r>
-              <a:t>Contexte &amp; Enjeux</a:t>
+              <a:t>Trouver le Calme dans le Tumulte</a:t>
             </a:r>
           </a:p>
         </p:txBody>
@@ -3246,7 +3241,7 @@
               </a:defRPr>
             </a:pPr>
             <a:r>
-              <a:t>•  L'importance de la créativité dans un environnement professionnel.</a:t>
+              <a:t>•  Créer des moments de silence pour favoriser l'inspiration.</a:t>
             </a:r>
           </a:p>
           <a:p>
@@ -3261,145 +3256,7 @@
               </a:defRPr>
             </a:pPr>
             <a:r>
-              <a:t>•  Les effets du stress sur la pensée créative.</a:t>
-            </a:r>
-          </a:p>
-        </p:txBody>
-      </p:sp>
-      <p:pic>
-        <p:nvPicPr>
-          <p:cNvPr id="4" name="Picture 3" descr="slide_keyframe_01.jpg"/>
-          <p:cNvPicPr>
-            <a:picLocks noChangeAspect="1"/>
-          </p:cNvPicPr>
-          <p:nvPr/>
-        </p:nvPicPr>
-        <p:blipFill>
-          <a:blip r:embed="rId2"/>
-          <a:stretch>
-            <a:fillRect/>
-          </a:stretch>
-        </p:blipFill>
-        <p:spPr>
-          <a:xfrm>
-            <a:off x="6400800" y="1645920"/>
-            <a:ext cx="5029200" cy="2826717"/>
-          </a:xfrm>
-          <a:prstGeom prst="rect">
-            <a:avLst/>
-          </a:prstGeom>
-        </p:spPr>
-      </p:pic>
-    </p:spTree>
-  </p:cSld>
-  <p:clrMapOvr>
-    <a:masterClrMapping/>
-  </p:clrMapOvr>
-</p:sld>
-</file>
-
-<file path=ppt/slides/slide3.xml><?xml version="1.0" encoding="utf-8"?>
-<p:sld xmlns:a="http://schemas.openxmlformats.org/drawingml/2006/main" xmlns:p="http://schemas.openxmlformats.org/presentationml/2006/main" xmlns:r="http://schemas.openxmlformats.org/officeDocument/2006/relationships">
-  <p:cSld>
-    <p:bg>
-      <p:bgPr>
-        <a:solidFill>
-          <a:srgbClr val="0F172A"/>
-        </a:solidFill>
-        <a:effectLst/>
-      </p:bgPr>
-    </p:bg>
-    <p:spTree>
-      <p:nvGrpSpPr>
-        <p:cNvPr id="1" name=""/>
-        <p:cNvGrpSpPr/>
-        <p:nvPr/>
-      </p:nvGrpSpPr>
-      <p:grpSpPr/>
-      <p:sp>
-        <p:nvSpPr>
-          <p:cNvPr id="2" name="TextBox 1"/>
-          <p:cNvSpPr txBox="1"/>
-          <p:nvPr/>
-        </p:nvSpPr>
-        <p:spPr>
-          <a:xfrm>
-            <a:off x="731520" y="457200"/>
-            <a:ext cx="10698480" cy="914400"/>
-          </a:xfrm>
-          <a:prstGeom prst="rect">
-            <a:avLst/>
-          </a:prstGeom>
-          <a:noFill/>
-        </p:spPr>
-        <p:txBody>
-          <a:bodyPr wrap="none">
-            <a:spAutoFit/>
-          </a:bodyPr>
-          <a:lstStyle/>
-          <a:p>
-            <a:pPr>
-              <a:defRPr sz="2800" b="1">
-                <a:solidFill>
-                  <a:srgbClr val="38BDF8"/>
-                </a:solidFill>
-              </a:defRPr>
-            </a:pPr>
-            <a:r>
-              <a:t>Stratégie 1 : Trouver le Silence</a:t>
-            </a:r>
-          </a:p>
-        </p:txBody>
-      </p:sp>
-      <p:sp>
-        <p:nvSpPr>
-          <p:cNvPr id="3" name="TextBox 2"/>
-          <p:cNvSpPr txBox="1"/>
-          <p:nvPr/>
-        </p:nvSpPr>
-        <p:spPr>
-          <a:xfrm>
-            <a:off x="731520" y="1645920"/>
-            <a:ext cx="5303520" cy="4389120"/>
-          </a:xfrm>
-          <a:prstGeom prst="rect">
-            <a:avLst/>
-          </a:prstGeom>
-          <a:noFill/>
-        </p:spPr>
-        <p:txBody>
-          <a:bodyPr wrap="square">
-            <a:spAutoFit/>
-          </a:bodyPr>
-          <a:lstStyle/>
-          <a:p>
-            <a:pPr>
-              <a:spcAft>
-                <a:spcPts val="1600"/>
-              </a:spcAft>
-              <a:defRPr sz="1700">
-                <a:solidFill>
-                  <a:srgbClr val="F8FAFC"/>
-                </a:solidFill>
-              </a:defRPr>
-            </a:pPr>
-            <a:r>
-              <a:t>•  Accordez-vous des moments de calme.</a:t>
-            </a:r>
-          </a:p>
-          <a:p>
-            <a:pPr>
-              <a:spcAft>
-                <a:spcPts val="1600"/>
-              </a:spcAft>
-              <a:defRPr sz="1700">
-                <a:solidFill>
-                  <a:srgbClr val="F8FAFC"/>
-                </a:solidFill>
-              </a:defRPr>
-            </a:pPr>
-            <a:r>
-              <a:t>•  Évitez les distractions numériques.</a:t>
+              <a:t>•  Se déconnecter des distractions numériques.</a:t>
             </a:r>
           </a:p>
         </p:txBody>
@@ -3407,558 +3264,6 @@
       <p:pic>
         <p:nvPicPr>
           <p:cNvPr id="4" name="Picture 3" descr="slide_keyframe_02.jpg"/>
-          <p:cNvPicPr>
-            <a:picLocks noChangeAspect="1"/>
-          </p:cNvPicPr>
-          <p:nvPr/>
-        </p:nvPicPr>
-        <p:blipFill>
-          <a:blip r:embed="rId2"/>
-          <a:stretch>
-            <a:fillRect/>
-          </a:stretch>
-        </p:blipFill>
-        <p:spPr>
-          <a:xfrm>
-            <a:off x="6400800" y="1645920"/>
-            <a:ext cx="5029200" cy="2826717"/>
-          </a:xfrm>
-          <a:prstGeom prst="rect">
-            <a:avLst/>
-          </a:prstGeom>
-        </p:spPr>
-      </p:pic>
-    </p:spTree>
-  </p:cSld>
-  <p:clrMapOvr>
-    <a:masterClrMapping/>
-  </p:clrMapOvr>
-</p:sld>
-</file>
-
-<file path=ppt/slides/slide4.xml><?xml version="1.0" encoding="utf-8"?>
-<p:sld xmlns:a="http://schemas.openxmlformats.org/drawingml/2006/main" xmlns:p="http://schemas.openxmlformats.org/presentationml/2006/main" xmlns:r="http://schemas.openxmlformats.org/officeDocument/2006/relationships">
-  <p:cSld>
-    <p:bg>
-      <p:bgPr>
-        <a:solidFill>
-          <a:srgbClr val="0F172A"/>
-        </a:solidFill>
-        <a:effectLst/>
-      </p:bgPr>
-    </p:bg>
-    <p:spTree>
-      <p:nvGrpSpPr>
-        <p:cNvPr id="1" name=""/>
-        <p:cNvGrpSpPr/>
-        <p:nvPr/>
-      </p:nvGrpSpPr>
-      <p:grpSpPr/>
-      <p:sp>
-        <p:nvSpPr>
-          <p:cNvPr id="2" name="TextBox 1"/>
-          <p:cNvSpPr txBox="1"/>
-          <p:nvPr/>
-        </p:nvSpPr>
-        <p:spPr>
-          <a:xfrm>
-            <a:off x="731520" y="457200"/>
-            <a:ext cx="10698480" cy="914400"/>
-          </a:xfrm>
-          <a:prstGeom prst="rect">
-            <a:avLst/>
-          </a:prstGeom>
-          <a:noFill/>
-        </p:spPr>
-        <p:txBody>
-          <a:bodyPr wrap="none">
-            <a:spAutoFit/>
-          </a:bodyPr>
-          <a:lstStyle/>
-          <a:p>
-            <a:pPr>
-              <a:defRPr sz="2800" b="1">
-                <a:solidFill>
-                  <a:srgbClr val="38BDF8"/>
-                </a:solidFill>
-              </a:defRPr>
-            </a:pPr>
-            <a:r>
-              <a:t>Stratégie 2 : Exploiter le Pouvoir des Rêves</a:t>
-            </a:r>
-          </a:p>
-        </p:txBody>
-      </p:sp>
-      <p:sp>
-        <p:nvSpPr>
-          <p:cNvPr id="3" name="TextBox 2"/>
-          <p:cNvSpPr txBox="1"/>
-          <p:nvPr/>
-        </p:nvSpPr>
-        <p:spPr>
-          <a:xfrm>
-            <a:off x="731520" y="1645920"/>
-            <a:ext cx="5303520" cy="4389120"/>
-          </a:xfrm>
-          <a:prstGeom prst="rect">
-            <a:avLst/>
-          </a:prstGeom>
-          <a:noFill/>
-        </p:spPr>
-        <p:txBody>
-          <a:bodyPr wrap="square">
-            <a:spAutoFit/>
-          </a:bodyPr>
-          <a:lstStyle/>
-          <a:p>
-            <a:pPr>
-              <a:spcAft>
-                <a:spcPts val="1600"/>
-              </a:spcAft>
-              <a:defRPr sz="1700">
-                <a:solidFill>
-                  <a:srgbClr val="F8FAFC"/>
-                </a:solidFill>
-              </a:defRPr>
-            </a:pPr>
-            <a:r>
-              <a:t>•  Laissez libre cours à votre imagination.</a:t>
-            </a:r>
-          </a:p>
-          <a:p>
-            <a:pPr>
-              <a:spcAft>
-                <a:spcPts val="1600"/>
-              </a:spcAft>
-              <a:defRPr sz="1700">
-                <a:solidFill>
-                  <a:srgbClr val="F8FAFC"/>
-                </a:solidFill>
-              </a:defRPr>
-            </a:pPr>
-            <a:r>
-              <a:t>•  Pratiquez des activités créatives sans contraintes.</a:t>
-            </a:r>
-          </a:p>
-        </p:txBody>
-      </p:sp>
-      <p:pic>
-        <p:nvPicPr>
-          <p:cNvPr id="4" name="Picture 3" descr="slide_keyframe_03.jpg"/>
-          <p:cNvPicPr>
-            <a:picLocks noChangeAspect="1"/>
-          </p:cNvPicPr>
-          <p:nvPr/>
-        </p:nvPicPr>
-        <p:blipFill>
-          <a:blip r:embed="rId2"/>
-          <a:stretch>
-            <a:fillRect/>
-          </a:stretch>
-        </p:blipFill>
-        <p:spPr>
-          <a:xfrm>
-            <a:off x="6400800" y="1645920"/>
-            <a:ext cx="5029200" cy="2826717"/>
-          </a:xfrm>
-          <a:prstGeom prst="rect">
-            <a:avLst/>
-          </a:prstGeom>
-        </p:spPr>
-      </p:pic>
-    </p:spTree>
-  </p:cSld>
-  <p:clrMapOvr>
-    <a:masterClrMapping/>
-  </p:clrMapOvr>
-</p:sld>
-</file>
-
-<file path=ppt/slides/slide5.xml><?xml version="1.0" encoding="utf-8"?>
-<p:sld xmlns:a="http://schemas.openxmlformats.org/drawingml/2006/main" xmlns:p="http://schemas.openxmlformats.org/presentationml/2006/main" xmlns:r="http://schemas.openxmlformats.org/officeDocument/2006/relationships">
-  <p:cSld>
-    <p:bg>
-      <p:bgPr>
-        <a:solidFill>
-          <a:srgbClr val="0F172A"/>
-        </a:solidFill>
-        <a:effectLst/>
-      </p:bgPr>
-    </p:bg>
-    <p:spTree>
-      <p:nvGrpSpPr>
-        <p:cNvPr id="1" name=""/>
-        <p:cNvGrpSpPr/>
-        <p:nvPr/>
-      </p:nvGrpSpPr>
-      <p:grpSpPr/>
-      <p:sp>
-        <p:nvSpPr>
-          <p:cNvPr id="2" name="TextBox 1"/>
-          <p:cNvSpPr txBox="1"/>
-          <p:nvPr/>
-        </p:nvSpPr>
-        <p:spPr>
-          <a:xfrm>
-            <a:off x="731520" y="457200"/>
-            <a:ext cx="10698480" cy="914400"/>
-          </a:xfrm>
-          <a:prstGeom prst="rect">
-            <a:avLst/>
-          </a:prstGeom>
-          <a:noFill/>
-        </p:spPr>
-        <p:txBody>
-          <a:bodyPr wrap="none">
-            <a:spAutoFit/>
-          </a:bodyPr>
-          <a:lstStyle/>
-          <a:p>
-            <a:pPr>
-              <a:defRPr sz="2800" b="1">
-                <a:solidFill>
-                  <a:srgbClr val="38BDF8"/>
-                </a:solidFill>
-              </a:defRPr>
-            </a:pPr>
-            <a:r>
-              <a:t>Stratégie 3 : Lâcher Prise</a:t>
-            </a:r>
-          </a:p>
-        </p:txBody>
-      </p:sp>
-      <p:sp>
-        <p:nvSpPr>
-          <p:cNvPr id="3" name="TextBox 2"/>
-          <p:cNvSpPr txBox="1"/>
-          <p:nvPr/>
-        </p:nvSpPr>
-        <p:spPr>
-          <a:xfrm>
-            <a:off x="731520" y="1645920"/>
-            <a:ext cx="5303520" cy="4389120"/>
-          </a:xfrm>
-          <a:prstGeom prst="rect">
-            <a:avLst/>
-          </a:prstGeom>
-          <a:noFill/>
-        </p:spPr>
-        <p:txBody>
-          <a:bodyPr wrap="square">
-            <a:spAutoFit/>
-          </a:bodyPr>
-          <a:lstStyle/>
-          <a:p>
-            <a:pPr>
-              <a:spcAft>
-                <a:spcPts val="1600"/>
-              </a:spcAft>
-              <a:defRPr sz="1700">
-                <a:solidFill>
-                  <a:srgbClr val="F8FAFC"/>
-                </a:solidFill>
-              </a:defRPr>
-            </a:pPr>
-            <a:r>
-              <a:t>•  Acceptez l'imperfection.</a:t>
-            </a:r>
-          </a:p>
-          <a:p>
-            <a:pPr>
-              <a:spcAft>
-                <a:spcPts val="1600"/>
-              </a:spcAft>
-              <a:defRPr sz="1700">
-                <a:solidFill>
-                  <a:srgbClr val="F8FAFC"/>
-                </a:solidFill>
-              </a:defRPr>
-            </a:pPr>
-            <a:r>
-              <a:t>•  Priorisez votre bien-être.</a:t>
-            </a:r>
-          </a:p>
-        </p:txBody>
-      </p:sp>
-      <p:pic>
-        <p:nvPicPr>
-          <p:cNvPr id="4" name="Picture 3" descr="slide_keyframe_04.jpg"/>
-          <p:cNvPicPr>
-            <a:picLocks noChangeAspect="1"/>
-          </p:cNvPicPr>
-          <p:nvPr/>
-        </p:nvPicPr>
-        <p:blipFill>
-          <a:blip r:embed="rId2"/>
-          <a:stretch>
-            <a:fillRect/>
-          </a:stretch>
-        </p:blipFill>
-        <p:spPr>
-          <a:xfrm>
-            <a:off x="6400800" y="1645920"/>
-            <a:ext cx="5029200" cy="2826717"/>
-          </a:xfrm>
-          <a:prstGeom prst="rect">
-            <a:avLst/>
-          </a:prstGeom>
-        </p:spPr>
-      </p:pic>
-    </p:spTree>
-  </p:cSld>
-  <p:clrMapOvr>
-    <a:masterClrMapping/>
-  </p:clrMapOvr>
-</p:sld>
-</file>
-
-<file path=ppt/slides/slide6.xml><?xml version="1.0" encoding="utf-8"?>
-<p:sld xmlns:a="http://schemas.openxmlformats.org/drawingml/2006/main" xmlns:p="http://schemas.openxmlformats.org/presentationml/2006/main" xmlns:r="http://schemas.openxmlformats.org/officeDocument/2006/relationships">
-  <p:cSld>
-    <p:bg>
-      <p:bgPr>
-        <a:solidFill>
-          <a:srgbClr val="0F172A"/>
-        </a:solidFill>
-        <a:effectLst/>
-      </p:bgPr>
-    </p:bg>
-    <p:spTree>
-      <p:nvGrpSpPr>
-        <p:cNvPr id="1" name=""/>
-        <p:cNvGrpSpPr/>
-        <p:nvPr/>
-      </p:nvGrpSpPr>
-      <p:grpSpPr/>
-      <p:sp>
-        <p:nvSpPr>
-          <p:cNvPr id="2" name="TextBox 1"/>
-          <p:cNvSpPr txBox="1"/>
-          <p:nvPr/>
-        </p:nvSpPr>
-        <p:spPr>
-          <a:xfrm>
-            <a:off x="731520" y="457200"/>
-            <a:ext cx="10698480" cy="914400"/>
-          </a:xfrm>
-          <a:prstGeom prst="rect">
-            <a:avLst/>
-          </a:prstGeom>
-          <a:noFill/>
-        </p:spPr>
-        <p:txBody>
-          <a:bodyPr wrap="none">
-            <a:spAutoFit/>
-          </a:bodyPr>
-          <a:lstStyle/>
-          <a:p>
-            <a:pPr>
-              <a:defRPr sz="2800" b="1">
-                <a:solidFill>
-                  <a:srgbClr val="38BDF8"/>
-                </a:solidFill>
-              </a:defRPr>
-            </a:pPr>
-            <a:r>
-              <a:t>Plan d'Action</a:t>
-            </a:r>
-          </a:p>
-        </p:txBody>
-      </p:sp>
-      <p:sp>
-        <p:nvSpPr>
-          <p:cNvPr id="3" name="TextBox 2"/>
-          <p:cNvSpPr txBox="1"/>
-          <p:nvPr/>
-        </p:nvSpPr>
-        <p:spPr>
-          <a:xfrm>
-            <a:off x="731520" y="1645920"/>
-            <a:ext cx="5303520" cy="4389120"/>
-          </a:xfrm>
-          <a:prstGeom prst="rect">
-            <a:avLst/>
-          </a:prstGeom>
-          <a:noFill/>
-        </p:spPr>
-        <p:txBody>
-          <a:bodyPr wrap="square">
-            <a:spAutoFit/>
-          </a:bodyPr>
-          <a:lstStyle/>
-          <a:p>
-            <a:pPr>
-              <a:spcAft>
-                <a:spcPts val="1600"/>
-              </a:spcAft>
-              <a:defRPr sz="1700">
-                <a:solidFill>
-                  <a:srgbClr val="F8FAFC"/>
-                </a:solidFill>
-              </a:defRPr>
-            </a:pPr>
-            <a:r>
-              <a:t>•  Planifiez des pauses régulières.</a:t>
-            </a:r>
-          </a:p>
-          <a:p>
-            <a:pPr>
-              <a:spcAft>
-                <a:spcPts val="1600"/>
-              </a:spcAft>
-              <a:defRPr sz="1700">
-                <a:solidFill>
-                  <a:srgbClr val="F8FAFC"/>
-                </a:solidFill>
-              </a:defRPr>
-            </a:pPr>
-            <a:r>
-              <a:t>•  Engagez-vous dans des activités créatives.</a:t>
-            </a:r>
-          </a:p>
-        </p:txBody>
-      </p:sp>
-      <p:pic>
-        <p:nvPicPr>
-          <p:cNvPr id="4" name="Picture 3" descr="slide_keyframe_05.jpg"/>
-          <p:cNvPicPr>
-            <a:picLocks noChangeAspect="1"/>
-          </p:cNvPicPr>
-          <p:nvPr/>
-        </p:nvPicPr>
-        <p:blipFill>
-          <a:blip r:embed="rId2"/>
-          <a:stretch>
-            <a:fillRect/>
-          </a:stretch>
-        </p:blipFill>
-        <p:spPr>
-          <a:xfrm>
-            <a:off x="6400800" y="1645920"/>
-            <a:ext cx="5029200" cy="2826717"/>
-          </a:xfrm>
-          <a:prstGeom prst="rect">
-            <a:avLst/>
-          </a:prstGeom>
-        </p:spPr>
-      </p:pic>
-    </p:spTree>
-  </p:cSld>
-  <p:clrMapOvr>
-    <a:masterClrMapping/>
-  </p:clrMapOvr>
-</p:sld>
-</file>
-
-<file path=ppt/slides/slide7.xml><?xml version="1.0" encoding="utf-8"?>
-<p:sld xmlns:a="http://schemas.openxmlformats.org/drawingml/2006/main" xmlns:p="http://schemas.openxmlformats.org/presentationml/2006/main" xmlns:r="http://schemas.openxmlformats.org/officeDocument/2006/relationships">
-  <p:cSld>
-    <p:bg>
-      <p:bgPr>
-        <a:solidFill>
-          <a:srgbClr val="0F172A"/>
-        </a:solidFill>
-        <a:effectLst/>
-      </p:bgPr>
-    </p:bg>
-    <p:spTree>
-      <p:nvGrpSpPr>
-        <p:cNvPr id="1" name=""/>
-        <p:cNvGrpSpPr/>
-        <p:nvPr/>
-      </p:nvGrpSpPr>
-      <p:grpSpPr/>
-      <p:sp>
-        <p:nvSpPr>
-          <p:cNvPr id="2" name="TextBox 1"/>
-          <p:cNvSpPr txBox="1"/>
-          <p:nvPr/>
-        </p:nvSpPr>
-        <p:spPr>
-          <a:xfrm>
-            <a:off x="731520" y="457200"/>
-            <a:ext cx="10698480" cy="914400"/>
-          </a:xfrm>
-          <a:prstGeom prst="rect">
-            <a:avLst/>
-          </a:prstGeom>
-          <a:noFill/>
-        </p:spPr>
-        <p:txBody>
-          <a:bodyPr wrap="none">
-            <a:spAutoFit/>
-          </a:bodyPr>
-          <a:lstStyle/>
-          <a:p>
-            <a:pPr>
-              <a:defRPr sz="2800" b="1">
-                <a:solidFill>
-                  <a:srgbClr val="38BDF8"/>
-                </a:solidFill>
-              </a:defRPr>
-            </a:pPr>
-            <a:r>
-              <a:t>Conclusion</a:t>
-            </a:r>
-          </a:p>
-        </p:txBody>
-      </p:sp>
-      <p:sp>
-        <p:nvSpPr>
-          <p:cNvPr id="3" name="TextBox 2"/>
-          <p:cNvSpPr txBox="1"/>
-          <p:nvPr/>
-        </p:nvSpPr>
-        <p:spPr>
-          <a:xfrm>
-            <a:off x="731520" y="1645920"/>
-            <a:ext cx="5303520" cy="4389120"/>
-          </a:xfrm>
-          <a:prstGeom prst="rect">
-            <a:avLst/>
-          </a:prstGeom>
-          <a:noFill/>
-        </p:spPr>
-        <p:txBody>
-          <a:bodyPr wrap="square">
-            <a:spAutoFit/>
-          </a:bodyPr>
-          <a:lstStyle/>
-          <a:p>
-            <a:pPr>
-              <a:spcAft>
-                <a:spcPts val="1600"/>
-              </a:spcAft>
-              <a:defRPr sz="1700">
-                <a:solidFill>
-                  <a:srgbClr val="F8FAFC"/>
-                </a:solidFill>
-              </a:defRPr>
-            </a:pPr>
-            <a:r>
-              <a:t>•  La créativité est un voyage, pas une destination.</a:t>
-            </a:r>
-          </a:p>
-          <a:p>
-            <a:pPr>
-              <a:spcAft>
-                <a:spcPts val="1600"/>
-              </a:spcAft>
-              <a:defRPr sz="1700">
-                <a:solidFill>
-                  <a:srgbClr val="F8FAFC"/>
-                </a:solidFill>
-              </a:defRPr>
-            </a:pPr>
-            <a:r>
-              <a:t>•  Expérimentez et laissez votre imagination s'exprimer.</a:t>
-            </a:r>
-          </a:p>
-        </p:txBody>
-      </p:sp>
-      <p:pic>
-        <p:nvPicPr>
-          <p:cNvPr id="4" name="Picture 3" descr="slide_keyframe_06.jpg"/>
           <p:cNvPicPr>
             <a:picLocks noChangeAspect="1"/>
           </p:cNvPicPr>

</xml_diff>

<commit_message>
Fix: finalize Windows batch installers syntax with CRLF, clean explorer launch and exit codes
</commit_message>
<xml_diff>
--- a/demo/output/presentation.pptx
+++ b/demo/output/presentation.pptx
@@ -7,6 +7,8 @@
   <p:sldIdLst>
     <p:sldId id="256" r:id="rId7"/>
     <p:sldId id="257" r:id="rId8"/>
+    <p:sldId id="258" r:id="rId9"/>
+    <p:sldId id="259" r:id="rId10"/>
   </p:sldIdLst>
   <p:sldSz cx="12191695" cy="6858000" type="screen4x3"/>
   <p:notesSz cx="6858000" cy="9144000"/>
@@ -3241,7 +3243,7 @@
               </a:defRPr>
             </a:pPr>
             <a:r>
-              <a:t>•  Créer des moments de silence pour favoriser l'inspiration.</a:t>
+              <a:t>•  L'importance de moments de silence pour l'inspiration</a:t>
             </a:r>
           </a:p>
           <a:p>
@@ -3256,7 +3258,7 @@
               </a:defRPr>
             </a:pPr>
             <a:r>
-              <a:t>•  Se déconnecter des distractions numériques.</a:t>
+              <a:t>•  Créer un espace propice à la créativité</a:t>
             </a:r>
           </a:p>
         </p:txBody>
@@ -3264,6 +3266,282 @@
       <p:pic>
         <p:nvPicPr>
           <p:cNvPr id="4" name="Picture 3" descr="slide_keyframe_02.jpg"/>
+          <p:cNvPicPr>
+            <a:picLocks noChangeAspect="1"/>
+          </p:cNvPicPr>
+          <p:nvPr/>
+        </p:nvPicPr>
+        <p:blipFill>
+          <a:blip r:embed="rId2"/>
+          <a:stretch>
+            <a:fillRect/>
+          </a:stretch>
+        </p:blipFill>
+        <p:spPr>
+          <a:xfrm>
+            <a:off x="6400800" y="1645920"/>
+            <a:ext cx="5029200" cy="2826717"/>
+          </a:xfrm>
+          <a:prstGeom prst="rect">
+            <a:avLst/>
+          </a:prstGeom>
+        </p:spPr>
+      </p:pic>
+    </p:spTree>
+  </p:cSld>
+  <p:clrMapOvr>
+    <a:masterClrMapping/>
+  </p:clrMapOvr>
+</p:sld>
+</file>
+
+<file path=ppt/slides/slide3.xml><?xml version="1.0" encoding="utf-8"?>
+<p:sld xmlns:a="http://schemas.openxmlformats.org/drawingml/2006/main" xmlns:p="http://schemas.openxmlformats.org/presentationml/2006/main" xmlns:r="http://schemas.openxmlformats.org/officeDocument/2006/relationships">
+  <p:cSld>
+    <p:bg>
+      <p:bgPr>
+        <a:solidFill>
+          <a:srgbClr val="0F172A"/>
+        </a:solidFill>
+        <a:effectLst/>
+      </p:bgPr>
+    </p:bg>
+    <p:spTree>
+      <p:nvGrpSpPr>
+        <p:cNvPr id="1" name=""/>
+        <p:cNvGrpSpPr/>
+        <p:nvPr/>
+      </p:nvGrpSpPr>
+      <p:grpSpPr/>
+      <p:sp>
+        <p:nvSpPr>
+          <p:cNvPr id="2" name="TextBox 1"/>
+          <p:cNvSpPr txBox="1"/>
+          <p:nvPr/>
+        </p:nvSpPr>
+        <p:spPr>
+          <a:xfrm>
+            <a:off x="731520" y="457200"/>
+            <a:ext cx="10698480" cy="914400"/>
+          </a:xfrm>
+          <a:prstGeom prst="rect">
+            <a:avLst/>
+          </a:prstGeom>
+          <a:noFill/>
+        </p:spPr>
+        <p:txBody>
+          <a:bodyPr wrap="none">
+            <a:spAutoFit/>
+          </a:bodyPr>
+          <a:lstStyle/>
+          <a:p>
+            <a:pPr>
+              <a:defRPr sz="2800" b="1">
+                <a:solidFill>
+                  <a:srgbClr val="38BDF8"/>
+                </a:solidFill>
+              </a:defRPr>
+            </a:pPr>
+            <a:r>
+              <a:t>Exploiter la Puissance des Rêves</a:t>
+            </a:r>
+          </a:p>
+        </p:txBody>
+      </p:sp>
+      <p:sp>
+        <p:nvSpPr>
+          <p:cNvPr id="3" name="TextBox 2"/>
+          <p:cNvSpPr txBox="1"/>
+          <p:nvPr/>
+        </p:nvSpPr>
+        <p:spPr>
+          <a:xfrm>
+            <a:off x="731520" y="1645920"/>
+            <a:ext cx="5303520" cy="4389120"/>
+          </a:xfrm>
+          <a:prstGeom prst="rect">
+            <a:avLst/>
+          </a:prstGeom>
+          <a:noFill/>
+        </p:spPr>
+        <p:txBody>
+          <a:bodyPr wrap="square">
+            <a:spAutoFit/>
+          </a:bodyPr>
+          <a:lstStyle/>
+          <a:p>
+            <a:pPr>
+              <a:spcAft>
+                <a:spcPts val="1600"/>
+              </a:spcAft>
+              <a:defRPr sz="1700">
+                <a:solidFill>
+                  <a:srgbClr val="F8FAFC"/>
+                </a:solidFill>
+              </a:defRPr>
+            </a:pPr>
+            <a:r>
+              <a:t>•  Reconnecter avec l'imagination enfantine</a:t>
+            </a:r>
+          </a:p>
+          <a:p>
+            <a:pPr>
+              <a:spcAft>
+                <a:spcPts val="1600"/>
+              </a:spcAft>
+              <a:defRPr sz="1700">
+                <a:solidFill>
+                  <a:srgbClr val="F8FAFC"/>
+                </a:solidFill>
+              </a:defRPr>
+            </a:pPr>
+            <a:r>
+              <a:t>•  Laisser libre cours aux idées sans jugement</a:t>
+            </a:r>
+          </a:p>
+        </p:txBody>
+      </p:sp>
+      <p:pic>
+        <p:nvPicPr>
+          <p:cNvPr id="4" name="Picture 3" descr="slide_keyframe_03.jpg"/>
+          <p:cNvPicPr>
+            <a:picLocks noChangeAspect="1"/>
+          </p:cNvPicPr>
+          <p:nvPr/>
+        </p:nvPicPr>
+        <p:blipFill>
+          <a:blip r:embed="rId2"/>
+          <a:stretch>
+            <a:fillRect/>
+          </a:stretch>
+        </p:blipFill>
+        <p:spPr>
+          <a:xfrm>
+            <a:off x="6400800" y="1645920"/>
+            <a:ext cx="5029200" cy="2826717"/>
+          </a:xfrm>
+          <a:prstGeom prst="rect">
+            <a:avLst/>
+          </a:prstGeom>
+        </p:spPr>
+      </p:pic>
+    </p:spTree>
+  </p:cSld>
+  <p:clrMapOvr>
+    <a:masterClrMapping/>
+  </p:clrMapOvr>
+</p:sld>
+</file>
+
+<file path=ppt/slides/slide4.xml><?xml version="1.0" encoding="utf-8"?>
+<p:sld xmlns:a="http://schemas.openxmlformats.org/drawingml/2006/main" xmlns:p="http://schemas.openxmlformats.org/presentationml/2006/main" xmlns:r="http://schemas.openxmlformats.org/officeDocument/2006/relationships">
+  <p:cSld>
+    <p:bg>
+      <p:bgPr>
+        <a:solidFill>
+          <a:srgbClr val="0F172A"/>
+        </a:solidFill>
+        <a:effectLst/>
+      </p:bgPr>
+    </p:bg>
+    <p:spTree>
+      <p:nvGrpSpPr>
+        <p:cNvPr id="1" name=""/>
+        <p:cNvGrpSpPr/>
+        <p:nvPr/>
+      </p:nvGrpSpPr>
+      <p:grpSpPr/>
+      <p:sp>
+        <p:nvSpPr>
+          <p:cNvPr id="2" name="TextBox 1"/>
+          <p:cNvSpPr txBox="1"/>
+          <p:nvPr/>
+        </p:nvSpPr>
+        <p:spPr>
+          <a:xfrm>
+            <a:off x="731520" y="457200"/>
+            <a:ext cx="10698480" cy="914400"/>
+          </a:xfrm>
+          <a:prstGeom prst="rect">
+            <a:avLst/>
+          </a:prstGeom>
+          <a:noFill/>
+        </p:spPr>
+        <p:txBody>
+          <a:bodyPr wrap="none">
+            <a:spAutoFit/>
+          </a:bodyPr>
+          <a:lstStyle/>
+          <a:p>
+            <a:pPr>
+              <a:defRPr sz="2800" b="1">
+                <a:solidFill>
+                  <a:srgbClr val="38BDF8"/>
+                </a:solidFill>
+              </a:defRPr>
+            </a:pPr>
+            <a:r>
+              <a:t>L'Art de Lâcher Prise</a:t>
+            </a:r>
+          </a:p>
+        </p:txBody>
+      </p:sp>
+      <p:sp>
+        <p:nvSpPr>
+          <p:cNvPr id="3" name="TextBox 2"/>
+          <p:cNvSpPr txBox="1"/>
+          <p:nvPr/>
+        </p:nvSpPr>
+        <p:spPr>
+          <a:xfrm>
+            <a:off x="731520" y="1645920"/>
+            <a:ext cx="5303520" cy="4389120"/>
+          </a:xfrm>
+          <a:prstGeom prst="rect">
+            <a:avLst/>
+          </a:prstGeom>
+          <a:noFill/>
+        </p:spPr>
+        <p:txBody>
+          <a:bodyPr wrap="square">
+            <a:spAutoFit/>
+          </a:bodyPr>
+          <a:lstStyle/>
+          <a:p>
+            <a:pPr>
+              <a:spcAft>
+                <a:spcPts val="1600"/>
+              </a:spcAft>
+              <a:defRPr sz="1700">
+                <a:solidFill>
+                  <a:srgbClr val="F8FAFC"/>
+                </a:solidFill>
+              </a:defRPr>
+            </a:pPr>
+            <a:r>
+              <a:t>•  Prioriser le bien-être pour nourrir la créativité</a:t>
+            </a:r>
+          </a:p>
+          <a:p>
+            <a:pPr>
+              <a:spcAft>
+                <a:spcPts val="1600"/>
+              </a:spcAft>
+              <a:defRPr sz="1700">
+                <a:solidFill>
+                  <a:srgbClr val="F8FAFC"/>
+                </a:solidFill>
+              </a:defRPr>
+            </a:pPr>
+            <a:r>
+              <a:t>•  Accepter de ne pas tout contrôler</a:t>
+            </a:r>
+          </a:p>
+        </p:txBody>
+      </p:sp>
+      <p:pic>
+        <p:nvPicPr>
+          <p:cNvPr id="4" name="Picture 3" descr="slide_keyframe_04.jpg"/>
           <p:cNvPicPr>
             <a:picLocks noChangeAspect="1"/>
           </p:cNvPicPr>

</xml_diff>

<commit_message>
feat: actualisation des livrables après exécution du test en conditions réelles
</commit_message>
<xml_diff>
--- a/demo/output/presentation.pptx
+++ b/demo/output/presentation.pptx
@@ -7,8 +7,6 @@
   <p:sldIdLst>
     <p:sldId id="256" r:id="rId7"/>
     <p:sldId id="257" r:id="rId8"/>
-    <p:sldId id="258" r:id="rId9"/>
-    <p:sldId id="259" r:id="rId10"/>
   </p:sldIdLst>
   <p:sldSz cx="12191695" cy="6858000" type="screen4x3"/>
   <p:notesSz cx="6858000" cy="9144000"/>
@@ -3144,7 +3142,7 @@
               </a:defRPr>
             </a:pPr>
             <a:r>
-              <a:t>Stratégies de créativité, 2023, Zoe Hames</a:t>
+              <a:t>Stratégies de créativité, 2023, Zoe Hames et Chris Lewis</a:t>
             </a:r>
           </a:p>
         </p:txBody>
@@ -3205,7 +3203,7 @@
               </a:defRPr>
             </a:pPr>
             <a:r>
-              <a:t>Trouver le Calme dans le Tumulte</a:t>
+              <a:t>Stratégies pour Libérer la Créativité</a:t>
             </a:r>
           </a:p>
         </p:txBody>
@@ -3243,7 +3241,7 @@
               </a:defRPr>
             </a:pPr>
             <a:r>
-              <a:t>•  L'importance de moments de silence pour l'inspiration</a:t>
+              <a:t>•  Trouver le calme pour favoriser l'inspiration.</a:t>
             </a:r>
           </a:p>
           <a:p>
@@ -3258,117 +3256,9 @@
               </a:defRPr>
             </a:pPr>
             <a:r>
-              <a:t>•  Créer un espace propice à la créativité</a:t>
-            </a:r>
-          </a:p>
-        </p:txBody>
-      </p:sp>
-      <p:pic>
-        <p:nvPicPr>
-          <p:cNvPr id="4" name="Picture 3" descr="slide_keyframe_02.jpg"/>
-          <p:cNvPicPr>
-            <a:picLocks noChangeAspect="1"/>
-          </p:cNvPicPr>
-          <p:nvPr/>
-        </p:nvPicPr>
-        <p:blipFill>
-          <a:blip r:embed="rId2"/>
-          <a:stretch>
-            <a:fillRect/>
-          </a:stretch>
-        </p:blipFill>
-        <p:spPr>
-          <a:xfrm>
-            <a:off x="6400800" y="1645920"/>
-            <a:ext cx="5029200" cy="2826717"/>
-          </a:xfrm>
-          <a:prstGeom prst="rect">
-            <a:avLst/>
-          </a:prstGeom>
-        </p:spPr>
-      </p:pic>
-    </p:spTree>
-  </p:cSld>
-  <p:clrMapOvr>
-    <a:masterClrMapping/>
-  </p:clrMapOvr>
-</p:sld>
-</file>
-
-<file path=ppt/slides/slide3.xml><?xml version="1.0" encoding="utf-8"?>
-<p:sld xmlns:a="http://schemas.openxmlformats.org/drawingml/2006/main" xmlns:p="http://schemas.openxmlformats.org/presentationml/2006/main" xmlns:r="http://schemas.openxmlformats.org/officeDocument/2006/relationships">
-  <p:cSld>
-    <p:bg>
-      <p:bgPr>
-        <a:solidFill>
-          <a:srgbClr val="0F172A"/>
-        </a:solidFill>
-        <a:effectLst/>
-      </p:bgPr>
-    </p:bg>
-    <p:spTree>
-      <p:nvGrpSpPr>
-        <p:cNvPr id="1" name=""/>
-        <p:cNvGrpSpPr/>
-        <p:nvPr/>
-      </p:nvGrpSpPr>
-      <p:grpSpPr/>
-      <p:sp>
-        <p:nvSpPr>
-          <p:cNvPr id="2" name="TextBox 1"/>
-          <p:cNvSpPr txBox="1"/>
-          <p:nvPr/>
-        </p:nvSpPr>
-        <p:spPr>
-          <a:xfrm>
-            <a:off x="731520" y="457200"/>
-            <a:ext cx="10698480" cy="914400"/>
-          </a:xfrm>
-          <a:prstGeom prst="rect">
-            <a:avLst/>
-          </a:prstGeom>
-          <a:noFill/>
-        </p:spPr>
-        <p:txBody>
-          <a:bodyPr wrap="none">
-            <a:spAutoFit/>
-          </a:bodyPr>
-          <a:lstStyle/>
-          <a:p>
-            <a:pPr>
-              <a:defRPr sz="2800" b="1">
-                <a:solidFill>
-                  <a:srgbClr val="38BDF8"/>
-                </a:solidFill>
-              </a:defRPr>
-            </a:pPr>
-            <a:r>
-              <a:t>Exploiter la Puissance des Rêves</a:t>
-            </a:r>
-          </a:p>
-        </p:txBody>
-      </p:sp>
-      <p:sp>
-        <p:nvSpPr>
-          <p:cNvPr id="3" name="TextBox 2"/>
-          <p:cNvSpPr txBox="1"/>
-          <p:nvPr/>
-        </p:nvSpPr>
-        <p:spPr>
-          <a:xfrm>
-            <a:off x="731520" y="1645920"/>
-            <a:ext cx="5303520" cy="4389120"/>
-          </a:xfrm>
-          <a:prstGeom prst="rect">
-            <a:avLst/>
-          </a:prstGeom>
-          <a:noFill/>
-        </p:spPr>
-        <p:txBody>
-          <a:bodyPr wrap="square">
-            <a:spAutoFit/>
-          </a:bodyPr>
-          <a:lstStyle/>
+              <a:t>•  Exploiter l'énergie imaginative de l'enfance.</a:t>
+            </a:r>
+          </a:p>
           <a:p>
             <a:pPr>
               <a:spcAft>
@@ -3381,167 +3271,14 @@
               </a:defRPr>
             </a:pPr>
             <a:r>
-              <a:t>•  Reconnecter avec l'imagination enfantine</a:t>
-            </a:r>
-          </a:p>
-          <a:p>
-            <a:pPr>
-              <a:spcAft>
-                <a:spcPts val="1600"/>
-              </a:spcAft>
-              <a:defRPr sz="1700">
-                <a:solidFill>
-                  <a:srgbClr val="F8FAFC"/>
-                </a:solidFill>
-              </a:defRPr>
-            </a:pPr>
-            <a:r>
-              <a:t>•  Laisser libre cours aux idées sans jugement</a:t>
+              <a:t>•  Lâcher prise pour permettre à la créativité de s'épanouir.</a:t>
             </a:r>
           </a:p>
         </p:txBody>
       </p:sp>
       <p:pic>
         <p:nvPicPr>
-          <p:cNvPr id="4" name="Picture 3" descr="slide_keyframe_03.jpg"/>
-          <p:cNvPicPr>
-            <a:picLocks noChangeAspect="1"/>
-          </p:cNvPicPr>
-          <p:nvPr/>
-        </p:nvPicPr>
-        <p:blipFill>
-          <a:blip r:embed="rId2"/>
-          <a:stretch>
-            <a:fillRect/>
-          </a:stretch>
-        </p:blipFill>
-        <p:spPr>
-          <a:xfrm>
-            <a:off x="6400800" y="1645920"/>
-            <a:ext cx="5029200" cy="2826717"/>
-          </a:xfrm>
-          <a:prstGeom prst="rect">
-            <a:avLst/>
-          </a:prstGeom>
-        </p:spPr>
-      </p:pic>
-    </p:spTree>
-  </p:cSld>
-  <p:clrMapOvr>
-    <a:masterClrMapping/>
-  </p:clrMapOvr>
-</p:sld>
-</file>
-
-<file path=ppt/slides/slide4.xml><?xml version="1.0" encoding="utf-8"?>
-<p:sld xmlns:a="http://schemas.openxmlformats.org/drawingml/2006/main" xmlns:p="http://schemas.openxmlformats.org/presentationml/2006/main" xmlns:r="http://schemas.openxmlformats.org/officeDocument/2006/relationships">
-  <p:cSld>
-    <p:bg>
-      <p:bgPr>
-        <a:solidFill>
-          <a:srgbClr val="0F172A"/>
-        </a:solidFill>
-        <a:effectLst/>
-      </p:bgPr>
-    </p:bg>
-    <p:spTree>
-      <p:nvGrpSpPr>
-        <p:cNvPr id="1" name=""/>
-        <p:cNvGrpSpPr/>
-        <p:nvPr/>
-      </p:nvGrpSpPr>
-      <p:grpSpPr/>
-      <p:sp>
-        <p:nvSpPr>
-          <p:cNvPr id="2" name="TextBox 1"/>
-          <p:cNvSpPr txBox="1"/>
-          <p:nvPr/>
-        </p:nvSpPr>
-        <p:spPr>
-          <a:xfrm>
-            <a:off x="731520" y="457200"/>
-            <a:ext cx="10698480" cy="914400"/>
-          </a:xfrm>
-          <a:prstGeom prst="rect">
-            <a:avLst/>
-          </a:prstGeom>
-          <a:noFill/>
-        </p:spPr>
-        <p:txBody>
-          <a:bodyPr wrap="none">
-            <a:spAutoFit/>
-          </a:bodyPr>
-          <a:lstStyle/>
-          <a:p>
-            <a:pPr>
-              <a:defRPr sz="2800" b="1">
-                <a:solidFill>
-                  <a:srgbClr val="38BDF8"/>
-                </a:solidFill>
-              </a:defRPr>
-            </a:pPr>
-            <a:r>
-              <a:t>L'Art de Lâcher Prise</a:t>
-            </a:r>
-          </a:p>
-        </p:txBody>
-      </p:sp>
-      <p:sp>
-        <p:nvSpPr>
-          <p:cNvPr id="3" name="TextBox 2"/>
-          <p:cNvSpPr txBox="1"/>
-          <p:nvPr/>
-        </p:nvSpPr>
-        <p:spPr>
-          <a:xfrm>
-            <a:off x="731520" y="1645920"/>
-            <a:ext cx="5303520" cy="4389120"/>
-          </a:xfrm>
-          <a:prstGeom prst="rect">
-            <a:avLst/>
-          </a:prstGeom>
-          <a:noFill/>
-        </p:spPr>
-        <p:txBody>
-          <a:bodyPr wrap="square">
-            <a:spAutoFit/>
-          </a:bodyPr>
-          <a:lstStyle/>
-          <a:p>
-            <a:pPr>
-              <a:spcAft>
-                <a:spcPts val="1600"/>
-              </a:spcAft>
-              <a:defRPr sz="1700">
-                <a:solidFill>
-                  <a:srgbClr val="F8FAFC"/>
-                </a:solidFill>
-              </a:defRPr>
-            </a:pPr>
-            <a:r>
-              <a:t>•  Prioriser le bien-être pour nourrir la créativité</a:t>
-            </a:r>
-          </a:p>
-          <a:p>
-            <a:pPr>
-              <a:spcAft>
-                <a:spcPts val="1600"/>
-              </a:spcAft>
-              <a:defRPr sz="1700">
-                <a:solidFill>
-                  <a:srgbClr val="F8FAFC"/>
-                </a:solidFill>
-              </a:defRPr>
-            </a:pPr>
-            <a:r>
-              <a:t>•  Accepter de ne pas tout contrôler</a:t>
-            </a:r>
-          </a:p>
-        </p:txBody>
-      </p:sp>
-      <p:pic>
-        <p:nvPicPr>
-          <p:cNvPr id="4" name="Picture 3" descr="slide_keyframe_04.jpg"/>
+          <p:cNvPr id="4" name="Picture 3" descr="slide_keyframe_02.jpg"/>
           <p:cNvPicPr>
             <a:picLocks noChangeAspect="1"/>
           </p:cNvPicPr>

</xml_diff>

<commit_message>
docs: humanisation des README et intégration du guide de sélection interactive
</commit_message>
<xml_diff>
--- a/demo/output/presentation.pptx
+++ b/demo/output/presentation.pptx
@@ -3142,7 +3142,7 @@
               </a:defRPr>
             </a:pPr>
             <a:r>
-              <a:t>Stratégies de créativité, 2023, Zoe Hames et Chris Lewis</a:t>
+              <a:t>Stratégies de créativité, 2023, Zoe Hames</a:t>
             </a:r>
           </a:p>
         </p:txBody>
@@ -3203,7 +3203,7 @@
               </a:defRPr>
             </a:pPr>
             <a:r>
-              <a:t>Stratégies pour Libérer la Créativité</a:t>
+              <a:t>Stratégies pour libérer votre potentiel</a:t>
             </a:r>
           </a:p>
         </p:txBody>
@@ -3241,7 +3241,7 @@
               </a:defRPr>
             </a:pPr>
             <a:r>
-              <a:t>•  Trouver le calme pour favoriser l'inspiration.</a:t>
+              <a:t>•  Trouver des moments de calme pour favoriser l'inspiration.</a:t>
             </a:r>
           </a:p>
           <a:p>
@@ -3271,7 +3271,7 @@
               </a:defRPr>
             </a:pPr>
             <a:r>
-              <a:t>•  Lâcher prise pour permettre à la créativité de s'épanouir.</a:t>
+              <a:t>•  Apprendre à lâcher prise pour laisser place à la créativité.</a:t>
             </a:r>
           </a:p>
         </p:txBody>

</xml_diff>

<commit_message>
feat: support du téléchargement automatique Google Drive et sélection interactive de vidéo
</commit_message>
<xml_diff>
--- a/demo/output/presentation.pptx
+++ b/demo/output/presentation.pptx
@@ -7,6 +7,8 @@
   <p:sldIdLst>
     <p:sldId id="256" r:id="rId7"/>
     <p:sldId id="257" r:id="rId8"/>
+    <p:sldId id="258" r:id="rId9"/>
+    <p:sldId id="259" r:id="rId10"/>
   </p:sldIdLst>
   <p:sldSz cx="12191695" cy="6858000" type="screen4x3"/>
   <p:notesSz cx="6858000" cy="9144000"/>
@@ -3142,7 +3144,7 @@
               </a:defRPr>
             </a:pPr>
             <a:r>
-              <a:t>Stratégies de créativité, 2023, Zoe Hames</a:t>
+              <a:t>Stratégies de créativité, date, Zoe Hames et Chris Lewis</a:t>
             </a:r>
           </a:p>
         </p:txBody>
@@ -3203,7 +3205,7 @@
               </a:defRPr>
             </a:pPr>
             <a:r>
-              <a:t>Stratégies pour libérer votre potentiel</a:t>
+              <a:t>Trouver le Silence</a:t>
             </a:r>
           </a:p>
         </p:txBody>
@@ -3241,7 +3243,7 @@
               </a:defRPr>
             </a:pPr>
             <a:r>
-              <a:t>•  Trouver des moments de calme pour favoriser l'inspiration.</a:t>
+              <a:t>•  Le silence permet à l'inspiration de surgir.</a:t>
             </a:r>
           </a:p>
           <a:p>
@@ -3256,9 +3258,117 @@
               </a:defRPr>
             </a:pPr>
             <a:r>
-              <a:t>•  Exploiter l'énergie imaginative de l'enfance.</a:t>
-            </a:r>
-          </a:p>
+              <a:t>•  Créer des moments de calme aide à se reconnecter à soi-même.</a:t>
+            </a:r>
+          </a:p>
+        </p:txBody>
+      </p:sp>
+      <p:pic>
+        <p:nvPicPr>
+          <p:cNvPr id="4" name="Picture 3" descr="slide_keyframe_02.jpg"/>
+          <p:cNvPicPr>
+            <a:picLocks noChangeAspect="1"/>
+          </p:cNvPicPr>
+          <p:nvPr/>
+        </p:nvPicPr>
+        <p:blipFill>
+          <a:blip r:embed="rId2"/>
+          <a:stretch>
+            <a:fillRect/>
+          </a:stretch>
+        </p:blipFill>
+        <p:spPr>
+          <a:xfrm>
+            <a:off x="6400800" y="1645920"/>
+            <a:ext cx="5029200" cy="2826717"/>
+          </a:xfrm>
+          <a:prstGeom prst="rect">
+            <a:avLst/>
+          </a:prstGeom>
+        </p:spPr>
+      </p:pic>
+    </p:spTree>
+  </p:cSld>
+  <p:clrMapOvr>
+    <a:masterClrMapping/>
+  </p:clrMapOvr>
+</p:sld>
+</file>
+
+<file path=ppt/slides/slide3.xml><?xml version="1.0" encoding="utf-8"?>
+<p:sld xmlns:a="http://schemas.openxmlformats.org/drawingml/2006/main" xmlns:p="http://schemas.openxmlformats.org/presentationml/2006/main" xmlns:r="http://schemas.openxmlformats.org/officeDocument/2006/relationships">
+  <p:cSld>
+    <p:bg>
+      <p:bgPr>
+        <a:solidFill>
+          <a:srgbClr val="0F172A"/>
+        </a:solidFill>
+        <a:effectLst/>
+      </p:bgPr>
+    </p:bg>
+    <p:spTree>
+      <p:nvGrpSpPr>
+        <p:cNvPr id="1" name=""/>
+        <p:cNvGrpSpPr/>
+        <p:nvPr/>
+      </p:nvGrpSpPr>
+      <p:grpSpPr/>
+      <p:sp>
+        <p:nvSpPr>
+          <p:cNvPr id="2" name="TextBox 1"/>
+          <p:cNvSpPr txBox="1"/>
+          <p:nvPr/>
+        </p:nvSpPr>
+        <p:spPr>
+          <a:xfrm>
+            <a:off x="731520" y="457200"/>
+            <a:ext cx="10698480" cy="914400"/>
+          </a:xfrm>
+          <a:prstGeom prst="rect">
+            <a:avLst/>
+          </a:prstGeom>
+          <a:noFill/>
+        </p:spPr>
+        <p:txBody>
+          <a:bodyPr wrap="none">
+            <a:spAutoFit/>
+          </a:bodyPr>
+          <a:lstStyle/>
+          <a:p>
+            <a:pPr>
+              <a:defRPr sz="2800" b="1">
+                <a:solidFill>
+                  <a:srgbClr val="38BDF8"/>
+                </a:solidFill>
+              </a:defRPr>
+            </a:pPr>
+            <a:r>
+              <a:t>Exploiter les Rêves</a:t>
+            </a:r>
+          </a:p>
+        </p:txBody>
+      </p:sp>
+      <p:sp>
+        <p:nvSpPr>
+          <p:cNvPr id="3" name="TextBox 2"/>
+          <p:cNvSpPr txBox="1"/>
+          <p:nvPr/>
+        </p:nvSpPr>
+        <p:spPr>
+          <a:xfrm>
+            <a:off x="731520" y="1645920"/>
+            <a:ext cx="5303520" cy="4389120"/>
+          </a:xfrm>
+          <a:prstGeom prst="rect">
+            <a:avLst/>
+          </a:prstGeom>
+          <a:noFill/>
+        </p:spPr>
+        <p:txBody>
+          <a:bodyPr wrap="square">
+            <a:spAutoFit/>
+          </a:bodyPr>
+          <a:lstStyle/>
           <a:p>
             <a:pPr>
               <a:spcAft>
@@ -3271,14 +3381,167 @@
               </a:defRPr>
             </a:pPr>
             <a:r>
-              <a:t>•  Apprendre à lâcher prise pour laisser place à la créativité.</a:t>
+              <a:t>•  Laissez libre cours à votre imagination.</a:t>
+            </a:r>
+          </a:p>
+          <a:p>
+            <a:pPr>
+              <a:spcAft>
+                <a:spcPts val="1600"/>
+              </a:spcAft>
+              <a:defRPr sz="1700">
+                <a:solidFill>
+                  <a:srgbClr val="F8FAFC"/>
+                </a:solidFill>
+              </a:defRPr>
+            </a:pPr>
+            <a:r>
+              <a:t>•  Les idées folles peuvent mener à des innovations.</a:t>
             </a:r>
           </a:p>
         </p:txBody>
       </p:sp>
       <p:pic>
         <p:nvPicPr>
-          <p:cNvPr id="4" name="Picture 3" descr="slide_keyframe_02.jpg"/>
+          <p:cNvPr id="4" name="Picture 3" descr="slide_keyframe_03.jpg"/>
+          <p:cNvPicPr>
+            <a:picLocks noChangeAspect="1"/>
+          </p:cNvPicPr>
+          <p:nvPr/>
+        </p:nvPicPr>
+        <p:blipFill>
+          <a:blip r:embed="rId2"/>
+          <a:stretch>
+            <a:fillRect/>
+          </a:stretch>
+        </p:blipFill>
+        <p:spPr>
+          <a:xfrm>
+            <a:off x="6400800" y="1645920"/>
+            <a:ext cx="5029200" cy="2826717"/>
+          </a:xfrm>
+          <a:prstGeom prst="rect">
+            <a:avLst/>
+          </a:prstGeom>
+        </p:spPr>
+      </p:pic>
+    </p:spTree>
+  </p:cSld>
+  <p:clrMapOvr>
+    <a:masterClrMapping/>
+  </p:clrMapOvr>
+</p:sld>
+</file>
+
+<file path=ppt/slides/slide4.xml><?xml version="1.0" encoding="utf-8"?>
+<p:sld xmlns:a="http://schemas.openxmlformats.org/drawingml/2006/main" xmlns:p="http://schemas.openxmlformats.org/presentationml/2006/main" xmlns:r="http://schemas.openxmlformats.org/officeDocument/2006/relationships">
+  <p:cSld>
+    <p:bg>
+      <p:bgPr>
+        <a:solidFill>
+          <a:srgbClr val="0F172A"/>
+        </a:solidFill>
+        <a:effectLst/>
+      </p:bgPr>
+    </p:bg>
+    <p:spTree>
+      <p:nvGrpSpPr>
+        <p:cNvPr id="1" name=""/>
+        <p:cNvGrpSpPr/>
+        <p:nvPr/>
+      </p:nvGrpSpPr>
+      <p:grpSpPr/>
+      <p:sp>
+        <p:nvSpPr>
+          <p:cNvPr id="2" name="TextBox 1"/>
+          <p:cNvSpPr txBox="1"/>
+          <p:nvPr/>
+        </p:nvSpPr>
+        <p:spPr>
+          <a:xfrm>
+            <a:off x="731520" y="457200"/>
+            <a:ext cx="10698480" cy="914400"/>
+          </a:xfrm>
+          <a:prstGeom prst="rect">
+            <a:avLst/>
+          </a:prstGeom>
+          <a:noFill/>
+        </p:spPr>
+        <p:txBody>
+          <a:bodyPr wrap="none">
+            <a:spAutoFit/>
+          </a:bodyPr>
+          <a:lstStyle/>
+          <a:p>
+            <a:pPr>
+              <a:defRPr sz="2800" b="1">
+                <a:solidFill>
+                  <a:srgbClr val="38BDF8"/>
+                </a:solidFill>
+              </a:defRPr>
+            </a:pPr>
+            <a:r>
+              <a:t>Laisser Aller</a:t>
+            </a:r>
+          </a:p>
+        </p:txBody>
+      </p:sp>
+      <p:sp>
+        <p:nvSpPr>
+          <p:cNvPr id="3" name="TextBox 2"/>
+          <p:cNvSpPr txBox="1"/>
+          <p:nvPr/>
+        </p:nvSpPr>
+        <p:spPr>
+          <a:xfrm>
+            <a:off x="731520" y="1645920"/>
+            <a:ext cx="5303520" cy="4389120"/>
+          </a:xfrm>
+          <a:prstGeom prst="rect">
+            <a:avLst/>
+          </a:prstGeom>
+          <a:noFill/>
+        </p:spPr>
+        <p:txBody>
+          <a:bodyPr wrap="square">
+            <a:spAutoFit/>
+          </a:bodyPr>
+          <a:lstStyle/>
+          <a:p>
+            <a:pPr>
+              <a:spcAft>
+                <a:spcPts val="1600"/>
+              </a:spcAft>
+              <a:defRPr sz="1700">
+                <a:solidFill>
+                  <a:srgbClr val="F8FAFC"/>
+                </a:solidFill>
+              </a:defRPr>
+            </a:pPr>
+            <a:r>
+              <a:t>•  Accepter de ne pas tout contrôler.</a:t>
+            </a:r>
+          </a:p>
+          <a:p>
+            <a:pPr>
+              <a:spcAft>
+                <a:spcPts val="1600"/>
+              </a:spcAft>
+              <a:defRPr sz="1700">
+                <a:solidFill>
+                  <a:srgbClr val="F8FAFC"/>
+                </a:solidFill>
+              </a:defRPr>
+            </a:pPr>
+            <a:r>
+              <a:t>•  Prioriser le bien-être pour favoriser la créativité.</a:t>
+            </a:r>
+          </a:p>
+        </p:txBody>
+      </p:sp>
+      <p:pic>
+        <p:nvPicPr>
+          <p:cNvPr id="4" name="Picture 3" descr="slide_keyframe_04.jpg"/>
           <p:cNvPicPr>
             <a:picLocks noChangeAspect="1"/>
           </p:cNvPicPr>

</xml_diff>

<commit_message>
feat: enregistrement intelligent des livrables a cote de la video, notification visuelle et deck 10 slides humanise
</commit_message>
<xml_diff>
--- a/demo/output/presentation.pptx
+++ b/demo/output/presentation.pptx
@@ -9,6 +9,12 @@
     <p:sldId id="257" r:id="rId8"/>
     <p:sldId id="258" r:id="rId9"/>
     <p:sldId id="259" r:id="rId10"/>
+    <p:sldId id="260" r:id="rId11"/>
+    <p:sldId id="261" r:id="rId12"/>
+    <p:sldId id="262" r:id="rId13"/>
+    <p:sldId id="263" r:id="rId14"/>
+    <p:sldId id="264" r:id="rId15"/>
+    <p:sldId id="265" r:id="rId16"/>
   </p:sldIdLst>
   <p:sldSz cx="12191695" cy="6858000" type="screen4x3"/>
   <p:notesSz cx="6858000" cy="9144000"/>
@@ -3129,7 +3135,7 @@
               </a:defRPr>
             </a:pPr>
             <a:r>
-              <a:t>Débloquer le Potentiel Créatif</a:t>
+              <a:t>stimuler la créativité</a:t>
             </a:r>
           </a:p>
           <a:p>
@@ -3144,11 +3150,149 @@
               </a:defRPr>
             </a:pPr>
             <a:r>
-              <a:t>Stratégies de créativité, date, Zoe Hames et Chris Lewis</a:t>
-            </a:r>
-          </a:p>
-        </p:txBody>
-      </p:sp>
+              <a:t>Session animée par Zoe Hames</a:t>
+            </a:r>
+          </a:p>
+        </p:txBody>
+      </p:sp>
+    </p:spTree>
+  </p:cSld>
+  <p:clrMapOvr>
+    <a:masterClrMapping/>
+  </p:clrMapOvr>
+</p:sld>
+</file>
+
+<file path=ppt/slides/slide10.xml><?xml version="1.0" encoding="utf-8"?>
+<p:sld xmlns:a="http://schemas.openxmlformats.org/drawingml/2006/main" xmlns:p="http://schemas.openxmlformats.org/presentationml/2006/main" xmlns:r="http://schemas.openxmlformats.org/officeDocument/2006/relationships">
+  <p:cSld>
+    <p:bg>
+      <p:bgPr>
+        <a:solidFill>
+          <a:srgbClr val="0F172A"/>
+        </a:solidFill>
+        <a:effectLst/>
+      </p:bgPr>
+    </p:bg>
+    <p:spTree>
+      <p:nvGrpSpPr>
+        <p:cNvPr id="1" name=""/>
+        <p:cNvGrpSpPr/>
+        <p:nvPr/>
+      </p:nvGrpSpPr>
+      <p:grpSpPr/>
+      <p:sp>
+        <p:nvSpPr>
+          <p:cNvPr id="2" name="TextBox 1"/>
+          <p:cNvSpPr txBox="1"/>
+          <p:nvPr/>
+        </p:nvSpPr>
+        <p:spPr>
+          <a:xfrm>
+            <a:off x="731520" y="457200"/>
+            <a:ext cx="10698480" cy="914400"/>
+          </a:xfrm>
+          <a:prstGeom prst="rect">
+            <a:avLst/>
+          </a:prstGeom>
+          <a:noFill/>
+        </p:spPr>
+        <p:txBody>
+          <a:bodyPr wrap="none">
+            <a:spAutoFit/>
+          </a:bodyPr>
+          <a:lstStyle/>
+          <a:p>
+            <a:pPr>
+              <a:defRPr sz="2800" b="1">
+                <a:solidFill>
+                  <a:srgbClr val="38BDF8"/>
+                </a:solidFill>
+              </a:defRPr>
+            </a:pPr>
+            <a:r>
+              <a:t>Questions et Échanges</a:t>
+            </a:r>
+          </a:p>
+        </p:txBody>
+      </p:sp>
+      <p:sp>
+        <p:nvSpPr>
+          <p:cNvPr id="3" name="TextBox 2"/>
+          <p:cNvSpPr txBox="1"/>
+          <p:nvPr/>
+        </p:nvSpPr>
+        <p:spPr>
+          <a:xfrm>
+            <a:off x="731520" y="1645920"/>
+            <a:ext cx="5303520" cy="4389120"/>
+          </a:xfrm>
+          <a:prstGeom prst="rect">
+            <a:avLst/>
+          </a:prstGeom>
+          <a:noFill/>
+        </p:spPr>
+        <p:txBody>
+          <a:bodyPr wrap="square">
+            <a:spAutoFit/>
+          </a:bodyPr>
+          <a:lstStyle/>
+          <a:p>
+            <a:pPr>
+              <a:spcAft>
+                <a:spcPts val="1600"/>
+              </a:spcAft>
+              <a:defRPr sz="1700">
+                <a:solidFill>
+                  <a:srgbClr val="F8FAFC"/>
+                </a:solidFill>
+              </a:defRPr>
+            </a:pPr>
+            <a:r>
+              <a:t>•  Discussion ouverte</a:t>
+            </a:r>
+          </a:p>
+          <a:p>
+            <a:pPr>
+              <a:spcAft>
+                <a:spcPts val="1600"/>
+              </a:spcAft>
+              <a:defRPr sz="1700">
+                <a:solidFill>
+                  <a:srgbClr val="F8FAFC"/>
+                </a:solidFill>
+              </a:defRPr>
+            </a:pPr>
+            <a:r>
+              <a:t>•  Partage d'expériences</a:t>
+            </a:r>
+          </a:p>
+        </p:txBody>
+      </p:sp>
+      <p:pic>
+        <p:nvPicPr>
+          <p:cNvPr id="4" name="Picture 3" descr="slide_keyframe_09.jpg"/>
+          <p:cNvPicPr>
+            <a:picLocks noChangeAspect="1"/>
+          </p:cNvPicPr>
+          <p:nvPr/>
+        </p:nvPicPr>
+        <p:blipFill>
+          <a:blip r:embed="rId2"/>
+          <a:stretch>
+            <a:fillRect/>
+          </a:stretch>
+        </p:blipFill>
+        <p:spPr>
+          <a:xfrm>
+            <a:off x="6400800" y="1645920"/>
+            <a:ext cx="5029200" cy="2826717"/>
+          </a:xfrm>
+          <a:prstGeom prst="rect">
+            <a:avLst/>
+          </a:prstGeom>
+        </p:spPr>
+      </p:pic>
     </p:spTree>
   </p:cSld>
   <p:clrMapOvr>
@@ -3205,7 +3349,7 @@
               </a:defRPr>
             </a:pPr>
             <a:r>
-              <a:t>Trouver le Silence</a:t>
+              <a:t>Contexte et problématique centrale</a:t>
             </a:r>
           </a:p>
         </p:txBody>
@@ -3243,7 +3387,7 @@
               </a:defRPr>
             </a:pPr>
             <a:r>
-              <a:t>•  Le silence permet à l'inspiration de surgir.</a:t>
+              <a:t>•  Saturation d'informations</a:t>
             </a:r>
           </a:p>
           <a:p>
@@ -3258,14 +3402,29 @@
               </a:defRPr>
             </a:pPr>
             <a:r>
-              <a:t>•  Créer des moments de calme aide à se reconnecter à soi-même.</a:t>
+              <a:t>•  Impact sur la créativité</a:t>
+            </a:r>
+          </a:p>
+          <a:p>
+            <a:pPr>
+              <a:spcAft>
+                <a:spcPts val="1600"/>
+              </a:spcAft>
+              <a:defRPr sz="1700">
+                <a:solidFill>
+                  <a:srgbClr val="F8FAFC"/>
+                </a:solidFill>
+              </a:defRPr>
+            </a:pPr>
+            <a:r>
+              <a:t>•  Nécessité de stratégies adaptées</a:t>
             </a:r>
           </a:p>
         </p:txBody>
       </p:sp>
       <p:pic>
         <p:nvPicPr>
-          <p:cNvPr id="4" name="Picture 3" descr="slide_keyframe_02.jpg"/>
+          <p:cNvPr id="4" name="Picture 3" descr="slide_keyframe_01.jpg"/>
           <p:cNvPicPr>
             <a:picLocks noChangeAspect="1"/>
           </p:cNvPicPr>
@@ -3343,7 +3502,7 @@
               </a:defRPr>
             </a:pPr>
             <a:r>
-              <a:t>Exploiter les Rêves</a:t>
+              <a:t>Importance du Silence</a:t>
             </a:r>
           </a:p>
         </p:txBody>
@@ -3381,7 +3540,7 @@
               </a:defRPr>
             </a:pPr>
             <a:r>
-              <a:t>•  Laissez libre cours à votre imagination.</a:t>
+              <a:t>•  Moments de déconnexion</a:t>
             </a:r>
           </a:p>
           <a:p>
@@ -3396,14 +3555,14 @@
               </a:defRPr>
             </a:pPr>
             <a:r>
-              <a:t>•  Les idées folles peuvent mener à des innovations.</a:t>
+              <a:t>•  Espace pour la réflexion</a:t>
             </a:r>
           </a:p>
         </p:txBody>
       </p:sp>
       <p:pic>
         <p:nvPicPr>
-          <p:cNvPr id="4" name="Picture 3" descr="slide_keyframe_03.jpg"/>
+          <p:cNvPr id="4" name="Picture 3" descr="slide_keyframe_02.jpg"/>
           <p:cNvPicPr>
             <a:picLocks noChangeAspect="1"/>
           </p:cNvPicPr>
@@ -3481,7 +3640,7 @@
               </a:defRPr>
             </a:pPr>
             <a:r>
-              <a:t>Laisser Aller</a:t>
+              <a:t>Explorer le Pouvoir des Rêves</a:t>
             </a:r>
           </a:p>
         </p:txBody>
@@ -3519,7 +3678,7 @@
               </a:defRPr>
             </a:pPr>
             <a:r>
-              <a:t>•  Accepter de ne pas tout contrôler.</a:t>
+              <a:t>•  Pensée libre</a:t>
             </a:r>
           </a:p>
           <a:p>
@@ -3534,7 +3693,145 @@
               </a:defRPr>
             </a:pPr>
             <a:r>
-              <a:t>•  Prioriser le bien-être pour favoriser la créativité.</a:t>
+              <a:t>•  Inspiration des rêves</a:t>
+            </a:r>
+          </a:p>
+        </p:txBody>
+      </p:sp>
+      <p:pic>
+        <p:nvPicPr>
+          <p:cNvPr id="4" name="Picture 3" descr="slide_keyframe_03.jpg"/>
+          <p:cNvPicPr>
+            <a:picLocks noChangeAspect="1"/>
+          </p:cNvPicPr>
+          <p:nvPr/>
+        </p:nvPicPr>
+        <p:blipFill>
+          <a:blip r:embed="rId2"/>
+          <a:stretch>
+            <a:fillRect/>
+          </a:stretch>
+        </p:blipFill>
+        <p:spPr>
+          <a:xfrm>
+            <a:off x="6400800" y="1645920"/>
+            <a:ext cx="5029200" cy="2826717"/>
+          </a:xfrm>
+          <a:prstGeom prst="rect">
+            <a:avLst/>
+          </a:prstGeom>
+        </p:spPr>
+      </p:pic>
+    </p:spTree>
+  </p:cSld>
+  <p:clrMapOvr>
+    <a:masterClrMapping/>
+  </p:clrMapOvr>
+</p:sld>
+</file>
+
+<file path=ppt/slides/slide5.xml><?xml version="1.0" encoding="utf-8"?>
+<p:sld xmlns:a="http://schemas.openxmlformats.org/drawingml/2006/main" xmlns:p="http://schemas.openxmlformats.org/presentationml/2006/main" xmlns:r="http://schemas.openxmlformats.org/officeDocument/2006/relationships">
+  <p:cSld>
+    <p:bg>
+      <p:bgPr>
+        <a:solidFill>
+          <a:srgbClr val="0F172A"/>
+        </a:solidFill>
+        <a:effectLst/>
+      </p:bgPr>
+    </p:bg>
+    <p:spTree>
+      <p:nvGrpSpPr>
+        <p:cNvPr id="1" name=""/>
+        <p:cNvGrpSpPr/>
+        <p:nvPr/>
+      </p:nvGrpSpPr>
+      <p:grpSpPr/>
+      <p:sp>
+        <p:nvSpPr>
+          <p:cNvPr id="2" name="TextBox 1"/>
+          <p:cNvSpPr txBox="1"/>
+          <p:nvPr/>
+        </p:nvSpPr>
+        <p:spPr>
+          <a:xfrm>
+            <a:off x="731520" y="457200"/>
+            <a:ext cx="10698480" cy="914400"/>
+          </a:xfrm>
+          <a:prstGeom prst="rect">
+            <a:avLst/>
+          </a:prstGeom>
+          <a:noFill/>
+        </p:spPr>
+        <p:txBody>
+          <a:bodyPr wrap="none">
+            <a:spAutoFit/>
+          </a:bodyPr>
+          <a:lstStyle/>
+          <a:p>
+            <a:pPr>
+              <a:defRPr sz="2800" b="1">
+                <a:solidFill>
+                  <a:srgbClr val="38BDF8"/>
+                </a:solidFill>
+              </a:defRPr>
+            </a:pPr>
+            <a:r>
+              <a:t>Lâcher Prise pour Favoriser la Créativité</a:t>
+            </a:r>
+          </a:p>
+        </p:txBody>
+      </p:sp>
+      <p:sp>
+        <p:nvSpPr>
+          <p:cNvPr id="3" name="TextBox 2"/>
+          <p:cNvSpPr txBox="1"/>
+          <p:nvPr/>
+        </p:nvSpPr>
+        <p:spPr>
+          <a:xfrm>
+            <a:off x="731520" y="1645920"/>
+            <a:ext cx="5303520" cy="4389120"/>
+          </a:xfrm>
+          <a:prstGeom prst="rect">
+            <a:avLst/>
+          </a:prstGeom>
+          <a:noFill/>
+        </p:spPr>
+        <p:txBody>
+          <a:bodyPr wrap="square">
+            <a:spAutoFit/>
+          </a:bodyPr>
+          <a:lstStyle/>
+          <a:p>
+            <a:pPr>
+              <a:spcAft>
+                <a:spcPts val="1600"/>
+              </a:spcAft>
+              <a:defRPr sz="1700">
+                <a:solidFill>
+                  <a:srgbClr val="F8FAFC"/>
+                </a:solidFill>
+              </a:defRPr>
+            </a:pPr>
+            <a:r>
+              <a:t>•  Accepter l'incertitude</a:t>
+            </a:r>
+          </a:p>
+          <a:p>
+            <a:pPr>
+              <a:spcAft>
+                <a:spcPts val="1600"/>
+              </a:spcAft>
+              <a:defRPr sz="1700">
+                <a:solidFill>
+                  <a:srgbClr val="F8FAFC"/>
+                </a:solidFill>
+              </a:defRPr>
+            </a:pPr>
+            <a:r>
+              <a:t>•  Prendre soin de soi</a:t>
             </a:r>
           </a:p>
         </p:txBody>
@@ -3542,6 +3839,558 @@
       <p:pic>
         <p:nvPicPr>
           <p:cNvPr id="4" name="Picture 3" descr="slide_keyframe_04.jpg"/>
+          <p:cNvPicPr>
+            <a:picLocks noChangeAspect="1"/>
+          </p:cNvPicPr>
+          <p:nvPr/>
+        </p:nvPicPr>
+        <p:blipFill>
+          <a:blip r:embed="rId2"/>
+          <a:stretch>
+            <a:fillRect/>
+          </a:stretch>
+        </p:blipFill>
+        <p:spPr>
+          <a:xfrm>
+            <a:off x="6400800" y="1645920"/>
+            <a:ext cx="5029200" cy="2826717"/>
+          </a:xfrm>
+          <a:prstGeom prst="rect">
+            <a:avLst/>
+          </a:prstGeom>
+        </p:spPr>
+      </p:pic>
+    </p:spTree>
+  </p:cSld>
+  <p:clrMapOvr>
+    <a:masterClrMapping/>
+  </p:clrMapOvr>
+</p:sld>
+</file>
+
+<file path=ppt/slides/slide6.xml><?xml version="1.0" encoding="utf-8"?>
+<p:sld xmlns:a="http://schemas.openxmlformats.org/drawingml/2006/main" xmlns:p="http://schemas.openxmlformats.org/presentationml/2006/main" xmlns:r="http://schemas.openxmlformats.org/officeDocument/2006/relationships">
+  <p:cSld>
+    <p:bg>
+      <p:bgPr>
+        <a:solidFill>
+          <a:srgbClr val="0F172A"/>
+        </a:solidFill>
+        <a:effectLst/>
+      </p:bgPr>
+    </p:bg>
+    <p:spTree>
+      <p:nvGrpSpPr>
+        <p:cNvPr id="1" name=""/>
+        <p:cNvGrpSpPr/>
+        <p:nvPr/>
+      </p:nvGrpSpPr>
+      <p:grpSpPr/>
+      <p:sp>
+        <p:nvSpPr>
+          <p:cNvPr id="2" name="TextBox 1"/>
+          <p:cNvSpPr txBox="1"/>
+          <p:nvPr/>
+        </p:nvSpPr>
+        <p:spPr>
+          <a:xfrm>
+            <a:off x="731520" y="457200"/>
+            <a:ext cx="10698480" cy="914400"/>
+          </a:xfrm>
+          <a:prstGeom prst="rect">
+            <a:avLst/>
+          </a:prstGeom>
+          <a:noFill/>
+        </p:spPr>
+        <p:txBody>
+          <a:bodyPr wrap="none">
+            <a:spAutoFit/>
+          </a:bodyPr>
+          <a:lstStyle/>
+          <a:p>
+            <a:pPr>
+              <a:defRPr sz="2800" b="1">
+                <a:solidFill>
+                  <a:srgbClr val="38BDF8"/>
+                </a:solidFill>
+              </a:defRPr>
+            </a:pPr>
+            <a:r>
+              <a:t>Pratiques Quotidiennes pour Stimuler la Créativité</a:t>
+            </a:r>
+          </a:p>
+        </p:txBody>
+      </p:sp>
+      <p:sp>
+        <p:nvSpPr>
+          <p:cNvPr id="3" name="TextBox 2"/>
+          <p:cNvSpPr txBox="1"/>
+          <p:nvPr/>
+        </p:nvSpPr>
+        <p:spPr>
+          <a:xfrm>
+            <a:off x="731520" y="1645920"/>
+            <a:ext cx="5303520" cy="4389120"/>
+          </a:xfrm>
+          <a:prstGeom prst="rect">
+            <a:avLst/>
+          </a:prstGeom>
+          <a:noFill/>
+        </p:spPr>
+        <p:txBody>
+          <a:bodyPr wrap="square">
+            <a:spAutoFit/>
+          </a:bodyPr>
+          <a:lstStyle/>
+          <a:p>
+            <a:pPr>
+              <a:spcAft>
+                <a:spcPts val="1600"/>
+              </a:spcAft>
+              <a:defRPr sz="1700">
+                <a:solidFill>
+                  <a:srgbClr val="F8FAFC"/>
+                </a:solidFill>
+              </a:defRPr>
+            </a:pPr>
+            <a:r>
+              <a:t>•  Rituels de déconnexion</a:t>
+            </a:r>
+          </a:p>
+          <a:p>
+            <a:pPr>
+              <a:spcAft>
+                <a:spcPts val="1600"/>
+              </a:spcAft>
+              <a:defRPr sz="1700">
+                <a:solidFill>
+                  <a:srgbClr val="F8FAFC"/>
+                </a:solidFill>
+              </a:defRPr>
+            </a:pPr>
+            <a:r>
+              <a:t>•  Activités artistiques</a:t>
+            </a:r>
+          </a:p>
+        </p:txBody>
+      </p:sp>
+      <p:pic>
+        <p:nvPicPr>
+          <p:cNvPr id="4" name="Picture 3" descr="slide_keyframe_05.jpg"/>
+          <p:cNvPicPr>
+            <a:picLocks noChangeAspect="1"/>
+          </p:cNvPicPr>
+          <p:nvPr/>
+        </p:nvPicPr>
+        <p:blipFill>
+          <a:blip r:embed="rId2"/>
+          <a:stretch>
+            <a:fillRect/>
+          </a:stretch>
+        </p:blipFill>
+        <p:spPr>
+          <a:xfrm>
+            <a:off x="6400800" y="1645920"/>
+            <a:ext cx="5029200" cy="2826717"/>
+          </a:xfrm>
+          <a:prstGeom prst="rect">
+            <a:avLst/>
+          </a:prstGeom>
+        </p:spPr>
+      </p:pic>
+    </p:spTree>
+  </p:cSld>
+  <p:clrMapOvr>
+    <a:masterClrMapping/>
+  </p:clrMapOvr>
+</p:sld>
+</file>
+
+<file path=ppt/slides/slide7.xml><?xml version="1.0" encoding="utf-8"?>
+<p:sld xmlns:a="http://schemas.openxmlformats.org/drawingml/2006/main" xmlns:p="http://schemas.openxmlformats.org/presentationml/2006/main" xmlns:r="http://schemas.openxmlformats.org/officeDocument/2006/relationships">
+  <p:cSld>
+    <p:bg>
+      <p:bgPr>
+        <a:solidFill>
+          <a:srgbClr val="0F172A"/>
+        </a:solidFill>
+        <a:effectLst/>
+      </p:bgPr>
+    </p:bg>
+    <p:spTree>
+      <p:nvGrpSpPr>
+        <p:cNvPr id="1" name=""/>
+        <p:cNvGrpSpPr/>
+        <p:nvPr/>
+      </p:nvGrpSpPr>
+      <p:grpSpPr/>
+      <p:sp>
+        <p:nvSpPr>
+          <p:cNvPr id="2" name="TextBox 1"/>
+          <p:cNvSpPr txBox="1"/>
+          <p:nvPr/>
+        </p:nvSpPr>
+        <p:spPr>
+          <a:xfrm>
+            <a:off x="731520" y="457200"/>
+            <a:ext cx="10698480" cy="914400"/>
+          </a:xfrm>
+          <a:prstGeom prst="rect">
+            <a:avLst/>
+          </a:prstGeom>
+          <a:noFill/>
+        </p:spPr>
+        <p:txBody>
+          <a:bodyPr wrap="none">
+            <a:spAutoFit/>
+          </a:bodyPr>
+          <a:lstStyle/>
+          <a:p>
+            <a:pPr>
+              <a:defRPr sz="2800" b="1">
+                <a:solidFill>
+                  <a:srgbClr val="38BDF8"/>
+                </a:solidFill>
+              </a:defRPr>
+            </a:pPr>
+            <a:r>
+              <a:t>Conclusion et Prochaines Étapes</a:t>
+            </a:r>
+          </a:p>
+        </p:txBody>
+      </p:sp>
+      <p:sp>
+        <p:nvSpPr>
+          <p:cNvPr id="3" name="TextBox 2"/>
+          <p:cNvSpPr txBox="1"/>
+          <p:nvPr/>
+        </p:nvSpPr>
+        <p:spPr>
+          <a:xfrm>
+            <a:off x="731520" y="1645920"/>
+            <a:ext cx="5303520" cy="4389120"/>
+          </a:xfrm>
+          <a:prstGeom prst="rect">
+            <a:avLst/>
+          </a:prstGeom>
+          <a:noFill/>
+        </p:spPr>
+        <p:txBody>
+          <a:bodyPr wrap="square">
+            <a:spAutoFit/>
+          </a:bodyPr>
+          <a:lstStyle/>
+          <a:p>
+            <a:pPr>
+              <a:spcAft>
+                <a:spcPts val="1600"/>
+              </a:spcAft>
+              <a:defRPr sz="1700">
+                <a:solidFill>
+                  <a:srgbClr val="F8FAFC"/>
+                </a:solidFill>
+              </a:defRPr>
+            </a:pPr>
+            <a:r>
+              <a:t>•  Évaluation des progrès</a:t>
+            </a:r>
+          </a:p>
+          <a:p>
+            <a:pPr>
+              <a:spcAft>
+                <a:spcPts val="1600"/>
+              </a:spcAft>
+              <a:defRPr sz="1700">
+                <a:solidFill>
+                  <a:srgbClr val="F8FAFC"/>
+                </a:solidFill>
+              </a:defRPr>
+            </a:pPr>
+            <a:r>
+              <a:t>•  Engagement à long terme</a:t>
+            </a:r>
+          </a:p>
+        </p:txBody>
+      </p:sp>
+      <p:pic>
+        <p:nvPicPr>
+          <p:cNvPr id="4" name="Picture 3" descr="slide_keyframe_06.jpg"/>
+          <p:cNvPicPr>
+            <a:picLocks noChangeAspect="1"/>
+          </p:cNvPicPr>
+          <p:nvPr/>
+        </p:nvPicPr>
+        <p:blipFill>
+          <a:blip r:embed="rId2"/>
+          <a:stretch>
+            <a:fillRect/>
+          </a:stretch>
+        </p:blipFill>
+        <p:spPr>
+          <a:xfrm>
+            <a:off x="6400800" y="1645920"/>
+            <a:ext cx="5029200" cy="2826717"/>
+          </a:xfrm>
+          <a:prstGeom prst="rect">
+            <a:avLst/>
+          </a:prstGeom>
+        </p:spPr>
+      </p:pic>
+    </p:spTree>
+  </p:cSld>
+  <p:clrMapOvr>
+    <a:masterClrMapping/>
+  </p:clrMapOvr>
+</p:sld>
+</file>
+
+<file path=ppt/slides/slide8.xml><?xml version="1.0" encoding="utf-8"?>
+<p:sld xmlns:a="http://schemas.openxmlformats.org/drawingml/2006/main" xmlns:p="http://schemas.openxmlformats.org/presentationml/2006/main" xmlns:r="http://schemas.openxmlformats.org/officeDocument/2006/relationships">
+  <p:cSld>
+    <p:bg>
+      <p:bgPr>
+        <a:solidFill>
+          <a:srgbClr val="0F172A"/>
+        </a:solidFill>
+        <a:effectLst/>
+      </p:bgPr>
+    </p:bg>
+    <p:spTree>
+      <p:nvGrpSpPr>
+        <p:cNvPr id="1" name=""/>
+        <p:cNvGrpSpPr/>
+        <p:nvPr/>
+      </p:nvGrpSpPr>
+      <p:grpSpPr/>
+      <p:sp>
+        <p:nvSpPr>
+          <p:cNvPr id="2" name="TextBox 1"/>
+          <p:cNvSpPr txBox="1"/>
+          <p:nvPr/>
+        </p:nvSpPr>
+        <p:spPr>
+          <a:xfrm>
+            <a:off x="731520" y="457200"/>
+            <a:ext cx="10698480" cy="914400"/>
+          </a:xfrm>
+          <a:prstGeom prst="rect">
+            <a:avLst/>
+          </a:prstGeom>
+          <a:noFill/>
+        </p:spPr>
+        <p:txBody>
+          <a:bodyPr wrap="none">
+            <a:spAutoFit/>
+          </a:bodyPr>
+          <a:lstStyle/>
+          <a:p>
+            <a:pPr>
+              <a:defRPr sz="2800" b="1">
+                <a:solidFill>
+                  <a:srgbClr val="38BDF8"/>
+                </a:solidFill>
+              </a:defRPr>
+            </a:pPr>
+            <a:r>
+              <a:t>Synthèse des Stratégies</a:t>
+            </a:r>
+          </a:p>
+        </p:txBody>
+      </p:sp>
+      <p:sp>
+        <p:nvSpPr>
+          <p:cNvPr id="3" name="TextBox 2"/>
+          <p:cNvSpPr txBox="1"/>
+          <p:nvPr/>
+        </p:nvSpPr>
+        <p:spPr>
+          <a:xfrm>
+            <a:off x="731520" y="1645920"/>
+            <a:ext cx="5303520" cy="4389120"/>
+          </a:xfrm>
+          <a:prstGeom prst="rect">
+            <a:avLst/>
+          </a:prstGeom>
+          <a:noFill/>
+        </p:spPr>
+        <p:txBody>
+          <a:bodyPr wrap="square">
+            <a:spAutoFit/>
+          </a:bodyPr>
+          <a:lstStyle/>
+          <a:p>
+            <a:pPr>
+              <a:spcAft>
+                <a:spcPts val="1600"/>
+              </a:spcAft>
+              <a:defRPr sz="1700">
+                <a:solidFill>
+                  <a:srgbClr val="F8FAFC"/>
+                </a:solidFill>
+              </a:defRPr>
+            </a:pPr>
+            <a:r>
+              <a:t>•  Silence, Rêves, Lâcher Prise</a:t>
+            </a:r>
+          </a:p>
+          <a:p>
+            <a:pPr>
+              <a:spcAft>
+                <a:spcPts val="1600"/>
+              </a:spcAft>
+              <a:defRPr sz="1700">
+                <a:solidFill>
+                  <a:srgbClr val="F8FAFC"/>
+                </a:solidFill>
+              </a:defRPr>
+            </a:pPr>
+            <a:r>
+              <a:t>•  Importance de l'expérimentation</a:t>
+            </a:r>
+          </a:p>
+        </p:txBody>
+      </p:sp>
+      <p:pic>
+        <p:nvPicPr>
+          <p:cNvPr id="4" name="Picture 3" descr="slide_keyframe_07.jpg"/>
+          <p:cNvPicPr>
+            <a:picLocks noChangeAspect="1"/>
+          </p:cNvPicPr>
+          <p:nvPr/>
+        </p:nvPicPr>
+        <p:blipFill>
+          <a:blip r:embed="rId2"/>
+          <a:stretch>
+            <a:fillRect/>
+          </a:stretch>
+        </p:blipFill>
+        <p:spPr>
+          <a:xfrm>
+            <a:off x="6400800" y="1645920"/>
+            <a:ext cx="5029200" cy="2826717"/>
+          </a:xfrm>
+          <a:prstGeom prst="rect">
+            <a:avLst/>
+          </a:prstGeom>
+        </p:spPr>
+      </p:pic>
+    </p:spTree>
+  </p:cSld>
+  <p:clrMapOvr>
+    <a:masterClrMapping/>
+  </p:clrMapOvr>
+</p:sld>
+</file>
+
+<file path=ppt/slides/slide9.xml><?xml version="1.0" encoding="utf-8"?>
+<p:sld xmlns:a="http://schemas.openxmlformats.org/drawingml/2006/main" xmlns:p="http://schemas.openxmlformats.org/presentationml/2006/main" xmlns:r="http://schemas.openxmlformats.org/officeDocument/2006/relationships">
+  <p:cSld>
+    <p:bg>
+      <p:bgPr>
+        <a:solidFill>
+          <a:srgbClr val="0F172A"/>
+        </a:solidFill>
+        <a:effectLst/>
+      </p:bgPr>
+    </p:bg>
+    <p:spTree>
+      <p:nvGrpSpPr>
+        <p:cNvPr id="1" name=""/>
+        <p:cNvGrpSpPr/>
+        <p:nvPr/>
+      </p:nvGrpSpPr>
+      <p:grpSpPr/>
+      <p:sp>
+        <p:nvSpPr>
+          <p:cNvPr id="2" name="TextBox 1"/>
+          <p:cNvSpPr txBox="1"/>
+          <p:nvPr/>
+        </p:nvSpPr>
+        <p:spPr>
+          <a:xfrm>
+            <a:off x="731520" y="457200"/>
+            <a:ext cx="10698480" cy="914400"/>
+          </a:xfrm>
+          <a:prstGeom prst="rect">
+            <a:avLst/>
+          </a:prstGeom>
+          <a:noFill/>
+        </p:spPr>
+        <p:txBody>
+          <a:bodyPr wrap="none">
+            <a:spAutoFit/>
+          </a:bodyPr>
+          <a:lstStyle/>
+          <a:p>
+            <a:pPr>
+              <a:defRPr sz="2800" b="1">
+                <a:solidFill>
+                  <a:srgbClr val="38BDF8"/>
+                </a:solidFill>
+              </a:defRPr>
+            </a:pPr>
+            <a:r>
+              <a:t>Impact sur la Créativité</a:t>
+            </a:r>
+          </a:p>
+        </p:txBody>
+      </p:sp>
+      <p:sp>
+        <p:nvSpPr>
+          <p:cNvPr id="3" name="TextBox 2"/>
+          <p:cNvSpPr txBox="1"/>
+          <p:nvPr/>
+        </p:nvSpPr>
+        <p:spPr>
+          <a:xfrm>
+            <a:off x="731520" y="1645920"/>
+            <a:ext cx="5303520" cy="4389120"/>
+          </a:xfrm>
+          <a:prstGeom prst="rect">
+            <a:avLst/>
+          </a:prstGeom>
+          <a:noFill/>
+        </p:spPr>
+        <p:txBody>
+          <a:bodyPr wrap="square">
+            <a:spAutoFit/>
+          </a:bodyPr>
+          <a:lstStyle/>
+          <a:p>
+            <a:pPr>
+              <a:spcAft>
+                <a:spcPts val="1600"/>
+              </a:spcAft>
+              <a:defRPr sz="1700">
+                <a:solidFill>
+                  <a:srgbClr val="F8FAFC"/>
+                </a:solidFill>
+              </a:defRPr>
+            </a:pPr>
+            <a:r>
+              <a:t>•  Amélioration de l'innovation</a:t>
+            </a:r>
+          </a:p>
+          <a:p>
+            <a:pPr>
+              <a:spcAft>
+                <a:spcPts val="1600"/>
+              </a:spcAft>
+              <a:defRPr sz="1700">
+                <a:solidFill>
+                  <a:srgbClr val="F8FAFC"/>
+                </a:solidFill>
+              </a:defRPr>
+            </a:pPr>
+            <a:r>
+              <a:t>•  Réduction du stress créatif</a:t>
+            </a:r>
+          </a:p>
+        </p:txBody>
+      </p:sp>
+      <p:pic>
+        <p:nvPicPr>
+          <p:cNvPr id="4" name="Picture 3" descr="slide_keyframe_08.jpg"/>
           <p:cNvPicPr>
             <a:picLocks noChangeAspect="1"/>
           </p:cNvPicPr>

</xml_diff>

<commit_message>
feat(finops): module d evaluation des couts, support utf-8 natif et 23 tests automatises
</commit_message>
<xml_diff>
--- a/demo/output/presentation.pptx
+++ b/demo/output/presentation.pptx
@@ -3150,7 +3150,7 @@
               </a:defRPr>
             </a:pPr>
             <a:r>
-              <a:t>Session animée par Zoe Hames</a:t>
+              <a:t>Session sur les Stratégies Créatives avec Zoe Hames</a:t>
             </a:r>
           </a:p>
         </p:txBody>
@@ -3249,7 +3249,7 @@
               </a:defRPr>
             </a:pPr>
             <a:r>
-              <a:t>•  Discussion ouverte</a:t>
+              <a:t>•  Ouverture aux questions</a:t>
             </a:r>
           </a:p>
           <a:p>
@@ -3264,7 +3264,7 @@
               </a:defRPr>
             </a:pPr>
             <a:r>
-              <a:t>•  Partage d'expériences</a:t>
+              <a:t>•  Partage d'expériences personnelles</a:t>
             </a:r>
           </a:p>
         </p:txBody>
@@ -3387,7 +3387,7 @@
               </a:defRPr>
             </a:pPr>
             <a:r>
-              <a:t>•  Saturation d'informations</a:t>
+              <a:t>•  L'impact des distractions sur la créativité</a:t>
             </a:r>
           </a:p>
           <a:p>
@@ -3402,7 +3402,7 @@
               </a:defRPr>
             </a:pPr>
             <a:r>
-              <a:t>•  Impact sur la créativité</a:t>
+              <a:t>•  Nécessité de trouver des moments de calme</a:t>
             </a:r>
           </a:p>
           <a:p>
@@ -3417,7 +3417,7 @@
               </a:defRPr>
             </a:pPr>
             <a:r>
-              <a:t>•  Nécessité de stratégies adaptées</a:t>
+              <a:t>•  Importance de la reconnexion à soi</a:t>
             </a:r>
           </a:p>
         </p:txBody>
@@ -3502,7 +3502,7 @@
               </a:defRPr>
             </a:pPr>
             <a:r>
-              <a:t>Importance du Silence</a:t>
+              <a:t>Importance du Calme dans un Monde Distrayant</a:t>
             </a:r>
           </a:p>
         </p:txBody>
@@ -3540,7 +3540,7 @@
               </a:defRPr>
             </a:pPr>
             <a:r>
-              <a:t>•  Moments de déconnexion</a:t>
+              <a:t>•  Carver du temps quotidien pour le silence</a:t>
             </a:r>
           </a:p>
           <a:p>
@@ -3555,7 +3555,7 @@
               </a:defRPr>
             </a:pPr>
             <a:r>
-              <a:t>•  Espace pour la réflexion</a:t>
+              <a:t>•  Pratiquer des activités en pleine nature</a:t>
             </a:r>
           </a:p>
         </p:txBody>
@@ -3640,7 +3640,7 @@
               </a:defRPr>
             </a:pPr>
             <a:r>
-              <a:t>Explorer le Pouvoir des Rêves</a:t>
+              <a:t>Exploiter le Pouvoir des Rêves</a:t>
             </a:r>
           </a:p>
         </p:txBody>
@@ -3678,7 +3678,7 @@
               </a:defRPr>
             </a:pPr>
             <a:r>
-              <a:t>•  Pensée libre</a:t>
+              <a:t>•  Accorder du temps à des activités ludiques</a:t>
             </a:r>
           </a:p>
           <a:p>
@@ -3693,7 +3693,7 @@
               </a:defRPr>
             </a:pPr>
             <a:r>
-              <a:t>•  Inspiration des rêves</a:t>
+              <a:t>•  Noter les idées sans autocensure</a:t>
             </a:r>
           </a:p>
         </p:txBody>
@@ -3778,7 +3778,7 @@
               </a:defRPr>
             </a:pPr>
             <a:r>
-              <a:t>Lâcher Prise pour Favoriser la Créativité</a:t>
+              <a:t>L'Art de Lâcher Prise</a:t>
             </a:r>
           </a:p>
         </p:txBody>
@@ -3816,7 +3816,7 @@
               </a:defRPr>
             </a:pPr>
             <a:r>
-              <a:t>•  Accepter l'incertitude</a:t>
+              <a:t>•  Établir des limites claires pour éviter l'épuisement</a:t>
             </a:r>
           </a:p>
           <a:p>
@@ -3831,7 +3831,7 @@
               </a:defRPr>
             </a:pPr>
             <a:r>
-              <a:t>•  Prendre soin de soi</a:t>
+              <a:t>•  S'accorder des pauses régulières</a:t>
             </a:r>
           </a:p>
         </p:txBody>
@@ -3954,7 +3954,7 @@
               </a:defRPr>
             </a:pPr>
             <a:r>
-              <a:t>•  Rituels de déconnexion</a:t>
+              <a:t>•  Méditation quotidienne</a:t>
             </a:r>
           </a:p>
           <a:p>
@@ -3969,7 +3969,7 @@
               </a:defRPr>
             </a:pPr>
             <a:r>
-              <a:t>•  Activités artistiques</a:t>
+              <a:t>•  Balades en pleine nature</a:t>
             </a:r>
           </a:p>
         </p:txBody>
@@ -4092,7 +4092,7 @@
               </a:defRPr>
             </a:pPr>
             <a:r>
-              <a:t>•  Évaluation des progrès</a:t>
+              <a:t>•  Mettre en pratique ces stratégies régulièrement</a:t>
             </a:r>
           </a:p>
           <a:p>
@@ -4107,7 +4107,7 @@
               </a:defRPr>
             </a:pPr>
             <a:r>
-              <a:t>•  Engagement à long terme</a:t>
+              <a:t>•  S'engager dans un processus d'apprentissage continu</a:t>
             </a:r>
           </a:p>
         </p:txBody>
@@ -4230,7 +4230,7 @@
               </a:defRPr>
             </a:pPr>
             <a:r>
-              <a:t>•  Silence, Rêves, Lâcher Prise</a:t>
+              <a:t>•  Trouver le calme pour favoriser l'inspiration</a:t>
             </a:r>
           </a:p>
           <a:p>
@@ -4245,7 +4245,7 @@
               </a:defRPr>
             </a:pPr>
             <a:r>
-              <a:t>•  Importance de l'expérimentation</a:t>
+              <a:t>•  Exploiter les rêves pour libérer l'imagination</a:t>
             </a:r>
           </a:p>
         </p:txBody>
@@ -4330,7 +4330,7 @@
               </a:defRPr>
             </a:pPr>
             <a:r>
-              <a:t>Impact sur la Créativité</a:t>
+              <a:t>Engagement vers la Créativité</a:t>
             </a:r>
           </a:p>
         </p:txBody>
@@ -4368,7 +4368,7 @@
               </a:defRPr>
             </a:pPr>
             <a:r>
-              <a:t>•  Amélioration de l'innovation</a:t>
+              <a:t>•  Encourager l'expérimentation</a:t>
             </a:r>
           </a:p>
           <a:p>
@@ -4383,7 +4383,7 @@
               </a:defRPr>
             </a:pPr>
             <a:r>
-              <a:t>•  Réduction du stress créatif</a:t>
+              <a:t>•  Accepter les erreurs comme partie du processus</a:t>
             </a:r>
           </a:p>
         </p:txBody>

</xml_diff>

<commit_message>
fix(cli): correction de l'import tqdm au niveau global, assainissement des fichiers bat et mise a jour de la commande registre Windows
</commit_message>
<xml_diff>
--- a/demo/output/presentation.pptx
+++ b/demo/output/presentation.pptx
@@ -6,15 +6,15 @@
   </p:sldMasterIdLst>
   <p:sldIdLst>
     <p:sldId id="256" r:id="rId7"/>
-    <p:sldId id="257" r:id="rId8"/>
-    <p:sldId id="258" r:id="rId9"/>
-    <p:sldId id="259" r:id="rId10"/>
-    <p:sldId id="260" r:id="rId11"/>
-    <p:sldId id="261" r:id="rId12"/>
-    <p:sldId id="262" r:id="rId13"/>
-    <p:sldId id="263" r:id="rId14"/>
-    <p:sldId id="264" r:id="rId15"/>
-    <p:sldId id="265" r:id="rId16"/>
+    <p:sldId id="257" r:id="rId9"/>
+    <p:sldId id="258" r:id="rId10"/>
+    <p:sldId id="259" r:id="rId11"/>
+    <p:sldId id="260" r:id="rId12"/>
+    <p:sldId id="261" r:id="rId13"/>
+    <p:sldId id="262" r:id="rId14"/>
+    <p:sldId id="263" r:id="rId15"/>
+    <p:sldId id="264" r:id="rId16"/>
+    <p:sldId id="265" r:id="rId17"/>
   </p:sldIdLst>
   <p:sldSz cx="12191695" cy="6858000" type="screen4x3"/>
   <p:notesSz cx="6858000" cy="9144000"/>
@@ -114,6 +114,1056 @@
     </a:lvl9pPr>
   </p:defaultTextStyle>
 </p:presentation>
+</file>
+
+<file path=ppt/notesMasters/notesMaster1.xml><?xml version="1.0" encoding="utf-8"?>
+<p:notesMaster xmlns:a="http://schemas.openxmlformats.org/drawingml/2006/main" xmlns:p="http://schemas.openxmlformats.org/presentationml/2006/main" xmlns:r="http://schemas.openxmlformats.org/officeDocument/2006/relationships">
+  <p:cSld>
+    <p:bg>
+      <p:bgRef idx="1001">
+        <a:schemeClr val="bg1"/>
+      </p:bgRef>
+    </p:bg>
+    <p:spTree>
+      <p:nvGrpSpPr>
+        <p:cNvPr id="1" name=""/>
+        <p:cNvGrpSpPr/>
+        <p:nvPr/>
+      </p:nvGrpSpPr>
+      <p:grpSpPr>
+        <a:xfrm>
+          <a:off x="0" y="0"/>
+          <a:ext cx="0" cy="0"/>
+          <a:chOff x="0" y="0"/>
+          <a:chExt cx="0" cy="0"/>
+        </a:xfrm>
+      </p:grpSpPr>
+      <p:sp>
+        <p:nvSpPr>
+          <p:cNvPr id="2" name="Header Placeholder 1"/>
+          <p:cNvSpPr>
+            <a:spLocks noGrp="1"/>
+          </p:cNvSpPr>
+          <p:nvPr>
+            <p:ph type="hdr" sz="quarter"/>
+          </p:nvPr>
+        </p:nvSpPr>
+        <p:spPr>
+          <a:xfrm>
+            <a:off x="0" y="0"/>
+            <a:ext cx="2971800" cy="457200"/>
+          </a:xfrm>
+          <a:prstGeom prst="rect">
+            <a:avLst/>
+          </a:prstGeom>
+        </p:spPr>
+        <p:txBody>
+          <a:bodyPr vert="horz" lIns="91440" tIns="45720" rIns="91440" bIns="45720" rtlCol="0"/>
+          <a:lstStyle>
+            <a:lvl1pPr algn="l">
+              <a:defRPr sz="1200"/>
+            </a:lvl1pPr>
+          </a:lstStyle>
+          <a:p>
+            <a:endParaRPr lang="en-US"/>
+          </a:p>
+        </p:txBody>
+      </p:sp>
+      <p:sp>
+        <p:nvSpPr>
+          <p:cNvPr id="3" name="Date Placeholder 2"/>
+          <p:cNvSpPr>
+            <a:spLocks noGrp="1"/>
+          </p:cNvSpPr>
+          <p:nvPr>
+            <p:ph type="dt" idx="1"/>
+          </p:nvPr>
+        </p:nvSpPr>
+        <p:spPr>
+          <a:xfrm>
+            <a:off x="3884613" y="0"/>
+            <a:ext cx="2971800" cy="457200"/>
+          </a:xfrm>
+          <a:prstGeom prst="rect">
+            <a:avLst/>
+          </a:prstGeom>
+        </p:spPr>
+        <p:txBody>
+          <a:bodyPr vert="horz" lIns="91440" tIns="45720" rIns="91440" bIns="45720" rtlCol="0"/>
+          <a:lstStyle>
+            <a:lvl1pPr algn="r">
+              <a:defRPr sz="1200"/>
+            </a:lvl1pPr>
+          </a:lstStyle>
+          <a:p>
+            <a:fld id="{0F89C1C7-3DCD-1040-A9CF-14679D8B5DDD}" type="datetimeFigureOut">
+              <a:rPr lang="en-US" smtClean="0"/>
+              <a:t>10/17/16</a:t>
+            </a:fld>
+            <a:endParaRPr lang="en-US"/>
+          </a:p>
+        </p:txBody>
+      </p:sp>
+      <p:sp>
+        <p:nvSpPr>
+          <p:cNvPr id="4" name="Slide Image Placeholder 3"/>
+          <p:cNvSpPr>
+            <a:spLocks noGrp="1" noRot="1" noChangeAspect="1"/>
+          </p:cNvSpPr>
+          <p:nvPr>
+            <p:ph type="sldImg" idx="2"/>
+          </p:nvPr>
+        </p:nvSpPr>
+        <p:spPr>
+          <a:xfrm>
+            <a:off x="1143000" y="685800"/>
+            <a:ext cx="4572000" cy="3429000"/>
+          </a:xfrm>
+          <a:prstGeom prst="rect">
+            <a:avLst/>
+          </a:prstGeom>
+          <a:noFill/>
+          <a:ln w="12700">
+            <a:solidFill>
+              <a:prstClr val="black"/>
+            </a:solidFill>
+          </a:ln>
+        </p:spPr>
+        <p:txBody>
+          <a:bodyPr vert="horz" lIns="91440" tIns="45720" rIns="91440" bIns="45720" rtlCol="0" anchor="ctr"/>
+          <a:lstStyle/>
+          <a:p>
+            <a:endParaRPr lang="en-US"/>
+          </a:p>
+        </p:txBody>
+      </p:sp>
+      <p:sp>
+        <p:nvSpPr>
+          <p:cNvPr id="5" name="Notes Placeholder 4"/>
+          <p:cNvSpPr>
+            <a:spLocks noGrp="1"/>
+          </p:cNvSpPr>
+          <p:nvPr>
+            <p:ph type="body" sz="quarter" idx="3"/>
+          </p:nvPr>
+        </p:nvSpPr>
+        <p:spPr>
+          <a:xfrm>
+            <a:off x="685800" y="4343400"/>
+            <a:ext cx="5486400" cy="4114800"/>
+          </a:xfrm>
+          <a:prstGeom prst="rect">
+            <a:avLst/>
+          </a:prstGeom>
+        </p:spPr>
+        <p:txBody>
+          <a:bodyPr vert="horz" lIns="91440" tIns="45720" rIns="91440" bIns="45720" rtlCol="0"/>
+          <a:lstStyle/>
+          <a:p>
+            <a:pPr lvl="0"/>
+            <a:r>
+              <a:rPr lang="en-US" smtClean="0"/>
+              <a:t>Click to edit Master text styles</a:t>
+            </a:r>
+          </a:p>
+          <a:p>
+            <a:pPr lvl="1"/>
+            <a:r>
+              <a:rPr lang="en-US" smtClean="0"/>
+              <a:t>Second level</a:t>
+            </a:r>
+          </a:p>
+          <a:p>
+            <a:pPr lvl="2"/>
+            <a:r>
+              <a:rPr lang="en-US" smtClean="0"/>
+              <a:t>Third level</a:t>
+            </a:r>
+          </a:p>
+          <a:p>
+            <a:pPr lvl="3"/>
+            <a:r>
+              <a:rPr lang="en-US" smtClean="0"/>
+              <a:t>Fourth level</a:t>
+            </a:r>
+          </a:p>
+          <a:p>
+            <a:pPr lvl="4"/>
+            <a:r>
+              <a:rPr lang="en-US" smtClean="0"/>
+              <a:t>Fifth level</a:t>
+            </a:r>
+            <a:endParaRPr lang="en-US"/>
+          </a:p>
+        </p:txBody>
+      </p:sp>
+      <p:sp>
+        <p:nvSpPr>
+          <p:cNvPr id="6" name="Footer Placeholder 5"/>
+          <p:cNvSpPr>
+            <a:spLocks noGrp="1"/>
+          </p:cNvSpPr>
+          <p:nvPr>
+            <p:ph type="ftr" sz="quarter" idx="4"/>
+          </p:nvPr>
+        </p:nvSpPr>
+        <p:spPr>
+          <a:xfrm>
+            <a:off x="0" y="8685213"/>
+            <a:ext cx="2971800" cy="457200"/>
+          </a:xfrm>
+          <a:prstGeom prst="rect">
+            <a:avLst/>
+          </a:prstGeom>
+        </p:spPr>
+        <p:txBody>
+          <a:bodyPr vert="horz" lIns="91440" tIns="45720" rIns="91440" bIns="45720" rtlCol="0" anchor="b"/>
+          <a:lstStyle>
+            <a:lvl1pPr algn="l">
+              <a:defRPr sz="1200"/>
+            </a:lvl1pPr>
+          </a:lstStyle>
+          <a:p>
+            <a:endParaRPr lang="en-US"/>
+          </a:p>
+        </p:txBody>
+      </p:sp>
+      <p:sp>
+        <p:nvSpPr>
+          <p:cNvPr id="7" name="Slide Number Placeholder 6"/>
+          <p:cNvSpPr>
+            <a:spLocks noGrp="1"/>
+          </p:cNvSpPr>
+          <p:nvPr>
+            <p:ph type="sldNum" sz="quarter" idx="5"/>
+          </p:nvPr>
+        </p:nvSpPr>
+        <p:spPr>
+          <a:xfrm>
+            <a:off x="3884613" y="8685213"/>
+            <a:ext cx="2971800" cy="457200"/>
+          </a:xfrm>
+          <a:prstGeom prst="rect">
+            <a:avLst/>
+          </a:prstGeom>
+        </p:spPr>
+        <p:txBody>
+          <a:bodyPr vert="horz" lIns="91440" tIns="45720" rIns="91440" bIns="45720" rtlCol="0" anchor="b"/>
+          <a:lstStyle>
+            <a:lvl1pPr algn="r">
+              <a:defRPr sz="1200"/>
+            </a:lvl1pPr>
+          </a:lstStyle>
+          <a:p>
+            <a:fld id="{BB5E49A5-4136-284D-997B-48E1D791AD67}" type="slidenum">
+              <a:rPr lang="en-US" smtClean="0"/>
+              <a:t>‹#›</a:t>
+            </a:fld>
+            <a:endParaRPr lang="en-US"/>
+          </a:p>
+        </p:txBody>
+      </p:sp>
+    </p:spTree>
+    <p:extLst>
+      <p:ext uri="{BB962C8B-B14F-4D97-AF65-F5344CB8AC3E}">
+        <p14:creationId xmlns:p14="http://schemas.microsoft.com/office/powerpoint/2010/main" val="2623252185"/>
+      </p:ext>
+    </p:extLst>
+  </p:cSld>
+  <p:clrMap bg1="lt1" tx1="dk1" bg2="lt2" tx2="dk2" accent1="accent1" accent2="accent2" accent3="accent3" accent4="accent4" accent5="accent5" accent6="accent6" hlink="hlink" folHlink="folHlink"/>
+  <p:notesStyle>
+    <a:lvl1pPr marL="0" algn="l" defTabSz="457200" rtl="0" eaLnBrk="1" latinLnBrk="0" hangingPunct="1">
+      <a:defRPr sz="1200" kern="1200">
+        <a:solidFill>
+          <a:schemeClr val="tx1"/>
+        </a:solidFill>
+        <a:latin typeface="+mn-lt"/>
+        <a:ea typeface="+mn-ea"/>
+        <a:cs typeface="+mn-cs"/>
+      </a:defRPr>
+    </a:lvl1pPr>
+    <a:lvl2pPr marL="457200" algn="l" defTabSz="457200" rtl="0" eaLnBrk="1" latinLnBrk="0" hangingPunct="1">
+      <a:defRPr sz="1200" kern="1200">
+        <a:solidFill>
+          <a:schemeClr val="tx1"/>
+        </a:solidFill>
+        <a:latin typeface="+mn-lt"/>
+        <a:ea typeface="+mn-ea"/>
+        <a:cs typeface="+mn-cs"/>
+      </a:defRPr>
+    </a:lvl2pPr>
+    <a:lvl3pPr marL="914400" algn="l" defTabSz="457200" rtl="0" eaLnBrk="1" latinLnBrk="0" hangingPunct="1">
+      <a:defRPr sz="1200" kern="1200">
+        <a:solidFill>
+          <a:schemeClr val="tx1"/>
+        </a:solidFill>
+        <a:latin typeface="+mn-lt"/>
+        <a:ea typeface="+mn-ea"/>
+        <a:cs typeface="+mn-cs"/>
+      </a:defRPr>
+    </a:lvl3pPr>
+    <a:lvl4pPr marL="1371600" algn="l" defTabSz="457200" rtl="0" eaLnBrk="1" latinLnBrk="0" hangingPunct="1">
+      <a:defRPr sz="1200" kern="1200">
+        <a:solidFill>
+          <a:schemeClr val="tx1"/>
+        </a:solidFill>
+        <a:latin typeface="+mn-lt"/>
+        <a:ea typeface="+mn-ea"/>
+        <a:cs typeface="+mn-cs"/>
+      </a:defRPr>
+    </a:lvl4pPr>
+    <a:lvl5pPr marL="1828800" algn="l" defTabSz="457200" rtl="0" eaLnBrk="1" latinLnBrk="0" hangingPunct="1">
+      <a:defRPr sz="1200" kern="1200">
+        <a:solidFill>
+          <a:schemeClr val="tx1"/>
+        </a:solidFill>
+        <a:latin typeface="+mn-lt"/>
+        <a:ea typeface="+mn-ea"/>
+        <a:cs typeface="+mn-cs"/>
+      </a:defRPr>
+    </a:lvl5pPr>
+    <a:lvl6pPr marL="2286000" algn="l" defTabSz="457200" rtl="0" eaLnBrk="1" latinLnBrk="0" hangingPunct="1">
+      <a:defRPr sz="1200" kern="1200">
+        <a:solidFill>
+          <a:schemeClr val="tx1"/>
+        </a:solidFill>
+        <a:latin typeface="+mn-lt"/>
+        <a:ea typeface="+mn-ea"/>
+        <a:cs typeface="+mn-cs"/>
+      </a:defRPr>
+    </a:lvl6pPr>
+    <a:lvl7pPr marL="2743200" algn="l" defTabSz="457200" rtl="0" eaLnBrk="1" latinLnBrk="0" hangingPunct="1">
+      <a:defRPr sz="1200" kern="1200">
+        <a:solidFill>
+          <a:schemeClr val="tx1"/>
+        </a:solidFill>
+        <a:latin typeface="+mn-lt"/>
+        <a:ea typeface="+mn-ea"/>
+        <a:cs typeface="+mn-cs"/>
+      </a:defRPr>
+    </a:lvl7pPr>
+    <a:lvl8pPr marL="3200400" algn="l" defTabSz="457200" rtl="0" eaLnBrk="1" latinLnBrk="0" hangingPunct="1">
+      <a:defRPr sz="1200" kern="1200">
+        <a:solidFill>
+          <a:schemeClr val="tx1"/>
+        </a:solidFill>
+        <a:latin typeface="+mn-lt"/>
+        <a:ea typeface="+mn-ea"/>
+        <a:cs typeface="+mn-cs"/>
+      </a:defRPr>
+    </a:lvl8pPr>
+    <a:lvl9pPr marL="3657600" algn="l" defTabSz="457200" rtl="0" eaLnBrk="1" latinLnBrk="0" hangingPunct="1">
+      <a:defRPr sz="1200" kern="1200">
+        <a:solidFill>
+          <a:schemeClr val="tx1"/>
+        </a:solidFill>
+        <a:latin typeface="+mn-lt"/>
+        <a:ea typeface="+mn-ea"/>
+        <a:cs typeface="+mn-cs"/>
+      </a:defRPr>
+    </a:lvl9pPr>
+  </p:notesStyle>
+</p:notesMaster>
+</file>
+
+<file path=ppt/notesSlides/notesSlide1.xml><?xml version="1.0" encoding="utf-8"?>
+<p:notes xmlns:a="http://schemas.openxmlformats.org/drawingml/2006/main" xmlns:p="http://schemas.openxmlformats.org/presentationml/2006/main" xmlns:r="http://schemas.openxmlformats.org/officeDocument/2006/relationships">
+  <p:cSld>
+    <p:spTree>
+      <p:nvGrpSpPr>
+        <p:cNvPr id="1" name=""/>
+        <p:cNvGrpSpPr/>
+        <p:nvPr/>
+      </p:nvGrpSpPr>
+      <p:grpSpPr>
+        <a:xfrm>
+          <a:off x="0" y="0"/>
+          <a:ext cx="0" cy="0"/>
+          <a:chOff x="0" y="0"/>
+          <a:chExt cx="0" cy="0"/>
+        </a:xfrm>
+      </p:grpSpPr>
+      <p:sp>
+        <p:nvSpPr>
+          <p:cNvPr id="2" name="Slide Image Placeholder 1"/>
+          <p:cNvSpPr>
+            <a:spLocks noGrp="1"/>
+          </p:cNvSpPr>
+          <p:nvPr>
+            <p:ph type="sldImg" idx="2"/>
+          </p:nvPr>
+        </p:nvSpPr>
+        <p:spPr/>
+      </p:sp>
+      <p:sp>
+        <p:nvSpPr>
+          <p:cNvPr id="3" name="Notes Placeholder 2"/>
+          <p:cNvSpPr>
+            <a:spLocks noGrp="1"/>
+          </p:cNvSpPr>
+          <p:nvPr>
+            <p:ph type="body" idx="3" sz="quarter"/>
+          </p:nvPr>
+        </p:nvSpPr>
+        <p:spPr/>
+        <p:txBody>
+          <a:bodyPr/>
+          <a:lstStyle/>
+          <a:p>
+            <a:r>
+              <a:t>Introduction de la présentation, cadrage du sujet et annonce des objectifs de la session.</a:t>
+            </a:r>
+          </a:p>
+        </p:txBody>
+      </p:sp>
+      <p:sp>
+        <p:nvSpPr>
+          <p:cNvPr id="4" name="Slide Number Placeholder 3"/>
+          <p:cNvSpPr>
+            <a:spLocks noGrp="1"/>
+          </p:cNvSpPr>
+          <p:nvPr>
+            <p:ph type="sldNum" idx="5" sz="quarter"/>
+          </p:nvPr>
+        </p:nvSpPr>
+        <p:spPr/>
+      </p:sp>
+    </p:spTree>
+  </p:cSld>
+  <p:clrMapOvr>
+    <a:masterClrMapping/>
+  </p:clrMapOvr>
+</p:notes>
+</file>
+
+<file path=ppt/notesSlides/notesSlide10.xml><?xml version="1.0" encoding="utf-8"?>
+<p:notes xmlns:a="http://schemas.openxmlformats.org/drawingml/2006/main" xmlns:p="http://schemas.openxmlformats.org/presentationml/2006/main" xmlns:r="http://schemas.openxmlformats.org/officeDocument/2006/relationships">
+  <p:cSld>
+    <p:spTree>
+      <p:nvGrpSpPr>
+        <p:cNvPr id="1" name=""/>
+        <p:cNvGrpSpPr/>
+        <p:nvPr/>
+      </p:nvGrpSpPr>
+      <p:grpSpPr>
+        <a:xfrm>
+          <a:off x="0" y="0"/>
+          <a:ext cx="0" cy="0"/>
+          <a:chOff x="0" y="0"/>
+          <a:chExt cx="0" cy="0"/>
+        </a:xfrm>
+      </p:grpSpPr>
+      <p:sp>
+        <p:nvSpPr>
+          <p:cNvPr id="2" name="Slide Image Placeholder 1"/>
+          <p:cNvSpPr>
+            <a:spLocks noGrp="1"/>
+          </p:cNvSpPr>
+          <p:nvPr>
+            <p:ph type="sldImg" idx="2"/>
+          </p:nvPr>
+        </p:nvSpPr>
+        <p:spPr/>
+      </p:sp>
+      <p:sp>
+        <p:nvSpPr>
+          <p:cNvPr id="3" name="Notes Placeholder 2"/>
+          <p:cNvSpPr>
+            <a:spLocks noGrp="1"/>
+          </p:cNvSpPr>
+          <p:nvPr>
+            <p:ph type="body" idx="3" sz="quarter"/>
+          </p:nvPr>
+        </p:nvSpPr>
+        <p:spPr/>
+        <p:txBody>
+          <a:bodyPr/>
+          <a:lstStyle/>
+          <a:p>
+            <a:r>
+              <a:t>Je vous invite maintenant à poser vos questions. C'est un moment pour échanger et clarifier les idées que nous avons abordées aujourd'hui.</a:t>
+            </a:r>
+          </a:p>
+        </p:txBody>
+      </p:sp>
+      <p:sp>
+        <p:nvSpPr>
+          <p:cNvPr id="4" name="Slide Number Placeholder 3"/>
+          <p:cNvSpPr>
+            <a:spLocks noGrp="1"/>
+          </p:cNvSpPr>
+          <p:nvPr>
+            <p:ph type="sldNum" idx="5" sz="quarter"/>
+          </p:nvPr>
+        </p:nvSpPr>
+        <p:spPr/>
+      </p:sp>
+    </p:spTree>
+  </p:cSld>
+  <p:clrMapOvr>
+    <a:masterClrMapping/>
+  </p:clrMapOvr>
+</p:notes>
+</file>
+
+<file path=ppt/notesSlides/notesSlide2.xml><?xml version="1.0" encoding="utf-8"?>
+<p:notes xmlns:a="http://schemas.openxmlformats.org/drawingml/2006/main" xmlns:p="http://schemas.openxmlformats.org/presentationml/2006/main" xmlns:r="http://schemas.openxmlformats.org/officeDocument/2006/relationships">
+  <p:cSld>
+    <p:spTree>
+      <p:nvGrpSpPr>
+        <p:cNvPr id="1" name=""/>
+        <p:cNvGrpSpPr/>
+        <p:nvPr/>
+      </p:nvGrpSpPr>
+      <p:grpSpPr>
+        <a:xfrm>
+          <a:off x="0" y="0"/>
+          <a:ext cx="0" cy="0"/>
+          <a:chOff x="0" y="0"/>
+          <a:chExt cx="0" cy="0"/>
+        </a:xfrm>
+      </p:grpSpPr>
+      <p:sp>
+        <p:nvSpPr>
+          <p:cNvPr id="2" name="Slide Image Placeholder 1"/>
+          <p:cNvSpPr>
+            <a:spLocks noGrp="1"/>
+          </p:cNvSpPr>
+          <p:nvPr>
+            <p:ph type="sldImg" idx="2"/>
+          </p:nvPr>
+        </p:nvSpPr>
+        <p:spPr/>
+      </p:sp>
+      <p:sp>
+        <p:nvSpPr>
+          <p:cNvPr id="3" name="Notes Placeholder 2"/>
+          <p:cNvSpPr>
+            <a:spLocks noGrp="1"/>
+          </p:cNvSpPr>
+          <p:nvPr>
+            <p:ph type="body" idx="3" sz="quarter"/>
+          </p:nvPr>
+        </p:nvSpPr>
+        <p:spPr/>
+        <p:txBody>
+          <a:bodyPr/>
+          <a:lstStyle/>
+          <a:p>
+            <a:r>
+              <a:t>il importe de créer des moments de silence dans nos vies professionnelles pour favoriser la créativité. Ces moments permettent au cerveau de se recharger et de faire des connexions nouvelles, essentielles pour l'innovation.</a:t>
+            </a:r>
+          </a:p>
+        </p:txBody>
+      </p:sp>
+      <p:sp>
+        <p:nvSpPr>
+          <p:cNvPr id="4" name="Slide Number Placeholder 3"/>
+          <p:cNvSpPr>
+            <a:spLocks noGrp="1"/>
+          </p:cNvSpPr>
+          <p:nvPr>
+            <p:ph type="sldNum" idx="5" sz="quarter"/>
+          </p:nvPr>
+        </p:nvSpPr>
+        <p:spPr/>
+      </p:sp>
+    </p:spTree>
+  </p:cSld>
+  <p:clrMapOvr>
+    <a:masterClrMapping/>
+  </p:clrMapOvr>
+</p:notes>
+</file>
+
+<file path=ppt/notesSlides/notesSlide3.xml><?xml version="1.0" encoding="utf-8"?>
+<p:notes xmlns:a="http://schemas.openxmlformats.org/drawingml/2006/main" xmlns:p="http://schemas.openxmlformats.org/presentationml/2006/main" xmlns:r="http://schemas.openxmlformats.org/officeDocument/2006/relationships">
+  <p:cSld>
+    <p:spTree>
+      <p:nvGrpSpPr>
+        <p:cNvPr id="1" name=""/>
+        <p:cNvGrpSpPr/>
+        <p:nvPr/>
+      </p:nvGrpSpPr>
+      <p:grpSpPr>
+        <a:xfrm>
+          <a:off x="0" y="0"/>
+          <a:ext cx="0" cy="0"/>
+          <a:chOff x="0" y="0"/>
+          <a:chExt cx="0" cy="0"/>
+        </a:xfrm>
+      </p:grpSpPr>
+      <p:sp>
+        <p:nvSpPr>
+          <p:cNvPr id="2" name="Slide Image Placeholder 1"/>
+          <p:cNvSpPr>
+            <a:spLocks noGrp="1"/>
+          </p:cNvSpPr>
+          <p:nvPr>
+            <p:ph type="sldImg" idx="2"/>
+          </p:nvPr>
+        </p:nvSpPr>
+        <p:spPr/>
+      </p:sp>
+      <p:sp>
+        <p:nvSpPr>
+          <p:cNvPr id="3" name="Notes Placeholder 2"/>
+          <p:cNvSpPr>
+            <a:spLocks noGrp="1"/>
+          </p:cNvSpPr>
+          <p:nvPr>
+            <p:ph type="body" idx="3" sz="quarter"/>
+          </p:nvPr>
+        </p:nvSpPr>
+        <p:spPr/>
+        <p:txBody>
+          <a:bodyPr/>
+          <a:lstStyle/>
+          <a:p>
+            <a:r>
+              <a:t>Se reconnecter à l'énergie des rêves permet d'explorer des idées sans limites. Encourager les équipes à exprimer des idées, même les plus farfelues, ouvre la porte à des solutions innovantes.</a:t>
+            </a:r>
+          </a:p>
+        </p:txBody>
+      </p:sp>
+      <p:sp>
+        <p:nvSpPr>
+          <p:cNvPr id="4" name="Slide Number Placeholder 3"/>
+          <p:cNvSpPr>
+            <a:spLocks noGrp="1"/>
+          </p:cNvSpPr>
+          <p:nvPr>
+            <p:ph type="sldNum" idx="5" sz="quarter"/>
+          </p:nvPr>
+        </p:nvSpPr>
+        <p:spPr/>
+      </p:sp>
+    </p:spTree>
+  </p:cSld>
+  <p:clrMapOvr>
+    <a:masterClrMapping/>
+  </p:clrMapOvr>
+</p:notes>
+</file>
+
+<file path=ppt/notesSlides/notesSlide4.xml><?xml version="1.0" encoding="utf-8"?>
+<p:notes xmlns:a="http://schemas.openxmlformats.org/drawingml/2006/main" xmlns:p="http://schemas.openxmlformats.org/presentationml/2006/main" xmlns:r="http://schemas.openxmlformats.org/officeDocument/2006/relationships">
+  <p:cSld>
+    <p:spTree>
+      <p:nvGrpSpPr>
+        <p:cNvPr id="1" name=""/>
+        <p:cNvGrpSpPr/>
+        <p:nvPr/>
+      </p:nvGrpSpPr>
+      <p:grpSpPr>
+        <a:xfrm>
+          <a:off x="0" y="0"/>
+          <a:ext cx="0" cy="0"/>
+          <a:chOff x="0" y="0"/>
+          <a:chExt cx="0" cy="0"/>
+        </a:xfrm>
+      </p:grpSpPr>
+      <p:sp>
+        <p:nvSpPr>
+          <p:cNvPr id="2" name="Slide Image Placeholder 1"/>
+          <p:cNvSpPr>
+            <a:spLocks noGrp="1"/>
+          </p:cNvSpPr>
+          <p:nvPr>
+            <p:ph type="sldImg" idx="2"/>
+          </p:nvPr>
+        </p:nvSpPr>
+        <p:spPr/>
+      </p:sp>
+      <p:sp>
+        <p:nvSpPr>
+          <p:cNvPr id="3" name="Notes Placeholder 2"/>
+          <p:cNvSpPr>
+            <a:spLocks noGrp="1"/>
+          </p:cNvSpPr>
+          <p:nvPr>
+            <p:ph type="body" idx="3" sz="quarter"/>
+          </p:nvPr>
+        </p:nvSpPr>
+        <p:spPr/>
+        <p:txBody>
+          <a:bodyPr/>
+          <a:lstStyle/>
+          <a:p>
+            <a:r>
+              <a:t>Apprendre à relâcher le contrôle est essentiel pour stimuler la créativité. Cela permet aux idées de circuler librement sans la contrainte de la perfection.</a:t>
+            </a:r>
+          </a:p>
+        </p:txBody>
+      </p:sp>
+      <p:sp>
+        <p:nvSpPr>
+          <p:cNvPr id="4" name="Slide Number Placeholder 3"/>
+          <p:cNvSpPr>
+            <a:spLocks noGrp="1"/>
+          </p:cNvSpPr>
+          <p:nvPr>
+            <p:ph type="sldNum" idx="5" sz="quarter"/>
+          </p:nvPr>
+        </p:nvSpPr>
+        <p:spPr/>
+      </p:sp>
+    </p:spTree>
+  </p:cSld>
+  <p:clrMapOvr>
+    <a:masterClrMapping/>
+  </p:clrMapOvr>
+</p:notes>
+</file>
+
+<file path=ppt/notesSlides/notesSlide5.xml><?xml version="1.0" encoding="utf-8"?>
+<p:notes xmlns:a="http://schemas.openxmlformats.org/drawingml/2006/main" xmlns:p="http://schemas.openxmlformats.org/presentationml/2006/main" xmlns:r="http://schemas.openxmlformats.org/officeDocument/2006/relationships">
+  <p:cSld>
+    <p:spTree>
+      <p:nvGrpSpPr>
+        <p:cNvPr id="1" name=""/>
+        <p:cNvGrpSpPr/>
+        <p:nvPr/>
+      </p:nvGrpSpPr>
+      <p:grpSpPr>
+        <a:xfrm>
+          <a:off x="0" y="0"/>
+          <a:ext cx="0" cy="0"/>
+          <a:chOff x="0" y="0"/>
+          <a:chExt cx="0" cy="0"/>
+        </a:xfrm>
+      </p:grpSpPr>
+      <p:sp>
+        <p:nvSpPr>
+          <p:cNvPr id="2" name="Slide Image Placeholder 1"/>
+          <p:cNvSpPr>
+            <a:spLocks noGrp="1"/>
+          </p:cNvSpPr>
+          <p:nvPr>
+            <p:ph type="sldImg" idx="2"/>
+          </p:nvPr>
+        </p:nvSpPr>
+        <p:spPr/>
+      </p:sp>
+      <p:sp>
+        <p:nvSpPr>
+          <p:cNvPr id="3" name="Notes Placeholder 2"/>
+          <p:cNvSpPr>
+            <a:spLocks noGrp="1"/>
+          </p:cNvSpPr>
+          <p:nvPr>
+            <p:ph type="body" idx="3" sz="quarter"/>
+          </p:nvPr>
+        </p:nvSpPr>
+        <p:spPr/>
+        <p:txBody>
+          <a:bodyPr/>
+          <a:lstStyle/>
+          <a:p>
+            <a:r>
+              <a:t>Pour que ces stratégies soient efficaces, il importe de les intégrer dans la culture d'entreprise. Cela nécessite un engagement de la part de la direction pour valoriser la créativité et le bien-être des employés.</a:t>
+            </a:r>
+          </a:p>
+        </p:txBody>
+      </p:sp>
+      <p:sp>
+        <p:nvSpPr>
+          <p:cNvPr id="4" name="Slide Number Placeholder 3"/>
+          <p:cNvSpPr>
+            <a:spLocks noGrp="1"/>
+          </p:cNvSpPr>
+          <p:nvPr>
+            <p:ph type="sldNum" idx="5" sz="quarter"/>
+          </p:nvPr>
+        </p:nvSpPr>
+        <p:spPr/>
+      </p:sp>
+    </p:spTree>
+  </p:cSld>
+  <p:clrMapOvr>
+    <a:masterClrMapping/>
+  </p:clrMapOvr>
+</p:notes>
+</file>
+
+<file path=ppt/notesSlides/notesSlide6.xml><?xml version="1.0" encoding="utf-8"?>
+<p:notes xmlns:a="http://schemas.openxmlformats.org/drawingml/2006/main" xmlns:p="http://schemas.openxmlformats.org/presentationml/2006/main" xmlns:r="http://schemas.openxmlformats.org/officeDocument/2006/relationships">
+  <p:cSld>
+    <p:spTree>
+      <p:nvGrpSpPr>
+        <p:cNvPr id="1" name=""/>
+        <p:cNvGrpSpPr/>
+        <p:nvPr/>
+      </p:nvGrpSpPr>
+      <p:grpSpPr>
+        <a:xfrm>
+          <a:off x="0" y="0"/>
+          <a:ext cx="0" cy="0"/>
+          <a:chOff x="0" y="0"/>
+          <a:chExt cx="0" cy="0"/>
+        </a:xfrm>
+      </p:grpSpPr>
+      <p:sp>
+        <p:nvSpPr>
+          <p:cNvPr id="2" name="Slide Image Placeholder 1"/>
+          <p:cNvSpPr>
+            <a:spLocks noGrp="1"/>
+          </p:cNvSpPr>
+          <p:nvPr>
+            <p:ph type="sldImg" idx="2"/>
+          </p:nvPr>
+        </p:nvSpPr>
+        <p:spPr/>
+      </p:sp>
+      <p:sp>
+        <p:nvSpPr>
+          <p:cNvPr id="3" name="Notes Placeholder 2"/>
+          <p:cNvSpPr>
+            <a:spLocks noGrp="1"/>
+          </p:cNvSpPr>
+          <p:nvPr>
+            <p:ph type="body" idx="3" sz="quarter"/>
+          </p:nvPr>
+        </p:nvSpPr>
+        <p:spPr/>
+        <p:txBody>
+          <a:bodyPr/>
+          <a:lstStyle/>
+          <a:p>
+            <a:r>
+              <a:t>Pour mesurer l'efficacité des stratégies mises en œuvre, il importe de définir des indicateurs de performance clairs. Cela permet d'ajuster les pratiques et d'identifier les domaines d'amélioration.</a:t>
+            </a:r>
+          </a:p>
+        </p:txBody>
+      </p:sp>
+      <p:sp>
+        <p:nvSpPr>
+          <p:cNvPr id="4" name="Slide Number Placeholder 3"/>
+          <p:cNvSpPr>
+            <a:spLocks noGrp="1"/>
+          </p:cNvSpPr>
+          <p:nvPr>
+            <p:ph type="sldNum" idx="5" sz="quarter"/>
+          </p:nvPr>
+        </p:nvSpPr>
+        <p:spPr/>
+      </p:sp>
+    </p:spTree>
+  </p:cSld>
+  <p:clrMapOvr>
+    <a:masterClrMapping/>
+  </p:clrMapOvr>
+</p:notes>
+</file>
+
+<file path=ppt/notesSlides/notesSlide7.xml><?xml version="1.0" encoding="utf-8"?>
+<p:notes xmlns:a="http://schemas.openxmlformats.org/drawingml/2006/main" xmlns:p="http://schemas.openxmlformats.org/presentationml/2006/main" xmlns:r="http://schemas.openxmlformats.org/officeDocument/2006/relationships">
+  <p:cSld>
+    <p:spTree>
+      <p:nvGrpSpPr>
+        <p:cNvPr id="1" name=""/>
+        <p:cNvGrpSpPr/>
+        <p:nvPr/>
+      </p:nvGrpSpPr>
+      <p:grpSpPr>
+        <a:xfrm>
+          <a:off x="0" y="0"/>
+          <a:ext cx="0" cy="0"/>
+          <a:chOff x="0" y="0"/>
+          <a:chExt cx="0" cy="0"/>
+        </a:xfrm>
+      </p:grpSpPr>
+      <p:sp>
+        <p:nvSpPr>
+          <p:cNvPr id="2" name="Slide Image Placeholder 1"/>
+          <p:cNvSpPr>
+            <a:spLocks noGrp="1"/>
+          </p:cNvSpPr>
+          <p:nvPr>
+            <p:ph type="sldImg" idx="2"/>
+          </p:nvPr>
+        </p:nvSpPr>
+        <p:spPr/>
+      </p:sp>
+      <p:sp>
+        <p:nvSpPr>
+          <p:cNvPr id="3" name="Notes Placeholder 2"/>
+          <p:cNvSpPr>
+            <a:spLocks noGrp="1"/>
+          </p:cNvSpPr>
+          <p:nvPr>
+            <p:ph type="body" idx="3" sz="quarter"/>
+          </p:nvPr>
+        </p:nvSpPr>
+        <p:spPr/>
+        <p:txBody>
+          <a:bodyPr/>
+          <a:lstStyle/>
+          <a:p>
+            <a:r>
+              <a:t>En conclusion, il est important de comprendre que la créativité est un voyage. En adoptant ces stratégies, nous pouvons encourager une culture d'expérimentation et d'innovation continue au sein de nos équipes.</a:t>
+            </a:r>
+          </a:p>
+        </p:txBody>
+      </p:sp>
+      <p:sp>
+        <p:nvSpPr>
+          <p:cNvPr id="4" name="Slide Number Placeholder 3"/>
+          <p:cNvSpPr>
+            <a:spLocks noGrp="1"/>
+          </p:cNvSpPr>
+          <p:nvPr>
+            <p:ph type="sldNum" idx="5" sz="quarter"/>
+          </p:nvPr>
+        </p:nvSpPr>
+        <p:spPr/>
+      </p:sp>
+    </p:spTree>
+  </p:cSld>
+  <p:clrMapOvr>
+    <a:masterClrMapping/>
+  </p:clrMapOvr>
+</p:notes>
+</file>
+
+<file path=ppt/notesSlides/notesSlide8.xml><?xml version="1.0" encoding="utf-8"?>
+<p:notes xmlns:a="http://schemas.openxmlformats.org/drawingml/2006/main" xmlns:p="http://schemas.openxmlformats.org/presentationml/2006/main" xmlns:r="http://schemas.openxmlformats.org/officeDocument/2006/relationships">
+  <p:cSld>
+    <p:spTree>
+      <p:nvGrpSpPr>
+        <p:cNvPr id="1" name=""/>
+        <p:cNvGrpSpPr/>
+        <p:nvPr/>
+      </p:nvGrpSpPr>
+      <p:grpSpPr>
+        <a:xfrm>
+          <a:off x="0" y="0"/>
+          <a:ext cx="0" cy="0"/>
+          <a:chOff x="0" y="0"/>
+          <a:chExt cx="0" cy="0"/>
+        </a:xfrm>
+      </p:grpSpPr>
+      <p:sp>
+        <p:nvSpPr>
+          <p:cNvPr id="2" name="Slide Image Placeholder 1"/>
+          <p:cNvSpPr>
+            <a:spLocks noGrp="1"/>
+          </p:cNvSpPr>
+          <p:nvPr>
+            <p:ph type="sldImg" idx="2"/>
+          </p:nvPr>
+        </p:nvSpPr>
+        <p:spPr/>
+      </p:sp>
+      <p:sp>
+        <p:nvSpPr>
+          <p:cNvPr id="3" name="Notes Placeholder 2"/>
+          <p:cNvSpPr>
+            <a:spLocks noGrp="1"/>
+          </p:cNvSpPr>
+          <p:nvPr>
+            <p:ph type="body" idx="3" sz="quarter"/>
+          </p:nvPr>
+        </p:nvSpPr>
+        <p:spPr/>
+        <p:txBody>
+          <a:bodyPr/>
+          <a:lstStyle/>
+          <a:p>
+            <a:r>
+              <a:t>Je vous encourage tous à mettre en pratique ces stratégies et à partager vos expériences. Ensemble, nous pouvons créer une communauté de soutien autour de la créativité au sein de notre organisation.</a:t>
+            </a:r>
+          </a:p>
+        </p:txBody>
+      </p:sp>
+      <p:sp>
+        <p:nvSpPr>
+          <p:cNvPr id="4" name="Slide Number Placeholder 3"/>
+          <p:cNvSpPr>
+            <a:spLocks noGrp="1"/>
+          </p:cNvSpPr>
+          <p:nvPr>
+            <p:ph type="sldNum" idx="5" sz="quarter"/>
+          </p:nvPr>
+        </p:nvSpPr>
+        <p:spPr/>
+      </p:sp>
+    </p:spTree>
+  </p:cSld>
+  <p:clrMapOvr>
+    <a:masterClrMapping/>
+  </p:clrMapOvr>
+</p:notes>
+</file>
+
+<file path=ppt/notesSlides/notesSlide9.xml><?xml version="1.0" encoding="utf-8"?>
+<p:notes xmlns:a="http://schemas.openxmlformats.org/drawingml/2006/main" xmlns:p="http://schemas.openxmlformats.org/presentationml/2006/main" xmlns:r="http://schemas.openxmlformats.org/officeDocument/2006/relationships">
+  <p:cSld>
+    <p:spTree>
+      <p:nvGrpSpPr>
+        <p:cNvPr id="1" name=""/>
+        <p:cNvGrpSpPr/>
+        <p:nvPr/>
+      </p:nvGrpSpPr>
+      <p:grpSpPr>
+        <a:xfrm>
+          <a:off x="0" y="0"/>
+          <a:ext cx="0" cy="0"/>
+          <a:chOff x="0" y="0"/>
+          <a:chExt cx="0" cy="0"/>
+        </a:xfrm>
+      </p:grpSpPr>
+      <p:sp>
+        <p:nvSpPr>
+          <p:cNvPr id="2" name="Slide Image Placeholder 1"/>
+          <p:cNvSpPr>
+            <a:spLocks noGrp="1"/>
+          </p:cNvSpPr>
+          <p:nvPr>
+            <p:ph type="sldImg" idx="2"/>
+          </p:nvPr>
+        </p:nvSpPr>
+        <p:spPr/>
+      </p:sp>
+      <p:sp>
+        <p:nvSpPr>
+          <p:cNvPr id="3" name="Notes Placeholder 2"/>
+          <p:cNvSpPr>
+            <a:spLocks noGrp="1"/>
+          </p:cNvSpPr>
+          <p:nvPr>
+            <p:ph type="body" idx="3" sz="quarter"/>
+          </p:nvPr>
+        </p:nvSpPr>
+        <p:spPr/>
+        <p:txBody>
+          <a:bodyPr/>
+          <a:lstStyle/>
+          <a:p>
+            <a:r>
+              <a:t>Pour ceux qui souhaitent approfondir leur compréhension de la créativité, je vais partager quelques ressources supplémentaires. Ces outils peuvent vous aider à développer vos compétences créatives.</a:t>
+            </a:r>
+          </a:p>
+        </p:txBody>
+      </p:sp>
+      <p:sp>
+        <p:nvSpPr>
+          <p:cNvPr id="4" name="Slide Number Placeholder 3"/>
+          <p:cNvSpPr>
+            <a:spLocks noGrp="1"/>
+          </p:cNvSpPr>
+          <p:nvPr>
+            <p:ph type="sldNum" idx="5" sz="quarter"/>
+          </p:nvPr>
+        </p:nvSpPr>
+        <p:spPr/>
+      </p:sp>
+    </p:spTree>
+  </p:cSld>
+  <p:clrMapOvr>
+    <a:masterClrMapping/>
+  </p:clrMapOvr>
+</p:notes>
 </file>
 
 <file path=ppt/slideLayouts/slideLayout1.xml><?xml version="1.0" encoding="utf-8"?>
@@ -3113,8 +4163,8 @@
         </p:nvSpPr>
         <p:spPr>
           <a:xfrm>
-            <a:off x="1371600" y="2011680"/>
-            <a:ext cx="9445752" cy="2743200"/>
+            <a:off x="1097280" y="1828800"/>
+            <a:ext cx="9966960" cy="3200400"/>
           </a:xfrm>
           <a:prstGeom prst="rect">
             <a:avLst/>
@@ -3128,7 +4178,7 @@
           <a:lstStyle/>
           <a:p>
             <a:pPr>
-              <a:defRPr sz="4400" b="1">
+              <a:defRPr sz="4000" b="1">
                 <a:solidFill>
                   <a:srgbClr val="38BDF8"/>
                 </a:solidFill>
@@ -3141,16 +4191,16 @@
           <a:p>
             <a:pPr>
               <a:spcBef>
-                <a:spcPts val="2000"/>
+                <a:spcPts val="1600"/>
               </a:spcBef>
-              <a:defRPr sz="2200">
+              <a:defRPr sz="2000">
                 <a:solidFill>
                   <a:srgbClr val="94A3B8"/>
                 </a:solidFill>
               </a:defRPr>
             </a:pPr>
             <a:r>
-              <a:t>Session sur les Stratégies Créatives avec Zoe Hames</a:t>
+              <a:t>Stratégies pour Libérer l'Innovation et la Créativité</a:t>
             </a:r>
           </a:p>
         </p:txBody>
@@ -3189,8 +4239,8 @@
         </p:nvSpPr>
         <p:spPr>
           <a:xfrm>
-            <a:off x="731520" y="457200"/>
-            <a:ext cx="10698480" cy="914400"/>
+            <a:off x="731520" y="365760"/>
+            <a:ext cx="10698480" cy="731520"/>
           </a:xfrm>
           <a:prstGeom prst="rect">
             <a:avLst/>
@@ -3198,20 +4248,20 @@
           <a:noFill/>
         </p:spPr>
         <p:txBody>
-          <a:bodyPr wrap="none">
+          <a:bodyPr wrap="square">
             <a:spAutoFit/>
           </a:bodyPr>
           <a:lstStyle/>
           <a:p>
             <a:pPr>
-              <a:defRPr sz="2800" b="1">
+              <a:defRPr sz="2400" b="1">
                 <a:solidFill>
                   <a:srgbClr val="38BDF8"/>
                 </a:solidFill>
               </a:defRPr>
             </a:pPr>
             <a:r>
-              <a:t>Questions et Échanges</a:t>
+              <a:t>Questions et Réponses</a:t>
             </a:r>
           </a:p>
         </p:txBody>
@@ -3224,8 +4274,8 @@
         </p:nvSpPr>
         <p:spPr>
           <a:xfrm>
-            <a:off x="731520" y="1645920"/>
-            <a:ext cx="5303520" cy="4389120"/>
+            <a:off x="731520" y="1143000"/>
+            <a:ext cx="10698480" cy="502920"/>
           </a:xfrm>
           <a:prstGeom prst="rect">
             <a:avLst/>
@@ -3239,60 +4289,157 @@
           <a:lstStyle/>
           <a:p>
             <a:pPr>
-              <a:spcAft>
-                <a:spcPts val="1600"/>
-              </a:spcAft>
-              <a:defRPr sz="1700">
-                <a:solidFill>
-                  <a:srgbClr val="F8FAFC"/>
+              <a:defRPr sz="1300" i="1">
+                <a:solidFill>
+                  <a:srgbClr val="BAE6FD"/>
                 </a:solidFill>
               </a:defRPr>
             </a:pPr>
             <a:r>
-              <a:t>•  Ouverture aux questions</a:t>
-            </a:r>
-          </a:p>
+              <a:t>Enseignement clé : Un moment pour échanger et clarifier les idées.</a:t>
+            </a:r>
+          </a:p>
+        </p:txBody>
+      </p:sp>
+      <p:sp>
+        <p:nvSpPr>
+          <p:cNvPr id="4" name="TextBox 3"/>
+          <p:cNvSpPr txBox="1"/>
+          <p:nvPr/>
+        </p:nvSpPr>
+        <p:spPr>
+          <a:xfrm>
+            <a:off x="731520" y="1645920"/>
+            <a:ext cx="5486400" cy="4846320"/>
+          </a:xfrm>
+          <a:prstGeom prst="rect">
+            <a:avLst/>
+          </a:prstGeom>
+          <a:noFill/>
+        </p:spPr>
+        <p:txBody>
+          <a:bodyPr wrap="square">
+            <a:spAutoFit/>
+          </a:bodyPr>
+          <a:lstStyle/>
           <a:p>
             <a:pPr>
               <a:spcAft>
-                <a:spcPts val="1600"/>
+                <a:spcPts val="1200"/>
               </a:spcAft>
-              <a:defRPr sz="1700">
+              <a:defRPr sz="1350">
                 <a:solidFill>
                   <a:srgbClr val="F8FAFC"/>
                 </a:solidFill>
               </a:defRPr>
             </a:pPr>
             <a:r>
-              <a:t>•  Partage d'expériences personnelles</a:t>
+              <a:t>•  Inviter les participants à poser des questions sur les stratégies présentées.</a:t>
+            </a:r>
+          </a:p>
+          <a:p>
+            <a:pPr>
+              <a:spcAft>
+                <a:spcPts val="1200"/>
+              </a:spcAft>
+              <a:defRPr sz="1350">
+                <a:solidFill>
+                  <a:srgbClr val="F8FAFC"/>
+                </a:solidFill>
+              </a:defRPr>
+            </a:pPr>
+            <a:r>
+              <a:t>•  Encourager le partage d'expériences personnelles liées à la créativité.</a:t>
+            </a:r>
+          </a:p>
+          <a:p>
+            <a:pPr>
+              <a:spcAft>
+                <a:spcPts val="1200"/>
+              </a:spcAft>
+              <a:defRPr sz="1350">
+                <a:solidFill>
+                  <a:srgbClr val="F8FAFC"/>
+                </a:solidFill>
+              </a:defRPr>
+            </a:pPr>
+            <a:r>
+              <a:t>•  Créer un espace de dialogue ouvert pour favoriser l'échange d'idées.</a:t>
             </a:r>
           </a:p>
         </p:txBody>
       </p:sp>
       <p:pic>
         <p:nvPicPr>
-          <p:cNvPr id="4" name="Picture 3" descr="slide_keyframe_09.jpg"/>
+          <p:cNvPr id="5" name="Picture 4" descr="slide_keyframe_09.jpg"/>
           <p:cNvPicPr>
             <a:picLocks noChangeAspect="1"/>
           </p:cNvPicPr>
           <p:nvPr/>
         </p:nvPicPr>
         <p:blipFill>
-          <a:blip r:embed="rId2"/>
+          <a:blip r:embed="rId3"/>
           <a:stretch>
             <a:fillRect/>
           </a:stretch>
         </p:blipFill>
         <p:spPr>
           <a:xfrm>
-            <a:off x="6400800" y="1645920"/>
-            <a:ext cx="5029200" cy="2826717"/>
+            <a:off x="6492240" y="1645920"/>
+            <a:ext cx="4937760" cy="2775322"/>
           </a:xfrm>
           <a:prstGeom prst="rect">
             <a:avLst/>
           </a:prstGeom>
         </p:spPr>
       </p:pic>
+      <p:sp>
+        <p:nvSpPr>
+          <p:cNvPr id="6" name="TextBox 5"/>
+          <p:cNvSpPr txBox="1"/>
+          <p:nvPr/>
+        </p:nvSpPr>
+        <p:spPr>
+          <a:xfrm>
+            <a:off x="6492240" y="4892040"/>
+            <a:ext cx="4937760" cy="1188720"/>
+          </a:xfrm>
+          <a:prstGeom prst="rect">
+            <a:avLst/>
+          </a:prstGeom>
+          <a:noFill/>
+        </p:spPr>
+        <p:txBody>
+          <a:bodyPr wrap="square">
+            <a:spAutoFit/>
+          </a:bodyPr>
+          <a:lstStyle/>
+          <a:p>
+            <a:pPr>
+              <a:defRPr sz="2200" b="1">
+                <a:solidFill>
+                  <a:srgbClr val="38BDF8"/>
+                </a:solidFill>
+              </a:defRPr>
+            </a:pPr>
+            <a:r>
+              <a:t>0</a:t>
+            </a:r>
+          </a:p>
+          <a:p>
+            <a:pPr>
+              <a:defRPr sz="1100">
+                <a:solidFill>
+                  <a:srgbClr val="94A3B8"/>
+                </a:solidFill>
+              </a:defRPr>
+            </a:pPr>
+            <a:r>
+              <a:t>Questions posées</a:t>
+            </a:r>
+          </a:p>
+        </p:txBody>
+      </p:sp>
     </p:spTree>
   </p:cSld>
   <p:clrMapOvr>
@@ -3327,8 +4474,8 @@
         </p:nvSpPr>
         <p:spPr>
           <a:xfrm>
-            <a:off x="731520" y="457200"/>
-            <a:ext cx="10698480" cy="914400"/>
+            <a:off x="731520" y="365760"/>
+            <a:ext cx="10698480" cy="731520"/>
           </a:xfrm>
           <a:prstGeom prst="rect">
             <a:avLst/>
@@ -3336,20 +4483,20 @@
           <a:noFill/>
         </p:spPr>
         <p:txBody>
-          <a:bodyPr wrap="none">
+          <a:bodyPr wrap="square">
             <a:spAutoFit/>
           </a:bodyPr>
           <a:lstStyle/>
           <a:p>
             <a:pPr>
-              <a:defRPr sz="2800" b="1">
+              <a:defRPr sz="2400" b="1">
                 <a:solidFill>
                   <a:srgbClr val="38BDF8"/>
                 </a:solidFill>
               </a:defRPr>
             </a:pPr>
             <a:r>
-              <a:t>Contexte et problématique centrale</a:t>
+              <a:t>L'Importance du Silence</a:t>
             </a:r>
           </a:p>
         </p:txBody>
@@ -3362,8 +4509,8 @@
         </p:nvSpPr>
         <p:spPr>
           <a:xfrm>
-            <a:off x="731520" y="1645920"/>
-            <a:ext cx="5303520" cy="4389120"/>
+            <a:off x="731520" y="1143000"/>
+            <a:ext cx="10698480" cy="502920"/>
           </a:xfrm>
           <a:prstGeom prst="rect">
             <a:avLst/>
@@ -3377,75 +4524,157 @@
           <a:lstStyle/>
           <a:p>
             <a:pPr>
-              <a:spcAft>
-                <a:spcPts val="1600"/>
-              </a:spcAft>
-              <a:defRPr sz="1700">
-                <a:solidFill>
-                  <a:srgbClr val="F8FAFC"/>
+              <a:defRPr sz="1300" i="1">
+                <a:solidFill>
+                  <a:srgbClr val="BAE6FD"/>
                 </a:solidFill>
               </a:defRPr>
             </a:pPr>
             <a:r>
-              <a:t>•  L'impact des distractions sur la créativité</a:t>
-            </a:r>
-          </a:p>
+              <a:t>Enseignement clé : Le silence est un catalyseur essentiel pour la créativité.</a:t>
+            </a:r>
+          </a:p>
+        </p:txBody>
+      </p:sp>
+      <p:sp>
+        <p:nvSpPr>
+          <p:cNvPr id="4" name="TextBox 3"/>
+          <p:cNvSpPr txBox="1"/>
+          <p:nvPr/>
+        </p:nvSpPr>
+        <p:spPr>
+          <a:xfrm>
+            <a:off x="731520" y="1645920"/>
+            <a:ext cx="5486400" cy="4846320"/>
+          </a:xfrm>
+          <a:prstGeom prst="rect">
+            <a:avLst/>
+          </a:prstGeom>
+          <a:noFill/>
+        </p:spPr>
+        <p:txBody>
+          <a:bodyPr wrap="square">
+            <a:spAutoFit/>
+          </a:bodyPr>
+          <a:lstStyle/>
           <a:p>
             <a:pPr>
               <a:spcAft>
-                <a:spcPts val="1600"/>
+                <a:spcPts val="1200"/>
               </a:spcAft>
-              <a:defRPr sz="1700">
+              <a:defRPr sz="1350">
                 <a:solidFill>
                   <a:srgbClr val="F8FAFC"/>
                 </a:solidFill>
               </a:defRPr>
             </a:pPr>
             <a:r>
-              <a:t>•  Nécessité de trouver des moments de calme</a:t>
+              <a:t>•  Instaurer des moments de silence quotidien pour favoriser la créativité et la concentration, en permettant au cerveau de se recharger.</a:t>
             </a:r>
           </a:p>
           <a:p>
             <a:pPr>
               <a:spcAft>
-                <a:spcPts val="1600"/>
+                <a:spcPts val="1200"/>
               </a:spcAft>
-              <a:defRPr sz="1700">
+              <a:defRPr sz="1350">
                 <a:solidFill>
                   <a:srgbClr val="F8FAFC"/>
                 </a:solidFill>
               </a:defRPr>
             </a:pPr>
             <a:r>
-              <a:t>•  Importance de la reconnexion à soi</a:t>
+              <a:t>•  Encourager des rituels d'équipe où le silence est valorisé, permettant ainsi à chacun de se recentrer sur ses idées et ses intuitions.</a:t>
+            </a:r>
+          </a:p>
+          <a:p>
+            <a:pPr>
+              <a:spcAft>
+                <a:spcPts val="1200"/>
+              </a:spcAft>
+              <a:defRPr sz="1350">
+                <a:solidFill>
+                  <a:srgbClr val="F8FAFC"/>
+                </a:solidFill>
+              </a:defRPr>
+            </a:pPr>
+            <a:r>
+              <a:t>•  Mesurer l'impact de ces moments de silence sur la productivité et la créativité à travers des indicateurs de performance adaptés.</a:t>
             </a:r>
           </a:p>
         </p:txBody>
       </p:sp>
       <p:pic>
         <p:nvPicPr>
-          <p:cNvPr id="4" name="Picture 3" descr="slide_keyframe_01.jpg"/>
+          <p:cNvPr id="5" name="Picture 4" descr="slide_keyframe_01.jpg"/>
           <p:cNvPicPr>
             <a:picLocks noChangeAspect="1"/>
           </p:cNvPicPr>
           <p:nvPr/>
         </p:nvPicPr>
         <p:blipFill>
-          <a:blip r:embed="rId2"/>
+          <a:blip r:embed="rId3"/>
           <a:stretch>
             <a:fillRect/>
           </a:stretch>
         </p:blipFill>
         <p:spPr>
           <a:xfrm>
-            <a:off x="6400800" y="1645920"/>
-            <a:ext cx="5029200" cy="2826717"/>
+            <a:off x="6492240" y="1645920"/>
+            <a:ext cx="4937760" cy="2775322"/>
           </a:xfrm>
           <a:prstGeom prst="rect">
             <a:avLst/>
           </a:prstGeom>
         </p:spPr>
       </p:pic>
+      <p:sp>
+        <p:nvSpPr>
+          <p:cNvPr id="6" name="TextBox 5"/>
+          <p:cNvSpPr txBox="1"/>
+          <p:nvPr/>
+        </p:nvSpPr>
+        <p:spPr>
+          <a:xfrm>
+            <a:off x="6492240" y="4892040"/>
+            <a:ext cx="4937760" cy="1188720"/>
+          </a:xfrm>
+          <a:prstGeom prst="rect">
+            <a:avLst/>
+          </a:prstGeom>
+          <a:noFill/>
+        </p:spPr>
+        <p:txBody>
+          <a:bodyPr wrap="square">
+            <a:spAutoFit/>
+          </a:bodyPr>
+          <a:lstStyle/>
+          <a:p>
+            <a:pPr>
+              <a:defRPr sz="2200" b="1">
+                <a:solidFill>
+                  <a:srgbClr val="38BDF8"/>
+                </a:solidFill>
+              </a:defRPr>
+            </a:pPr>
+            <a:r>
+              <a:t>75%</a:t>
+            </a:r>
+          </a:p>
+          <a:p>
+            <a:pPr>
+              <a:defRPr sz="1100">
+                <a:solidFill>
+                  <a:srgbClr val="94A3B8"/>
+                </a:solidFill>
+              </a:defRPr>
+            </a:pPr>
+            <a:r>
+              <a:t>Professionnels submergés par les distractions</a:t>
+            </a:r>
+          </a:p>
+        </p:txBody>
+      </p:sp>
     </p:spTree>
   </p:cSld>
   <p:clrMapOvr>
@@ -3480,8 +4709,8 @@
         </p:nvSpPr>
         <p:spPr>
           <a:xfrm>
-            <a:off x="731520" y="457200"/>
-            <a:ext cx="10698480" cy="914400"/>
+            <a:off x="731520" y="365760"/>
+            <a:ext cx="10698480" cy="731520"/>
           </a:xfrm>
           <a:prstGeom prst="rect">
             <a:avLst/>
@@ -3489,20 +4718,20 @@
           <a:noFill/>
         </p:spPr>
         <p:txBody>
-          <a:bodyPr wrap="none">
+          <a:bodyPr wrap="square">
             <a:spAutoFit/>
           </a:bodyPr>
           <a:lstStyle/>
           <a:p>
             <a:pPr>
-              <a:defRPr sz="2800" b="1">
+              <a:defRPr sz="2400" b="1">
                 <a:solidFill>
                   <a:srgbClr val="38BDF8"/>
                 </a:solidFill>
               </a:defRPr>
             </a:pPr>
             <a:r>
-              <a:t>Importance du Calme dans un Monde Distrayant</a:t>
+              <a:t>L'Énergie des Rêves : Une Source d'Inspiration</a:t>
             </a:r>
           </a:p>
         </p:txBody>
@@ -3515,8 +4744,8 @@
         </p:nvSpPr>
         <p:spPr>
           <a:xfrm>
-            <a:off x="731520" y="1645920"/>
-            <a:ext cx="5303520" cy="4389120"/>
+            <a:off x="731520" y="1143000"/>
+            <a:ext cx="10698480" cy="502920"/>
           </a:xfrm>
           <a:prstGeom prst="rect">
             <a:avLst/>
@@ -3530,60 +4759,157 @@
           <a:lstStyle/>
           <a:p>
             <a:pPr>
-              <a:spcAft>
-                <a:spcPts val="1600"/>
-              </a:spcAft>
-              <a:defRPr sz="1700">
-                <a:solidFill>
-                  <a:srgbClr val="F8FAFC"/>
+              <a:defRPr sz="1300" i="1">
+                <a:solidFill>
+                  <a:srgbClr val="BAE6FD"/>
                 </a:solidFill>
               </a:defRPr>
             </a:pPr>
             <a:r>
-              <a:t>•  Carver du temps quotidien pour le silence</a:t>
-            </a:r>
-          </a:p>
+              <a:t>Enseignement clé : Les rêves et l'imaginaire sont des ressources inexploitées pour l'innovation.</a:t>
+            </a:r>
+          </a:p>
+        </p:txBody>
+      </p:sp>
+      <p:sp>
+        <p:nvSpPr>
+          <p:cNvPr id="4" name="TextBox 3"/>
+          <p:cNvSpPr txBox="1"/>
+          <p:nvPr/>
+        </p:nvSpPr>
+        <p:spPr>
+          <a:xfrm>
+            <a:off x="731520" y="1645920"/>
+            <a:ext cx="5486400" cy="4846320"/>
+          </a:xfrm>
+          <a:prstGeom prst="rect">
+            <a:avLst/>
+          </a:prstGeom>
+          <a:noFill/>
+        </p:spPr>
+        <p:txBody>
+          <a:bodyPr wrap="square">
+            <a:spAutoFit/>
+          </a:bodyPr>
+          <a:lstStyle/>
           <a:p>
             <a:pPr>
               <a:spcAft>
-                <a:spcPts val="1600"/>
+                <a:spcPts val="1200"/>
               </a:spcAft>
-              <a:defRPr sz="1700">
+              <a:defRPr sz="1350">
                 <a:solidFill>
                   <a:srgbClr val="F8FAFC"/>
                 </a:solidFill>
               </a:defRPr>
             </a:pPr>
             <a:r>
-              <a:t>•  Pratiquer des activités en pleine nature</a:t>
+              <a:t>•  Encourager la libre expression des idées au sein des équipes pour stimuler l'innovation et l'engagement.</a:t>
+            </a:r>
+          </a:p>
+          <a:p>
+            <a:pPr>
+              <a:spcAft>
+                <a:spcPts val="1200"/>
+              </a:spcAft>
+              <a:defRPr sz="1350">
+                <a:solidFill>
+                  <a:srgbClr val="F8FAFC"/>
+                </a:solidFill>
+              </a:defRPr>
+            </a:pPr>
+            <a:r>
+              <a:t>•  Organiser des sessions de brainstorming où toutes les idées sont acceptées, favorisant ainsi un climat de créativité.</a:t>
+            </a:r>
+          </a:p>
+          <a:p>
+            <a:pPr>
+              <a:spcAft>
+                <a:spcPts val="1200"/>
+              </a:spcAft>
+              <a:defRPr sz="1350">
+                <a:solidFill>
+                  <a:srgbClr val="F8FAFC"/>
+                </a:solidFill>
+              </a:defRPr>
+            </a:pPr>
+            <a:r>
+              <a:t>•  Utiliser des techniques créatives comme le doodling ou l'écriture libre pour débloquer la pensée et explorer de nouvelles avenues.</a:t>
             </a:r>
           </a:p>
         </p:txBody>
       </p:sp>
       <p:pic>
         <p:nvPicPr>
-          <p:cNvPr id="4" name="Picture 3" descr="slide_keyframe_02.jpg"/>
+          <p:cNvPr id="5" name="Picture 4" descr="slide_keyframe_02.jpg"/>
           <p:cNvPicPr>
             <a:picLocks noChangeAspect="1"/>
           </p:cNvPicPr>
           <p:nvPr/>
         </p:nvPicPr>
         <p:blipFill>
-          <a:blip r:embed="rId2"/>
+          <a:blip r:embed="rId3"/>
           <a:stretch>
             <a:fillRect/>
           </a:stretch>
         </p:blipFill>
         <p:spPr>
           <a:xfrm>
-            <a:off x="6400800" y="1645920"/>
-            <a:ext cx="5029200" cy="2826717"/>
+            <a:off x="6492240" y="1645920"/>
+            <a:ext cx="4937760" cy="2775322"/>
           </a:xfrm>
           <a:prstGeom prst="rect">
             <a:avLst/>
           </a:prstGeom>
         </p:spPr>
       </p:pic>
+      <p:sp>
+        <p:nvSpPr>
+          <p:cNvPr id="6" name="TextBox 5"/>
+          <p:cNvSpPr txBox="1"/>
+          <p:nvPr/>
+        </p:nvSpPr>
+        <p:spPr>
+          <a:xfrm>
+            <a:off x="6492240" y="4892040"/>
+            <a:ext cx="4937760" cy="1188720"/>
+          </a:xfrm>
+          <a:prstGeom prst="rect">
+            <a:avLst/>
+          </a:prstGeom>
+          <a:noFill/>
+        </p:spPr>
+        <p:txBody>
+          <a:bodyPr wrap="square">
+            <a:spAutoFit/>
+          </a:bodyPr>
+          <a:lstStyle/>
+          <a:p>
+            <a:pPr>
+              <a:defRPr sz="2200" b="1">
+                <a:solidFill>
+                  <a:srgbClr val="38BDF8"/>
+                </a:solidFill>
+              </a:defRPr>
+            </a:pPr>
+            <a:r>
+              <a:t>3 techniques</a:t>
+            </a:r>
+          </a:p>
+          <a:p>
+            <a:pPr>
+              <a:defRPr sz="1100">
+                <a:solidFill>
+                  <a:srgbClr val="94A3B8"/>
+                </a:solidFill>
+              </a:defRPr>
+            </a:pPr>
+            <a:r>
+              <a:t>Approches créatives</a:t>
+            </a:r>
+          </a:p>
+        </p:txBody>
+      </p:sp>
     </p:spTree>
   </p:cSld>
   <p:clrMapOvr>
@@ -3618,8 +4944,8 @@
         </p:nvSpPr>
         <p:spPr>
           <a:xfrm>
-            <a:off x="731520" y="457200"/>
-            <a:ext cx="10698480" cy="914400"/>
+            <a:off x="731520" y="365760"/>
+            <a:ext cx="10698480" cy="731520"/>
           </a:xfrm>
           <a:prstGeom prst="rect">
             <a:avLst/>
@@ -3627,20 +4953,20 @@
           <a:noFill/>
         </p:spPr>
         <p:txBody>
-          <a:bodyPr wrap="none">
+          <a:bodyPr wrap="square">
             <a:spAutoFit/>
           </a:bodyPr>
           <a:lstStyle/>
           <a:p>
             <a:pPr>
-              <a:defRPr sz="2800" b="1">
+              <a:defRPr sz="2400" b="1">
                 <a:solidFill>
                   <a:srgbClr val="38BDF8"/>
                 </a:solidFill>
               </a:defRPr>
             </a:pPr>
             <a:r>
-              <a:t>Exploiter le Pouvoir des Rêves</a:t>
+              <a:t>L'Art de Lâcher Prise : Une Nécessité pour Créer</a:t>
             </a:r>
           </a:p>
         </p:txBody>
@@ -3653,8 +4979,8 @@
         </p:nvSpPr>
         <p:spPr>
           <a:xfrm>
-            <a:off x="731520" y="1645920"/>
-            <a:ext cx="5303520" cy="4389120"/>
+            <a:off x="731520" y="1143000"/>
+            <a:ext cx="10698480" cy="502920"/>
           </a:xfrm>
           <a:prstGeom prst="rect">
             <a:avLst/>
@@ -3668,60 +4994,157 @@
           <a:lstStyle/>
           <a:p>
             <a:pPr>
-              <a:spcAft>
-                <a:spcPts val="1600"/>
-              </a:spcAft>
-              <a:defRPr sz="1700">
-                <a:solidFill>
-                  <a:srgbClr val="F8FAFC"/>
+              <a:defRPr sz="1300" i="1">
+                <a:solidFill>
+                  <a:srgbClr val="BAE6FD"/>
                 </a:solidFill>
               </a:defRPr>
             </a:pPr>
             <a:r>
-              <a:t>•  Accorder du temps à des activités ludiques</a:t>
-            </a:r>
-          </a:p>
+              <a:t>Enseignement clé : Le lâcher-prise est essentiel pour stimuler la créativité.</a:t>
+            </a:r>
+          </a:p>
+        </p:txBody>
+      </p:sp>
+      <p:sp>
+        <p:nvSpPr>
+          <p:cNvPr id="4" name="TextBox 3"/>
+          <p:cNvSpPr txBox="1"/>
+          <p:nvPr/>
+        </p:nvSpPr>
+        <p:spPr>
+          <a:xfrm>
+            <a:off x="731520" y="1645920"/>
+            <a:ext cx="5486400" cy="4846320"/>
+          </a:xfrm>
+          <a:prstGeom prst="rect">
+            <a:avLst/>
+          </a:prstGeom>
+          <a:noFill/>
+        </p:spPr>
+        <p:txBody>
+          <a:bodyPr wrap="square">
+            <a:spAutoFit/>
+          </a:bodyPr>
+          <a:lstStyle/>
           <a:p>
             <a:pPr>
               <a:spcAft>
-                <a:spcPts val="1600"/>
+                <a:spcPts val="1200"/>
               </a:spcAft>
-              <a:defRPr sz="1700">
+              <a:defRPr sz="1350">
                 <a:solidFill>
                   <a:srgbClr val="F8FAFC"/>
                 </a:solidFill>
               </a:defRPr>
             </a:pPr>
             <a:r>
-              <a:t>•  Noter les idées sans autocensure</a:t>
+              <a:t>•  Mettre en place des politiques de bien-être au travail pour favoriser un équilibre entre vie professionnelle et personnelle.</a:t>
+            </a:r>
+          </a:p>
+          <a:p>
+            <a:pPr>
+              <a:spcAft>
+                <a:spcPts val="1200"/>
+              </a:spcAft>
+              <a:defRPr sz="1350">
+                <a:solidFill>
+                  <a:srgbClr val="F8FAFC"/>
+                </a:solidFill>
+              </a:defRPr>
+            </a:pPr>
+            <a:r>
+              <a:t>•  Encourager les employés à prendre des pauses régulières pour recharger leurs batteries et stimuler leur créativité.</a:t>
+            </a:r>
+          </a:p>
+          <a:p>
+            <a:pPr>
+              <a:spcAft>
+                <a:spcPts val="1200"/>
+              </a:spcAft>
+              <a:defRPr sz="1350">
+                <a:solidFill>
+                  <a:srgbClr val="F8FAFC"/>
+                </a:solidFill>
+              </a:defRPr>
+            </a:pPr>
+            <a:r>
+              <a:t>•  Évaluer l'impact des initiatives de bien-être sur la créativité et la productivité à travers des enquêtes et des indicateurs de performance.</a:t>
             </a:r>
           </a:p>
         </p:txBody>
       </p:sp>
       <p:pic>
         <p:nvPicPr>
-          <p:cNvPr id="4" name="Picture 3" descr="slide_keyframe_03.jpg"/>
+          <p:cNvPr id="5" name="Picture 4" descr="slide_keyframe_03.jpg"/>
           <p:cNvPicPr>
             <a:picLocks noChangeAspect="1"/>
           </p:cNvPicPr>
           <p:nvPr/>
         </p:nvPicPr>
         <p:blipFill>
-          <a:blip r:embed="rId2"/>
+          <a:blip r:embed="rId3"/>
           <a:stretch>
             <a:fillRect/>
           </a:stretch>
         </p:blipFill>
         <p:spPr>
           <a:xfrm>
-            <a:off x="6400800" y="1645920"/>
-            <a:ext cx="5029200" cy="2826717"/>
+            <a:off x="6492240" y="1645920"/>
+            <a:ext cx="4937760" cy="2775322"/>
           </a:xfrm>
           <a:prstGeom prst="rect">
             <a:avLst/>
           </a:prstGeom>
         </p:spPr>
       </p:pic>
+      <p:sp>
+        <p:nvSpPr>
+          <p:cNvPr id="6" name="TextBox 5"/>
+          <p:cNvSpPr txBox="1"/>
+          <p:nvPr/>
+        </p:nvSpPr>
+        <p:spPr>
+          <a:xfrm>
+            <a:off x="6492240" y="4892040"/>
+            <a:ext cx="4937760" cy="1188720"/>
+          </a:xfrm>
+          <a:prstGeom prst="rect">
+            <a:avLst/>
+          </a:prstGeom>
+          <a:noFill/>
+        </p:spPr>
+        <p:txBody>
+          <a:bodyPr wrap="square">
+            <a:spAutoFit/>
+          </a:bodyPr>
+          <a:lstStyle/>
+          <a:p>
+            <a:pPr>
+              <a:defRPr sz="2200" b="1">
+                <a:solidFill>
+                  <a:srgbClr val="38BDF8"/>
+                </a:solidFill>
+              </a:defRPr>
+            </a:pPr>
+            <a:r>
+              <a:t>100%</a:t>
+            </a:r>
+          </a:p>
+          <a:p>
+            <a:pPr>
+              <a:defRPr sz="1100">
+                <a:solidFill>
+                  <a:srgbClr val="94A3B8"/>
+                </a:solidFill>
+              </a:defRPr>
+            </a:pPr>
+            <a:r>
+              <a:t>Nécessité de prioriser le bien-être</a:t>
+            </a:r>
+          </a:p>
+        </p:txBody>
+      </p:sp>
     </p:spTree>
   </p:cSld>
   <p:clrMapOvr>
@@ -3756,8 +5179,8 @@
         </p:nvSpPr>
         <p:spPr>
           <a:xfrm>
-            <a:off x="731520" y="457200"/>
-            <a:ext cx="10698480" cy="914400"/>
+            <a:off x="731520" y="365760"/>
+            <a:ext cx="10698480" cy="731520"/>
           </a:xfrm>
           <a:prstGeom prst="rect">
             <a:avLst/>
@@ -3765,20 +5188,20 @@
           <a:noFill/>
         </p:spPr>
         <p:txBody>
-          <a:bodyPr wrap="none">
+          <a:bodyPr wrap="square">
             <a:spAutoFit/>
           </a:bodyPr>
           <a:lstStyle/>
           <a:p>
             <a:pPr>
-              <a:defRPr sz="2800" b="1">
+              <a:defRPr sz="2400" b="1">
                 <a:solidFill>
                   <a:srgbClr val="38BDF8"/>
                 </a:solidFill>
               </a:defRPr>
             </a:pPr>
             <a:r>
-              <a:t>L'Art de Lâcher Prise</a:t>
+              <a:t>Mise en Pratique des Stratégies Créatives</a:t>
             </a:r>
           </a:p>
         </p:txBody>
@@ -3791,8 +5214,8 @@
         </p:nvSpPr>
         <p:spPr>
           <a:xfrm>
-            <a:off x="731520" y="1645920"/>
-            <a:ext cx="5303520" cy="4389120"/>
+            <a:off x="731520" y="1143000"/>
+            <a:ext cx="10698480" cy="502920"/>
           </a:xfrm>
           <a:prstGeom prst="rect">
             <a:avLst/>
@@ -3806,60 +5229,157 @@
           <a:lstStyle/>
           <a:p>
             <a:pPr>
-              <a:spcAft>
-                <a:spcPts val="1600"/>
-              </a:spcAft>
-              <a:defRPr sz="1700">
-                <a:solidFill>
-                  <a:srgbClr val="F8FAFC"/>
+              <a:defRPr sz="1300" i="1">
+                <a:solidFill>
+                  <a:srgbClr val="BAE6FD"/>
                 </a:solidFill>
               </a:defRPr>
             </a:pPr>
             <a:r>
-              <a:t>•  Établir des limites claires pour éviter l'épuisement</a:t>
-            </a:r>
-          </a:p>
+              <a:t>Enseignement clé : L'intégration des stratégies créatives nécessite un engagement collectif.</a:t>
+            </a:r>
+          </a:p>
+        </p:txBody>
+      </p:sp>
+      <p:sp>
+        <p:nvSpPr>
+          <p:cNvPr id="4" name="TextBox 3"/>
+          <p:cNvSpPr txBox="1"/>
+          <p:nvPr/>
+        </p:nvSpPr>
+        <p:spPr>
+          <a:xfrm>
+            <a:off x="731520" y="1645920"/>
+            <a:ext cx="5486400" cy="4846320"/>
+          </a:xfrm>
+          <a:prstGeom prst="rect">
+            <a:avLst/>
+          </a:prstGeom>
+          <a:noFill/>
+        </p:spPr>
+        <p:txBody>
+          <a:bodyPr wrap="square">
+            <a:spAutoFit/>
+          </a:bodyPr>
+          <a:lstStyle/>
           <a:p>
             <a:pPr>
               <a:spcAft>
-                <a:spcPts val="1600"/>
+                <a:spcPts val="1200"/>
               </a:spcAft>
-              <a:defRPr sz="1700">
+              <a:defRPr sz="1350">
                 <a:solidFill>
                   <a:srgbClr val="F8FAFC"/>
                 </a:solidFill>
               </a:defRPr>
             </a:pPr>
             <a:r>
-              <a:t>•  S'accorder des pauses régulières</a:t>
+              <a:t>•  Intégrer les stratégies créatives dans la culture d'entreprise pour favoriser un environnement propice à l'innovation.</a:t>
+            </a:r>
+          </a:p>
+          <a:p>
+            <a:pPr>
+              <a:spcAft>
+                <a:spcPts val="1200"/>
+              </a:spcAft>
+              <a:defRPr sz="1350">
+                <a:solidFill>
+                  <a:srgbClr val="F8FAFC"/>
+                </a:solidFill>
+              </a:defRPr>
+            </a:pPr>
+            <a:r>
+              <a:t>•  Proposer des formations sur des techniques de créativité et de gestion du stress pour outiller les employés.</a:t>
+            </a:r>
+          </a:p>
+          <a:p>
+            <a:pPr>
+              <a:spcAft>
+                <a:spcPts val="1200"/>
+              </a:spcAft>
+              <a:defRPr sz="1350">
+                <a:solidFill>
+                  <a:srgbClr val="F8FAFC"/>
+                </a:solidFill>
+              </a:defRPr>
+            </a:pPr>
+            <a:r>
+              <a:t>•  Célébrer les réussites créatives pour encourager la prise de risque et l'innovation au sein des équipes.</a:t>
             </a:r>
           </a:p>
         </p:txBody>
       </p:sp>
       <p:pic>
         <p:nvPicPr>
-          <p:cNvPr id="4" name="Picture 3" descr="slide_keyframe_04.jpg"/>
+          <p:cNvPr id="5" name="Picture 4" descr="slide_keyframe_04.jpg"/>
           <p:cNvPicPr>
             <a:picLocks noChangeAspect="1"/>
           </p:cNvPicPr>
           <p:nvPr/>
         </p:nvPicPr>
         <p:blipFill>
-          <a:blip r:embed="rId2"/>
+          <a:blip r:embed="rId3"/>
           <a:stretch>
             <a:fillRect/>
           </a:stretch>
         </p:blipFill>
         <p:spPr>
           <a:xfrm>
-            <a:off x="6400800" y="1645920"/>
-            <a:ext cx="5029200" cy="2826717"/>
+            <a:off x="6492240" y="1645920"/>
+            <a:ext cx="4937760" cy="2775322"/>
           </a:xfrm>
           <a:prstGeom prst="rect">
             <a:avLst/>
           </a:prstGeom>
         </p:spPr>
       </p:pic>
+      <p:sp>
+        <p:nvSpPr>
+          <p:cNvPr id="6" name="TextBox 5"/>
+          <p:cNvSpPr txBox="1"/>
+          <p:nvPr/>
+        </p:nvSpPr>
+        <p:spPr>
+          <a:xfrm>
+            <a:off x="6492240" y="4892040"/>
+            <a:ext cx="4937760" cy="1188720"/>
+          </a:xfrm>
+          <a:prstGeom prst="rect">
+            <a:avLst/>
+          </a:prstGeom>
+          <a:noFill/>
+        </p:spPr>
+        <p:txBody>
+          <a:bodyPr wrap="square">
+            <a:spAutoFit/>
+          </a:bodyPr>
+          <a:lstStyle/>
+          <a:p>
+            <a:pPr>
+              <a:defRPr sz="2200" b="1">
+                <a:solidFill>
+                  <a:srgbClr val="38BDF8"/>
+                </a:solidFill>
+              </a:defRPr>
+            </a:pPr>
+            <a:r>
+              <a:t>3 initiatives</a:t>
+            </a:r>
+          </a:p>
+          <a:p>
+            <a:pPr>
+              <a:defRPr sz="1100">
+                <a:solidFill>
+                  <a:srgbClr val="94A3B8"/>
+                </a:solidFill>
+              </a:defRPr>
+            </a:pPr>
+            <a:r>
+              <a:t>Actions recommandées</a:t>
+            </a:r>
+          </a:p>
+        </p:txBody>
+      </p:sp>
     </p:spTree>
   </p:cSld>
   <p:clrMapOvr>
@@ -3894,8 +5414,8 @@
         </p:nvSpPr>
         <p:spPr>
           <a:xfrm>
-            <a:off x="731520" y="457200"/>
-            <a:ext cx="10698480" cy="914400"/>
+            <a:off x="731520" y="365760"/>
+            <a:ext cx="10698480" cy="731520"/>
           </a:xfrm>
           <a:prstGeom prst="rect">
             <a:avLst/>
@@ -3903,20 +5423,20 @@
           <a:noFill/>
         </p:spPr>
         <p:txBody>
-          <a:bodyPr wrap="none">
+          <a:bodyPr wrap="square">
             <a:spAutoFit/>
           </a:bodyPr>
           <a:lstStyle/>
           <a:p>
             <a:pPr>
-              <a:defRPr sz="2800" b="1">
+              <a:defRPr sz="2400" b="1">
                 <a:solidFill>
                   <a:srgbClr val="38BDF8"/>
                 </a:solidFill>
               </a:defRPr>
             </a:pPr>
             <a:r>
-              <a:t>Pratiques Quotidiennes pour Stimuler la Créativité</a:t>
+              <a:t>Évaluation de l'Impact des Stratégies sur la Créativité</a:t>
             </a:r>
           </a:p>
         </p:txBody>
@@ -3929,8 +5449,8 @@
         </p:nvSpPr>
         <p:spPr>
           <a:xfrm>
-            <a:off x="731520" y="1645920"/>
-            <a:ext cx="5303520" cy="4389120"/>
+            <a:off x="731520" y="1143000"/>
+            <a:ext cx="10698480" cy="502920"/>
           </a:xfrm>
           <a:prstGeom prst="rect">
             <a:avLst/>
@@ -3944,60 +5464,157 @@
           <a:lstStyle/>
           <a:p>
             <a:pPr>
-              <a:spcAft>
-                <a:spcPts val="1600"/>
-              </a:spcAft>
-              <a:defRPr sz="1700">
-                <a:solidFill>
-                  <a:srgbClr val="F8FAFC"/>
+              <a:defRPr sz="1300" i="1">
+                <a:solidFill>
+                  <a:srgbClr val="BAE6FD"/>
                 </a:solidFill>
               </a:defRPr>
             </a:pPr>
             <a:r>
-              <a:t>•  Méditation quotidienne</a:t>
-            </a:r>
-          </a:p>
+              <a:t>Enseignement clé : L'évaluation continue est essentielle pour maintenir l'efficacité des stratégies créatives.</a:t>
+            </a:r>
+          </a:p>
+        </p:txBody>
+      </p:sp>
+      <p:sp>
+        <p:nvSpPr>
+          <p:cNvPr id="4" name="TextBox 3"/>
+          <p:cNvSpPr txBox="1"/>
+          <p:nvPr/>
+        </p:nvSpPr>
+        <p:spPr>
+          <a:xfrm>
+            <a:off x="731520" y="1645920"/>
+            <a:ext cx="5486400" cy="4846320"/>
+          </a:xfrm>
+          <a:prstGeom prst="rect">
+            <a:avLst/>
+          </a:prstGeom>
+          <a:noFill/>
+        </p:spPr>
+        <p:txBody>
+          <a:bodyPr wrap="square">
+            <a:spAutoFit/>
+          </a:bodyPr>
+          <a:lstStyle/>
           <a:p>
             <a:pPr>
               <a:spcAft>
-                <a:spcPts val="1600"/>
+                <a:spcPts val="1200"/>
               </a:spcAft>
-              <a:defRPr sz="1700">
+              <a:defRPr sz="1350">
                 <a:solidFill>
                   <a:srgbClr val="F8FAFC"/>
                 </a:solidFill>
               </a:defRPr>
             </a:pPr>
             <a:r>
-              <a:t>•  Balades en pleine nature</a:t>
+              <a:t>•  Définir des indicateurs de performance pour mesurer l'impact des stratégies créatives sur la satisfaction et l'innovation.</a:t>
+            </a:r>
+          </a:p>
+          <a:p>
+            <a:pPr>
+              <a:spcAft>
+                <a:spcPts val="1200"/>
+              </a:spcAft>
+              <a:defRPr sz="1350">
+                <a:solidFill>
+                  <a:srgbClr val="F8FAFC"/>
+                </a:solidFill>
+              </a:defRPr>
+            </a:pPr>
+            <a:r>
+              <a:t>•  Instaurer des feedbacks réguliers pour ajuster les pratiques et améliorer continuellement les processus créatifs.</a:t>
+            </a:r>
+          </a:p>
+          <a:p>
+            <a:pPr>
+              <a:spcAft>
+                <a:spcPts val="1200"/>
+              </a:spcAft>
+              <a:defRPr sz="1350">
+                <a:solidFill>
+                  <a:srgbClr val="F8FAFC"/>
+                </a:solidFill>
+              </a:defRPr>
+            </a:pPr>
+            <a:r>
+              <a:t>•  Communiquer les résultats obtenus pour renforcer l'engagement des employés et valoriser les efforts créatifs.</a:t>
             </a:r>
           </a:p>
         </p:txBody>
       </p:sp>
       <p:pic>
         <p:nvPicPr>
-          <p:cNvPr id="4" name="Picture 3" descr="slide_keyframe_05.jpg"/>
+          <p:cNvPr id="5" name="Picture 4" descr="slide_keyframe_05.jpg"/>
           <p:cNvPicPr>
             <a:picLocks noChangeAspect="1"/>
           </p:cNvPicPr>
           <p:nvPr/>
         </p:nvPicPr>
         <p:blipFill>
-          <a:blip r:embed="rId2"/>
+          <a:blip r:embed="rId3"/>
           <a:stretch>
             <a:fillRect/>
           </a:stretch>
         </p:blipFill>
         <p:spPr>
           <a:xfrm>
-            <a:off x="6400800" y="1645920"/>
-            <a:ext cx="5029200" cy="2826717"/>
+            <a:off x="6492240" y="1645920"/>
+            <a:ext cx="4937760" cy="2775322"/>
           </a:xfrm>
           <a:prstGeom prst="rect">
             <a:avLst/>
           </a:prstGeom>
         </p:spPr>
       </p:pic>
+      <p:sp>
+        <p:nvSpPr>
+          <p:cNvPr id="6" name="TextBox 5"/>
+          <p:cNvSpPr txBox="1"/>
+          <p:nvPr/>
+        </p:nvSpPr>
+        <p:spPr>
+          <a:xfrm>
+            <a:off x="6492240" y="4892040"/>
+            <a:ext cx="4937760" cy="1188720"/>
+          </a:xfrm>
+          <a:prstGeom prst="rect">
+            <a:avLst/>
+          </a:prstGeom>
+          <a:noFill/>
+        </p:spPr>
+        <p:txBody>
+          <a:bodyPr wrap="square">
+            <a:spAutoFit/>
+          </a:bodyPr>
+          <a:lstStyle/>
+          <a:p>
+            <a:pPr>
+              <a:defRPr sz="2200" b="1">
+                <a:solidFill>
+                  <a:srgbClr val="38BDF8"/>
+                </a:solidFill>
+              </a:defRPr>
+            </a:pPr>
+            <a:r>
+              <a:t>5 indicateurs</a:t>
+            </a:r>
+          </a:p>
+          <a:p>
+            <a:pPr>
+              <a:defRPr sz="1100">
+                <a:solidFill>
+                  <a:srgbClr val="94A3B8"/>
+                </a:solidFill>
+              </a:defRPr>
+            </a:pPr>
+            <a:r>
+              <a:t>Mesures de performance</a:t>
+            </a:r>
+          </a:p>
+        </p:txBody>
+      </p:sp>
     </p:spTree>
   </p:cSld>
   <p:clrMapOvr>
@@ -4032,8 +5649,8 @@
         </p:nvSpPr>
         <p:spPr>
           <a:xfrm>
-            <a:off x="731520" y="457200"/>
-            <a:ext cx="10698480" cy="914400"/>
+            <a:off x="731520" y="365760"/>
+            <a:ext cx="10698480" cy="731520"/>
           </a:xfrm>
           <a:prstGeom prst="rect">
             <a:avLst/>
@@ -4041,20 +5658,20 @@
           <a:noFill/>
         </p:spPr>
         <p:txBody>
-          <a:bodyPr wrap="none">
+          <a:bodyPr wrap="square">
             <a:spAutoFit/>
           </a:bodyPr>
           <a:lstStyle/>
           <a:p>
             <a:pPr>
-              <a:defRPr sz="2800" b="1">
+              <a:defRPr sz="2400" b="1">
                 <a:solidFill>
                   <a:srgbClr val="38BDF8"/>
                 </a:solidFill>
               </a:defRPr>
             </a:pPr>
             <a:r>
-              <a:t>Conclusion et Prochaines Étapes</a:t>
+              <a:t>Conclusion : Un Voyage Créatif Continu</a:t>
             </a:r>
           </a:p>
         </p:txBody>
@@ -4067,8 +5684,8 @@
         </p:nvSpPr>
         <p:spPr>
           <a:xfrm>
-            <a:off x="731520" y="1645920"/>
-            <a:ext cx="5303520" cy="4389120"/>
+            <a:off x="731520" y="1143000"/>
+            <a:ext cx="10698480" cy="502920"/>
           </a:xfrm>
           <a:prstGeom prst="rect">
             <a:avLst/>
@@ -4082,60 +5699,157 @@
           <a:lstStyle/>
           <a:p>
             <a:pPr>
-              <a:spcAft>
-                <a:spcPts val="1600"/>
-              </a:spcAft>
-              <a:defRPr sz="1700">
-                <a:solidFill>
-                  <a:srgbClr val="F8FAFC"/>
+              <a:defRPr sz="1300" i="1">
+                <a:solidFill>
+                  <a:srgbClr val="BAE6FD"/>
                 </a:solidFill>
               </a:defRPr>
             </a:pPr>
             <a:r>
-              <a:t>•  Mettre en pratique ces stratégies régulièrement</a:t>
-            </a:r>
-          </a:p>
+              <a:t>Enseignement clé : La créativité est un voyage, pas une destination.</a:t>
+            </a:r>
+          </a:p>
+        </p:txBody>
+      </p:sp>
+      <p:sp>
+        <p:nvSpPr>
+          <p:cNvPr id="4" name="TextBox 3"/>
+          <p:cNvSpPr txBox="1"/>
+          <p:nvPr/>
+        </p:nvSpPr>
+        <p:spPr>
+          <a:xfrm>
+            <a:off x="731520" y="1645920"/>
+            <a:ext cx="5486400" cy="4846320"/>
+          </a:xfrm>
+          <a:prstGeom prst="rect">
+            <a:avLst/>
+          </a:prstGeom>
+          <a:noFill/>
+        </p:spPr>
+        <p:txBody>
+          <a:bodyPr wrap="square">
+            <a:spAutoFit/>
+          </a:bodyPr>
+          <a:lstStyle/>
           <a:p>
             <a:pPr>
               <a:spcAft>
-                <a:spcPts val="1600"/>
+                <a:spcPts val="1200"/>
               </a:spcAft>
-              <a:defRPr sz="1700">
+              <a:defRPr sz="1350">
                 <a:solidFill>
                   <a:srgbClr val="F8FAFC"/>
                 </a:solidFill>
               </a:defRPr>
             </a:pPr>
             <a:r>
-              <a:t>•  S'engager dans un processus d'apprentissage continu</a:t>
+              <a:t>•  Encourager une culture d'expérimentation et d'innovation continue au sein des équipes.</a:t>
+            </a:r>
+          </a:p>
+          <a:p>
+            <a:pPr>
+              <a:spcAft>
+                <a:spcPts val="1200"/>
+              </a:spcAft>
+              <a:defRPr sz="1350">
+                <a:solidFill>
+                  <a:srgbClr val="F8FAFC"/>
+                </a:solidFill>
+              </a:defRPr>
+            </a:pPr>
+            <a:r>
+              <a:t>•  Rappeler que chaque échec est une opportunité d'apprentissage et de croissance.</a:t>
+            </a:r>
+          </a:p>
+          <a:p>
+            <a:pPr>
+              <a:spcAft>
+                <a:spcPts val="1200"/>
+              </a:spcAft>
+              <a:defRPr sz="1350">
+                <a:solidFill>
+                  <a:srgbClr val="F8FAFC"/>
+                </a:solidFill>
+              </a:defRPr>
+            </a:pPr>
+            <a:r>
+              <a:t>•  Promouvoir l'idée que la créativité peut être cultivée et développée avec le temps.</a:t>
             </a:r>
           </a:p>
         </p:txBody>
       </p:sp>
       <p:pic>
         <p:nvPicPr>
-          <p:cNvPr id="4" name="Picture 3" descr="slide_keyframe_06.jpg"/>
+          <p:cNvPr id="5" name="Picture 4" descr="slide_keyframe_06.jpg"/>
           <p:cNvPicPr>
             <a:picLocks noChangeAspect="1"/>
           </p:cNvPicPr>
           <p:nvPr/>
         </p:nvPicPr>
         <p:blipFill>
-          <a:blip r:embed="rId2"/>
+          <a:blip r:embed="rId3"/>
           <a:stretch>
             <a:fillRect/>
           </a:stretch>
         </p:blipFill>
         <p:spPr>
           <a:xfrm>
-            <a:off x="6400800" y="1645920"/>
-            <a:ext cx="5029200" cy="2826717"/>
+            <a:off x="6492240" y="1645920"/>
+            <a:ext cx="4937760" cy="2775322"/>
           </a:xfrm>
           <a:prstGeom prst="rect">
             <a:avLst/>
           </a:prstGeom>
         </p:spPr>
       </p:pic>
+      <p:sp>
+        <p:nvSpPr>
+          <p:cNvPr id="6" name="TextBox 5"/>
+          <p:cNvSpPr txBox="1"/>
+          <p:nvPr/>
+        </p:nvSpPr>
+        <p:spPr>
+          <a:xfrm>
+            <a:off x="6492240" y="4892040"/>
+            <a:ext cx="4937760" cy="1188720"/>
+          </a:xfrm>
+          <a:prstGeom prst="rect">
+            <a:avLst/>
+          </a:prstGeom>
+          <a:noFill/>
+        </p:spPr>
+        <p:txBody>
+          <a:bodyPr wrap="square">
+            <a:spAutoFit/>
+          </a:bodyPr>
+          <a:lstStyle/>
+          <a:p>
+            <a:pPr>
+              <a:defRPr sz="2200" b="1">
+                <a:solidFill>
+                  <a:srgbClr val="38BDF8"/>
+                </a:solidFill>
+              </a:defRPr>
+            </a:pPr>
+            <a:r>
+              <a:t>100%</a:t>
+            </a:r>
+          </a:p>
+          <a:p>
+            <a:pPr>
+              <a:defRPr sz="1100">
+                <a:solidFill>
+                  <a:srgbClr val="94A3B8"/>
+                </a:solidFill>
+              </a:defRPr>
+            </a:pPr>
+            <a:r>
+              <a:t>Engagement envers l'innovation</a:t>
+            </a:r>
+          </a:p>
+        </p:txBody>
+      </p:sp>
     </p:spTree>
   </p:cSld>
   <p:clrMapOvr>
@@ -4170,8 +5884,8 @@
         </p:nvSpPr>
         <p:spPr>
           <a:xfrm>
-            <a:off x="731520" y="457200"/>
-            <a:ext cx="10698480" cy="914400"/>
+            <a:off x="731520" y="365760"/>
+            <a:ext cx="10698480" cy="731520"/>
           </a:xfrm>
           <a:prstGeom prst="rect">
             <a:avLst/>
@@ -4179,20 +5893,20 @@
           <a:noFill/>
         </p:spPr>
         <p:txBody>
-          <a:bodyPr wrap="none">
+          <a:bodyPr wrap="square">
             <a:spAutoFit/>
           </a:bodyPr>
           <a:lstStyle/>
           <a:p>
             <a:pPr>
-              <a:defRPr sz="2800" b="1">
+              <a:defRPr sz="2400" b="1">
                 <a:solidFill>
                   <a:srgbClr val="38BDF8"/>
                 </a:solidFill>
               </a:defRPr>
             </a:pPr>
             <a:r>
-              <a:t>Synthèse des Stratégies</a:t>
+              <a:t>Appel à l'Action : Libérer Votre Créativité</a:t>
             </a:r>
           </a:p>
         </p:txBody>
@@ -4205,8 +5919,8 @@
         </p:nvSpPr>
         <p:spPr>
           <a:xfrm>
-            <a:off x="731520" y="1645920"/>
-            <a:ext cx="5303520" cy="4389120"/>
+            <a:off x="731520" y="1143000"/>
+            <a:ext cx="10698480" cy="502920"/>
           </a:xfrm>
           <a:prstGeom prst="rect">
             <a:avLst/>
@@ -4220,60 +5934,157 @@
           <a:lstStyle/>
           <a:p>
             <a:pPr>
-              <a:spcAft>
-                <a:spcPts val="1600"/>
-              </a:spcAft>
-              <a:defRPr sz="1700">
-                <a:solidFill>
-                  <a:srgbClr val="F8FAFC"/>
+              <a:defRPr sz="1300" i="1">
+                <a:solidFill>
+                  <a:srgbClr val="BAE6FD"/>
                 </a:solidFill>
               </a:defRPr>
             </a:pPr>
             <a:r>
-              <a:t>•  Trouver le calme pour favoriser l'inspiration</a:t>
-            </a:r>
-          </a:p>
+              <a:t>Enseignement clé : Chaque individu a le potentiel de créer des chefs-d'œuvre.</a:t>
+            </a:r>
+          </a:p>
+        </p:txBody>
+      </p:sp>
+      <p:sp>
+        <p:nvSpPr>
+          <p:cNvPr id="4" name="TextBox 3"/>
+          <p:cNvSpPr txBox="1"/>
+          <p:nvPr/>
+        </p:nvSpPr>
+        <p:spPr>
+          <a:xfrm>
+            <a:off x="731520" y="1645920"/>
+            <a:ext cx="5486400" cy="4846320"/>
+          </a:xfrm>
+          <a:prstGeom prst="rect">
+            <a:avLst/>
+          </a:prstGeom>
+          <a:noFill/>
+        </p:spPr>
+        <p:txBody>
+          <a:bodyPr wrap="square">
+            <a:spAutoFit/>
+          </a:bodyPr>
+          <a:lstStyle/>
           <a:p>
             <a:pPr>
               <a:spcAft>
-                <a:spcPts val="1600"/>
+                <a:spcPts val="1200"/>
               </a:spcAft>
-              <a:defRPr sz="1700">
+              <a:defRPr sz="1350">
                 <a:solidFill>
                   <a:srgbClr val="F8FAFC"/>
                 </a:solidFill>
               </a:defRPr>
             </a:pPr>
             <a:r>
-              <a:t>•  Exploiter les rêves pour libérer l'imagination</a:t>
+              <a:t>•  Inviter les participants à mettre en pratique les stratégies discutées dans leur quotidien.</a:t>
+            </a:r>
+          </a:p>
+          <a:p>
+            <a:pPr>
+              <a:spcAft>
+                <a:spcPts val="1200"/>
+              </a:spcAft>
+              <a:defRPr sz="1350">
+                <a:solidFill>
+                  <a:srgbClr val="F8FAFC"/>
+                </a:solidFill>
+              </a:defRPr>
+            </a:pPr>
+            <a:r>
+              <a:t>•  Encourager à partager leurs expériences et découvertes avec leurs collègues.</a:t>
+            </a:r>
+          </a:p>
+          <a:p>
+            <a:pPr>
+              <a:spcAft>
+                <a:spcPts val="1200"/>
+              </a:spcAft>
+              <a:defRPr sz="1350">
+                <a:solidFill>
+                  <a:srgbClr val="F8FAFC"/>
+                </a:solidFill>
+              </a:defRPr>
+            </a:pPr>
+            <a:r>
+              <a:t>•  Promouvoir une communauté de soutien autour de la créativité au sein de l'organisation.</a:t>
             </a:r>
           </a:p>
         </p:txBody>
       </p:sp>
       <p:pic>
         <p:nvPicPr>
-          <p:cNvPr id="4" name="Picture 3" descr="slide_keyframe_07.jpg"/>
+          <p:cNvPr id="5" name="Picture 4" descr="slide_keyframe_07.jpg"/>
           <p:cNvPicPr>
             <a:picLocks noChangeAspect="1"/>
           </p:cNvPicPr>
           <p:nvPr/>
         </p:nvPicPr>
         <p:blipFill>
-          <a:blip r:embed="rId2"/>
+          <a:blip r:embed="rId3"/>
           <a:stretch>
             <a:fillRect/>
           </a:stretch>
         </p:blipFill>
         <p:spPr>
           <a:xfrm>
-            <a:off x="6400800" y="1645920"/>
-            <a:ext cx="5029200" cy="2826717"/>
+            <a:off x="6492240" y="1645920"/>
+            <a:ext cx="4937760" cy="2775322"/>
           </a:xfrm>
           <a:prstGeom prst="rect">
             <a:avLst/>
           </a:prstGeom>
         </p:spPr>
       </p:pic>
+      <p:sp>
+        <p:nvSpPr>
+          <p:cNvPr id="6" name="TextBox 5"/>
+          <p:cNvSpPr txBox="1"/>
+          <p:nvPr/>
+        </p:nvSpPr>
+        <p:spPr>
+          <a:xfrm>
+            <a:off x="6492240" y="4892040"/>
+            <a:ext cx="4937760" cy="1188720"/>
+          </a:xfrm>
+          <a:prstGeom prst="rect">
+            <a:avLst/>
+          </a:prstGeom>
+          <a:noFill/>
+        </p:spPr>
+        <p:txBody>
+          <a:bodyPr wrap="square">
+            <a:spAutoFit/>
+          </a:bodyPr>
+          <a:lstStyle/>
+          <a:p>
+            <a:pPr>
+              <a:defRPr sz="2200" b="1">
+                <a:solidFill>
+                  <a:srgbClr val="38BDF8"/>
+                </a:solidFill>
+              </a:defRPr>
+            </a:pPr>
+            <a:r>
+              <a:t>1 action</a:t>
+            </a:r>
+          </a:p>
+          <a:p>
+            <a:pPr>
+              <a:defRPr sz="1100">
+                <a:solidFill>
+                  <a:srgbClr val="94A3B8"/>
+                </a:solidFill>
+              </a:defRPr>
+            </a:pPr>
+            <a:r>
+              <a:t>Engagement personnel</a:t>
+            </a:r>
+          </a:p>
+        </p:txBody>
+      </p:sp>
     </p:spTree>
   </p:cSld>
   <p:clrMapOvr>
@@ -4308,8 +6119,8 @@
         </p:nvSpPr>
         <p:spPr>
           <a:xfrm>
-            <a:off x="731520" y="457200"/>
-            <a:ext cx="10698480" cy="914400"/>
+            <a:off x="731520" y="365760"/>
+            <a:ext cx="10698480" cy="731520"/>
           </a:xfrm>
           <a:prstGeom prst="rect">
             <a:avLst/>
@@ -4317,20 +6128,20 @@
           <a:noFill/>
         </p:spPr>
         <p:txBody>
-          <a:bodyPr wrap="none">
+          <a:bodyPr wrap="square">
             <a:spAutoFit/>
           </a:bodyPr>
           <a:lstStyle/>
           <a:p>
             <a:pPr>
-              <a:defRPr sz="2800" b="1">
+              <a:defRPr sz="2400" b="1">
                 <a:solidFill>
                   <a:srgbClr val="38BDF8"/>
                 </a:solidFill>
               </a:defRPr>
             </a:pPr>
             <a:r>
-              <a:t>Engagement vers la Créativité</a:t>
+              <a:t>Ressources Supplémentaires</a:t>
             </a:r>
           </a:p>
         </p:txBody>
@@ -4343,8 +6154,8 @@
         </p:nvSpPr>
         <p:spPr>
           <a:xfrm>
-            <a:off x="731520" y="1645920"/>
-            <a:ext cx="5303520" cy="4389120"/>
+            <a:off x="731520" y="1143000"/>
+            <a:ext cx="10698480" cy="502920"/>
           </a:xfrm>
           <a:prstGeom prst="rect">
             <a:avLst/>
@@ -4358,60 +6169,157 @@
           <a:lstStyle/>
           <a:p>
             <a:pPr>
-              <a:spcAft>
-                <a:spcPts val="1600"/>
-              </a:spcAft>
-              <a:defRPr sz="1700">
-                <a:solidFill>
-                  <a:srgbClr val="F8FAFC"/>
+              <a:defRPr sz="1300" i="1">
+                <a:solidFill>
+                  <a:srgbClr val="BAE6FD"/>
                 </a:solidFill>
               </a:defRPr>
             </a:pPr>
             <a:r>
-              <a:t>•  Encourager l'expérimentation</a:t>
-            </a:r>
-          </a:p>
+              <a:t>Enseignement clé : Accéder à des outils et des lectures pour approfondir la créativité.</a:t>
+            </a:r>
+          </a:p>
+        </p:txBody>
+      </p:sp>
+      <p:sp>
+        <p:nvSpPr>
+          <p:cNvPr id="4" name="TextBox 3"/>
+          <p:cNvSpPr txBox="1"/>
+          <p:nvPr/>
+        </p:nvSpPr>
+        <p:spPr>
+          <a:xfrm>
+            <a:off x="731520" y="1645920"/>
+            <a:ext cx="5486400" cy="4846320"/>
+          </a:xfrm>
+          <a:prstGeom prst="rect">
+            <a:avLst/>
+          </a:prstGeom>
+          <a:noFill/>
+        </p:spPr>
+        <p:txBody>
+          <a:bodyPr wrap="square">
+            <a:spAutoFit/>
+          </a:bodyPr>
+          <a:lstStyle/>
           <a:p>
             <a:pPr>
               <a:spcAft>
-                <a:spcPts val="1600"/>
+                <a:spcPts val="1200"/>
               </a:spcAft>
-              <a:defRPr sz="1700">
+              <a:defRPr sz="1350">
                 <a:solidFill>
                   <a:srgbClr val="F8FAFC"/>
                 </a:solidFill>
               </a:defRPr>
             </a:pPr>
             <a:r>
-              <a:t>•  Accepter les erreurs comme partie du processus</a:t>
+              <a:t>•  Recommander des livres et des articles sur la créativité et l'innovation.</a:t>
+            </a:r>
+          </a:p>
+          <a:p>
+            <a:pPr>
+              <a:spcAft>
+                <a:spcPts val="1200"/>
+              </a:spcAft>
+              <a:defRPr sz="1350">
+                <a:solidFill>
+                  <a:srgbClr val="F8FAFC"/>
+                </a:solidFill>
+              </a:defRPr>
+            </a:pPr>
+            <a:r>
+              <a:t>•  Proposer des ateliers et des formations pour développer des compétences créatives.</a:t>
+            </a:r>
+          </a:p>
+          <a:p>
+            <a:pPr>
+              <a:spcAft>
+                <a:spcPts val="1200"/>
+              </a:spcAft>
+              <a:defRPr sz="1350">
+                <a:solidFill>
+                  <a:srgbClr val="F8FAFC"/>
+                </a:solidFill>
+              </a:defRPr>
+            </a:pPr>
+            <a:r>
+              <a:t>•  Mettre à disposition des outils de gestion de projet qui favorisent la créativité.</a:t>
             </a:r>
           </a:p>
         </p:txBody>
       </p:sp>
       <p:pic>
         <p:nvPicPr>
-          <p:cNvPr id="4" name="Picture 3" descr="slide_keyframe_08.jpg"/>
+          <p:cNvPr id="5" name="Picture 4" descr="slide_keyframe_08.jpg"/>
           <p:cNvPicPr>
             <a:picLocks noChangeAspect="1"/>
           </p:cNvPicPr>
           <p:nvPr/>
         </p:nvPicPr>
         <p:blipFill>
-          <a:blip r:embed="rId2"/>
+          <a:blip r:embed="rId3"/>
           <a:stretch>
             <a:fillRect/>
           </a:stretch>
         </p:blipFill>
         <p:spPr>
           <a:xfrm>
-            <a:off x="6400800" y="1645920"/>
-            <a:ext cx="5029200" cy="2826717"/>
+            <a:off x="6492240" y="1645920"/>
+            <a:ext cx="4937760" cy="2775322"/>
           </a:xfrm>
           <a:prstGeom prst="rect">
             <a:avLst/>
           </a:prstGeom>
         </p:spPr>
       </p:pic>
+      <p:sp>
+        <p:nvSpPr>
+          <p:cNvPr id="6" name="TextBox 5"/>
+          <p:cNvSpPr txBox="1"/>
+          <p:nvPr/>
+        </p:nvSpPr>
+        <p:spPr>
+          <a:xfrm>
+            <a:off x="6492240" y="4892040"/>
+            <a:ext cx="4937760" cy="1188720"/>
+          </a:xfrm>
+          <a:prstGeom prst="rect">
+            <a:avLst/>
+          </a:prstGeom>
+          <a:noFill/>
+        </p:spPr>
+        <p:txBody>
+          <a:bodyPr wrap="square">
+            <a:spAutoFit/>
+          </a:bodyPr>
+          <a:lstStyle/>
+          <a:p>
+            <a:pPr>
+              <a:defRPr sz="2200" b="1">
+                <a:solidFill>
+                  <a:srgbClr val="38BDF8"/>
+                </a:solidFill>
+              </a:defRPr>
+            </a:pPr>
+            <a:r>
+              <a:t>3 ressources</a:t>
+            </a:r>
+          </a:p>
+          <a:p>
+            <a:pPr>
+              <a:defRPr sz="1100">
+                <a:solidFill>
+                  <a:srgbClr val="94A3B8"/>
+                </a:solidFill>
+              </a:defRPr>
+            </a:pPr>
+            <a:r>
+              <a:t>Outils recommandés</a:t>
+            </a:r>
+          </a:p>
+        </p:txBody>
+      </p:sp>
     </p:spTree>
   </p:cSld>
   <p:clrMapOvr>
@@ -4738,4 +6646,324 @@
   </a:objectDefaults>
   <a:extraClrSchemeLst/>
 </a:theme>
+</file>
+
+<file path=ppt/theme/theme2.xml><?xml version="1.0" encoding="utf-8"?>
+<a:theme xmlns:a="http://schemas.openxmlformats.org/drawingml/2006/main" name="Office Theme">
+  <a:themeElements>
+    <a:clrScheme name="Office">
+      <a:dk1>
+        <a:sysClr val="windowText" lastClr="000000"/>
+      </a:dk1>
+      <a:lt1>
+        <a:sysClr val="window" lastClr="FFFFFF"/>
+      </a:lt1>
+      <a:dk2>
+        <a:srgbClr val="1F497D"/>
+      </a:dk2>
+      <a:lt2>
+        <a:srgbClr val="EEECE1"/>
+      </a:lt2>
+      <a:accent1>
+        <a:srgbClr val="4F81BD"/>
+      </a:accent1>
+      <a:accent2>
+        <a:srgbClr val="C0504D"/>
+      </a:accent2>
+      <a:accent3>
+        <a:srgbClr val="9BBB59"/>
+      </a:accent3>
+      <a:accent4>
+        <a:srgbClr val="8064A2"/>
+      </a:accent4>
+      <a:accent5>
+        <a:srgbClr val="4BACC6"/>
+      </a:accent5>
+      <a:accent6>
+        <a:srgbClr val="F79646"/>
+      </a:accent6>
+      <a:hlink>
+        <a:srgbClr val="0000FF"/>
+      </a:hlink>
+      <a:folHlink>
+        <a:srgbClr val="800080"/>
+      </a:folHlink>
+    </a:clrScheme>
+    <a:fontScheme name="Office">
+      <a:majorFont>
+        <a:latin typeface="Calibri"/>
+        <a:ea typeface=""/>
+        <a:cs typeface=""/>
+        <a:font script="Jpan" typeface="ＭＳ Ｐゴシック"/>
+        <a:font script="Hang" typeface="맑은 고딕"/>
+        <a:font script="Hans" typeface="宋体"/>
+        <a:font script="Hant" typeface="新細明體"/>
+        <a:font script="Arab" typeface="Times New Roman"/>
+        <a:font script="Hebr" typeface="Times New Roman"/>
+        <a:font script="Thai" typeface="Angsana New"/>
+        <a:font script="Ethi" typeface="Nyala"/>
+        <a:font script="Beng" typeface="Vrinda"/>
+        <a:font script="Gujr" typeface="Shruti"/>
+        <a:font script="Khmr" typeface="MoolBoran"/>
+        <a:font script="Knda" typeface="Tunga"/>
+        <a:font script="Guru" typeface="Raavi"/>
+        <a:font script="Cans" typeface="Euphemia"/>
+        <a:font script="Cher" typeface="Plantagenet Cherokee"/>
+        <a:font script="Yiii" typeface="Microsoft Yi Baiti"/>
+        <a:font script="Tibt" typeface="Microsoft Himalaya"/>
+        <a:font script="Thaa" typeface="MV Boli"/>
+        <a:font script="Deva" typeface="Mangal"/>
+        <a:font script="Telu" typeface="Gautami"/>
+        <a:font script="Taml" typeface="Latha"/>
+        <a:font script="Syrc" typeface="Estrangelo Edessa"/>
+        <a:font script="Orya" typeface="Kalinga"/>
+        <a:font script="Mlym" typeface="Kartika"/>
+        <a:font script="Laoo" typeface="DokChampa"/>
+        <a:font script="Sinh" typeface="Iskoola Pota"/>
+        <a:font script="Mong" typeface="Mongolian Baiti"/>
+        <a:font script="Viet" typeface="Times New Roman"/>
+        <a:font script="Uigh" typeface="Microsoft Uighur"/>
+        <a:font script="Geor" typeface="Sylfaen"/>
+      </a:majorFont>
+      <a:minorFont>
+        <a:latin typeface="Calibri"/>
+        <a:ea typeface=""/>
+        <a:cs typeface=""/>
+        <a:font script="Jpan" typeface="ＭＳ Ｐゴシック"/>
+        <a:font script="Hang" typeface="맑은 고딕"/>
+        <a:font script="Hans" typeface="宋体"/>
+        <a:font script="Hant" typeface="新細明體"/>
+        <a:font script="Arab" typeface="Arial"/>
+        <a:font script="Hebr" typeface="Arial"/>
+        <a:font script="Thai" typeface="Cordia New"/>
+        <a:font script="Ethi" typeface="Nyala"/>
+        <a:font script="Beng" typeface="Vrinda"/>
+        <a:font script="Gujr" typeface="Shruti"/>
+        <a:font script="Khmr" typeface="DaunPenh"/>
+        <a:font script="Knda" typeface="Tunga"/>
+        <a:font script="Guru" typeface="Raavi"/>
+        <a:font script="Cans" typeface="Euphemia"/>
+        <a:font script="Cher" typeface="Plantagenet Cherokee"/>
+        <a:font script="Yiii" typeface="Microsoft Yi Baiti"/>
+        <a:font script="Tibt" typeface="Microsoft Himalaya"/>
+        <a:font script="Thaa" typeface="MV Boli"/>
+        <a:font script="Deva" typeface="Mangal"/>
+        <a:font script="Telu" typeface="Gautami"/>
+        <a:font script="Taml" typeface="Latha"/>
+        <a:font script="Syrc" typeface="Estrangelo Edessa"/>
+        <a:font script="Orya" typeface="Kalinga"/>
+        <a:font script="Mlym" typeface="Kartika"/>
+        <a:font script="Laoo" typeface="DokChampa"/>
+        <a:font script="Sinh" typeface="Iskoola Pota"/>
+        <a:font script="Mong" typeface="Mongolian Baiti"/>
+        <a:font script="Viet" typeface="Arial"/>
+        <a:font script="Uigh" typeface="Microsoft Uighur"/>
+        <a:font script="Geor" typeface="Sylfaen"/>
+      </a:minorFont>
+    </a:fontScheme>
+    <a:fmtScheme name="Office">
+      <a:fillStyleLst>
+        <a:solidFill>
+          <a:schemeClr val="phClr"/>
+        </a:solidFill>
+        <a:gradFill rotWithShape="1">
+          <a:gsLst>
+            <a:gs pos="0">
+              <a:schemeClr val="phClr">
+                <a:tint val="50000"/>
+                <a:satMod val="300000"/>
+              </a:schemeClr>
+            </a:gs>
+            <a:gs pos="35000">
+              <a:schemeClr val="phClr">
+                <a:tint val="37000"/>
+                <a:satMod val="300000"/>
+              </a:schemeClr>
+            </a:gs>
+            <a:gs pos="100000">
+              <a:schemeClr val="phClr">
+                <a:tint val="15000"/>
+                <a:satMod val="350000"/>
+              </a:schemeClr>
+            </a:gs>
+          </a:gsLst>
+          <a:lin ang="16200000" scaled="1"/>
+        </a:gradFill>
+        <a:gradFill rotWithShape="1">
+          <a:gsLst>
+            <a:gs pos="0">
+              <a:schemeClr val="phClr">
+                <a:tint val="100000"/>
+                <a:shade val="100000"/>
+                <a:satMod val="130000"/>
+              </a:schemeClr>
+            </a:gs>
+            <a:gs pos="100000">
+              <a:schemeClr val="phClr">
+                <a:tint val="50000"/>
+                <a:shade val="100000"/>
+                <a:satMod val="350000"/>
+              </a:schemeClr>
+            </a:gs>
+          </a:gsLst>
+          <a:lin ang="16200000" scaled="0"/>
+        </a:gradFill>
+      </a:fillStyleLst>
+      <a:lnStyleLst>
+        <a:ln w="9525" cap="flat" cmpd="sng" algn="ctr">
+          <a:solidFill>
+            <a:schemeClr val="phClr">
+              <a:shade val="95000"/>
+              <a:satMod val="105000"/>
+            </a:schemeClr>
+          </a:solidFill>
+          <a:prstDash val="solid"/>
+        </a:ln>
+        <a:ln w="25400" cap="flat" cmpd="sng" algn="ctr">
+          <a:solidFill>
+            <a:schemeClr val="phClr"/>
+          </a:solidFill>
+          <a:prstDash val="solid"/>
+        </a:ln>
+        <a:ln w="38100" cap="flat" cmpd="sng" algn="ctr">
+          <a:solidFill>
+            <a:schemeClr val="phClr"/>
+          </a:solidFill>
+          <a:prstDash val="solid"/>
+        </a:ln>
+      </a:lnStyleLst>
+      <a:effectStyleLst>
+        <a:effectStyle>
+          <a:effectLst>
+            <a:outerShdw blurRad="40000" dist="20000" dir="5400000" rotWithShape="0">
+              <a:srgbClr val="000000">
+                <a:alpha val="38000"/>
+              </a:srgbClr>
+            </a:outerShdw>
+          </a:effectLst>
+        </a:effectStyle>
+        <a:effectStyle>
+          <a:effectLst>
+            <a:outerShdw blurRad="40000" dist="23000" dir="5400000" rotWithShape="0">
+              <a:srgbClr val="000000">
+                <a:alpha val="35000"/>
+              </a:srgbClr>
+            </a:outerShdw>
+          </a:effectLst>
+        </a:effectStyle>
+        <a:effectStyle>
+          <a:effectLst>
+            <a:outerShdw blurRad="40000" dist="23000" dir="5400000" rotWithShape="0">
+              <a:srgbClr val="000000">
+                <a:alpha val="35000"/>
+              </a:srgbClr>
+            </a:outerShdw>
+          </a:effectLst>
+          <a:scene3d>
+            <a:camera prst="orthographicFront">
+              <a:rot lat="0" lon="0" rev="0"/>
+            </a:camera>
+            <a:lightRig rig="threePt" dir="t">
+              <a:rot lat="0" lon="0" rev="1200000"/>
+            </a:lightRig>
+          </a:scene3d>
+          <a:sp3d>
+            <a:bevelT w="63500" h="25400"/>
+          </a:sp3d>
+        </a:effectStyle>
+      </a:effectStyleLst>
+      <a:bgFillStyleLst>
+        <a:solidFill>
+          <a:schemeClr val="phClr"/>
+        </a:solidFill>
+        <a:gradFill rotWithShape="1">
+          <a:gsLst>
+            <a:gs pos="0">
+              <a:schemeClr val="phClr">
+                <a:tint val="40000"/>
+                <a:satMod val="350000"/>
+              </a:schemeClr>
+            </a:gs>
+            <a:gs pos="40000">
+              <a:schemeClr val="phClr">
+                <a:tint val="45000"/>
+                <a:shade val="99000"/>
+                <a:satMod val="350000"/>
+              </a:schemeClr>
+            </a:gs>
+            <a:gs pos="100000">
+              <a:schemeClr val="phClr">
+                <a:shade val="20000"/>
+                <a:satMod val="255000"/>
+              </a:schemeClr>
+            </a:gs>
+          </a:gsLst>
+          <a:path path="circle">
+            <a:fillToRect l="50000" t="-80000" r="50000" b="180000"/>
+          </a:path>
+        </a:gradFill>
+        <a:gradFill rotWithShape="1">
+          <a:gsLst>
+            <a:gs pos="0">
+              <a:schemeClr val="phClr">
+                <a:tint val="80000"/>
+                <a:satMod val="300000"/>
+              </a:schemeClr>
+            </a:gs>
+            <a:gs pos="100000">
+              <a:schemeClr val="phClr">
+                <a:shade val="30000"/>
+                <a:satMod val="200000"/>
+              </a:schemeClr>
+            </a:gs>
+          </a:gsLst>
+          <a:path path="circle">
+            <a:fillToRect l="50000" t="50000" r="50000" b="50000"/>
+          </a:path>
+        </a:gradFill>
+      </a:bgFillStyleLst>
+    </a:fmtScheme>
+  </a:themeElements>
+  <a:objectDefaults>
+    <a:spDef>
+      <a:spPr/>
+      <a:bodyPr/>
+      <a:lstStyle/>
+      <a:style>
+        <a:lnRef idx="1">
+          <a:schemeClr val="accent1"/>
+        </a:lnRef>
+        <a:fillRef idx="3">
+          <a:schemeClr val="accent1"/>
+        </a:fillRef>
+        <a:effectRef idx="2">
+          <a:schemeClr val="accent1"/>
+        </a:effectRef>
+        <a:fontRef idx="minor">
+          <a:schemeClr val="lt1"/>
+        </a:fontRef>
+      </a:style>
+    </a:spDef>
+    <a:lnDef>
+      <a:spPr/>
+      <a:bodyPr/>
+      <a:lstStyle/>
+      <a:style>
+        <a:lnRef idx="2">
+          <a:schemeClr val="accent1"/>
+        </a:lnRef>
+        <a:fillRef idx="0">
+          <a:schemeClr val="accent1"/>
+        </a:fillRef>
+        <a:effectRef idx="1">
+          <a:schemeClr val="accent1"/>
+        </a:effectRef>
+        <a:fontRef idx="minor">
+          <a:schemeClr val="tx1"/>
+        </a:fontRef>
+      </a:style>
+    </a:lnDef>
+  </a:objectDefaults>
+  <a:extraClrSchemeLst/>
+</a:theme>
 </file>
</xml_diff>